<commit_message>
Deck v4 trimmed to 14 slides for the 10-minute limit; guide timings updated
Co-Authored-By: Claude Opus 5.5 <noreply@anthropic.com>
</commit_message>
<xml_diff>
--- a/presentation/FYP-assessment-presentation-v4.pptx
+++ b/presentation/FYP-assessment-presentation-v4.pptx
@@ -11,20 +11,16 @@
     <p:sldId xmlns:r="http://schemas.openxmlformats.org/officeDocument/2006/relationships" id="256" r:id="Ref2a4bf3706c4352"/>
     <p:sldId xmlns:r="http://schemas.openxmlformats.org/officeDocument/2006/relationships" id="257" r:id="Re6cd846b0b584733"/>
     <p:sldId xmlns:r="http://schemas.openxmlformats.org/officeDocument/2006/relationships" id="258" r:id="R731e077aa12e4340"/>
-    <p:sldId xmlns:ns0="http://schemas.openxmlformats.org/officeDocument/2006/relationships" id="268" ns0:id="rId19"/>
     <p:sldId xmlns:ns0="http://schemas.openxmlformats.org/officeDocument/2006/relationships" id="269" ns0:id="rId20"/>
     <p:sldId xmlns:r="http://schemas.openxmlformats.org/officeDocument/2006/relationships" id="259" r:id="Rf6250f778e214466"/>
     <p:sldId xmlns:r="http://schemas.openxmlformats.org/officeDocument/2006/relationships" id="260" r:id="R427b3517ce644e16"/>
-    <p:sldId xmlns:r="http://schemas.openxmlformats.org/officeDocument/2006/relationships" id="261" r:id="R1e9d0d0c5f744df0"/>
-    <p:sldId xmlns:ns0="http://schemas.openxmlformats.org/officeDocument/2006/relationships" id="272" ns0:id="rId23"/>
     <p:sldId xmlns:ns0="http://schemas.openxmlformats.org/officeDocument/2006/relationships" id="273" ns0:id="rId24"/>
     <p:sldId xmlns:r="http://schemas.openxmlformats.org/officeDocument/2006/relationships" id="262" r:id="R67d8387fc811496e"/>
     <p:sldId xmlns:r="http://schemas.openxmlformats.org/officeDocument/2006/relationships" id="263" r:id="R65dff22df0704d17"/>
-    <p:sldId xmlns:ns0="http://schemas.openxmlformats.org/officeDocument/2006/relationships" id="270" ns0:id="rId21"/>
-    <p:sldId xmlns:ns0="http://schemas.openxmlformats.org/officeDocument/2006/relationships" id="271" ns0:id="rId22"/>
     <p:sldId xmlns:r="http://schemas.openxmlformats.org/officeDocument/2006/relationships" id="264" r:id="R5788775e71334f66"/>
     <p:sldId xmlns:r="http://schemas.openxmlformats.org/officeDocument/2006/relationships" id="265" r:id="Re14ba9e474d542fd"/>
     <p:sldId xmlns:r="http://schemas.openxmlformats.org/officeDocument/2006/relationships" id="266" r:id="R7735b38b9c204791"/>
+    <p:sldId xmlns:ns0="http://schemas.openxmlformats.org/officeDocument/2006/relationships" id="271" ns0:id="rId22"/>
     <p:sldId xmlns:r="http://schemas.openxmlformats.org/officeDocument/2006/relationships" id="267" r:id="R997e45ef8e6d46c1"/>
   </p:sldIdLst>
   <p:sldSz cx="12192000" cy="6858000"/>
@@ -1100,94 +1096,6 @@
           <a:p xmlns:a="http://schemas.openxmlformats.org/drawingml/2006/main">
             <a:r>
               <a:t>Sources: Paper Experimental Method; data/analysis/recovered/results.json; data/analysis/questionnaires/results.json. Fourteen trials, 65,697 telemetry rows, 31 block responses, eleven matched intake/end sets.</a:t>
-            </a:r>
-          </a:p>
-        </p:txBody>
-      </p:sp>
-      <p:sp>
-        <p:nvSpPr>
-          <p:cNvPr id="4" name="Slide Number Placeholder 3"/>
-          <p:cNvSpPr>
-            <a:spLocks xmlns:a="http://schemas.openxmlformats.org/drawingml/2006/main" noGrp="1"/>
-          </p:cNvSpPr>
-          <p:nvPr>
-            <p:ph type="sldNum" idx="5"/>
-          </p:nvPr>
-        </p:nvSpPr>
-        <p:spPr/>
-        <p:txBody>
-          <a:bodyPr xmlns:a="http://schemas.openxmlformats.org/drawingml/2006/main"/>
-          <a:lstStyle xmlns:a="http://schemas.openxmlformats.org/drawingml/2006/main"/>
-          <a:p xmlns:a="http://schemas.openxmlformats.org/drawingml/2006/main"/>
-        </p:txBody>
-      </p:sp>
-    </p:spTree>
-  </p:cSld>
-  <p:clrMapOvr>
-    <a:masterClrMapping xmlns:a="http://schemas.openxmlformats.org/drawingml/2006/main"/>
-  </p:clrMapOvr>
-</p:notes>
-</file>
-
-<file path=ppt/notesSlides/notesSlide6.xml><?xml version="1.0" encoding="utf-8"?>
-<p:notes xmlns:p="http://schemas.openxmlformats.org/presentationml/2006/main">
-  <p:cSld>
-    <p:spTree>
-      <p:nvGrpSpPr>
-        <p:cNvPr id="1" name=""/>
-        <p:cNvGrpSpPr/>
-        <p:nvPr/>
-      </p:nvGrpSpPr>
-      <p:grpSpPr>
-        <a:xfrm xmlns:a="http://schemas.openxmlformats.org/drawingml/2006/main"/>
-      </p:grpSpPr>
-      <p:sp>
-        <p:nvSpPr>
-          <p:cNvPr id="2" name="Slide Image Placeholder 1"/>
-          <p:cNvSpPr>
-            <a:spLocks xmlns:a="http://schemas.openxmlformats.org/drawingml/2006/main" noGrp="1"/>
-          </p:cNvSpPr>
-          <p:nvPr>
-            <p:ph type="sldImg" idx="0"/>
-          </p:nvPr>
-        </p:nvSpPr>
-        <p:spPr/>
-      </p:sp>
-      <p:sp>
-        <p:nvSpPr>
-          <p:cNvPr id="3" name="Notes Placeholder 2"/>
-          <p:cNvSpPr>
-            <a:spLocks xmlns:a="http://schemas.openxmlformats.org/drawingml/2006/main" noGrp="1"/>
-          </p:cNvSpPr>
-          <p:nvPr>
-            <p:ph type="body" idx="1"/>
-          </p:nvPr>
-        </p:nvSpPr>
-        <p:spPr/>
-        <p:txBody>
-          <a:bodyPr xmlns:a="http://schemas.openxmlformats.org/drawingml/2006/main"/>
-          <a:lstStyle xmlns:a="http://schemas.openxmlformats.org/drawingml/2006/main"/>
-          <a:p xmlns:a="http://schemas.openxmlformats.org/drawingml/2006/main">
-            <a:r>
-              <a:t>Zenan | 45 seconds</a:t>
-            </a:r>
-          </a:p>
-          <a:p xmlns:a="http://schemas.openxmlformats.org/drawingml/2006/main"/>
-          <a:p xmlns:a="http://schemas.openxmlformats.org/drawingml/2006/main">
-            <a:r>
-              <a:t>The model assigns each observation to one of three task phases. For the version that can operate online using only present and past observations, accuracy was 79.4 percent. Giving the three phases equal weight lowers the score to 72.5 percent, so the overall figure hides weaker performance outside the dominant working phase. Validation held out each of three development operators in turn across thirty-two accepted trials.</a:t>
-            </a:r>
-          </a:p>
-          <a:p xmlns:a="http://schemas.openxmlformats.org/drawingml/2006/main"/>
-          <a:p xmlns:a="http://schemas.openxmlformats.org/drawingml/2006/main">
-            <a:r>
-              <a:t>The cost of learned context showed up in the trials. The predictive controller issued between 15 and 73 protective-stop onsets per trial, against 6 to 9 for the fixed and reactive controllers, but only two or three per trial lasted a second or more. The rest were sub-half-second toggles near a threshold. It did not hold the robot stopped for longer; it switched the request far more often. That is a design defect we can fix with hysteresis or a minimum stop dwell on the learned inputs, without touching the deterministic envelope.</a:t>
-            </a:r>
-          </a:p>
-          <a:p xmlns:a="http://schemas.openxmlformats.org/drawingml/2006/main"/>
-          <a:p xmlns:a="http://schemas.openxmlformats.org/drawingml/2006/main">
-            <a:r>
-              <a:t>Sources: data/models/pilot_hmm.json validation; paper Table III stop-onset column and Section VII-A.</a:t>
             </a:r>
           </a:p>
         </p:txBody>
@@ -7267,251 +7175,6 @@
 </a:theme>
 </file>
 
-<file path=ppt/slides/charts/chart1.xml><?xml version="1.0" encoding="utf-8"?>
-<c:chartSpace xmlns:c="http://schemas.openxmlformats.org/drawingml/2006/chart" xmlns:r="http://schemas.openxmlformats.org/officeDocument/2006/relationships">
-  <c:lang val="en-US"/>
-  <c:chart>
-    <c:plotArea>
-      <c:barChart>
-        <c:barDir val="col"/>
-        <c:grouping val="clustered"/>
-        <c:varyColors val="0"/>
-        <c:ser>
-          <c:idx val="0"/>
-          <c:order val="0"/>
-          <c:tx>
-            <c:v>Causal recognition accuracy</c:v>
-          </c:tx>
-          <c:spPr>
-            <a:solidFill xmlns:a="http://schemas.openxmlformats.org/drawingml/2006/main">
-              <a:srgbClr val="006DAE"/>
-            </a:solidFill>
-          </c:spPr>
-          <c:dLbls>
-            <c:dLbl>
-              <c:idx val="0"/>
-              <c:tx>
-                <c:rich>
-                  <a:bodyPr xmlns:a="http://schemas.openxmlformats.org/drawingml/2006/main"/>
-                  <a:lstStyle xmlns:a="http://schemas.openxmlformats.org/drawingml/2006/main"/>
-                  <a:p xmlns:a="http://schemas.openxmlformats.org/drawingml/2006/main">
-                    <a:r>
-                      <a:rPr sz="2100">
-                        <a:latin typeface="Arial"/>
-                        <a:ea typeface="Arial"/>
-                        <a:cs typeface="Arial"/>
-                      </a:rPr>
-                      <a:t>79.4%</a:t>
-                    </a:r>
-                  </a:p>
-                </c:rich>
-              </c:tx>
-              <c:txPr>
-                <a:bodyPr xmlns:a="http://schemas.openxmlformats.org/drawingml/2006/main" anchorCtr="1"/>
-                <a:lstStyle xmlns:a="http://schemas.openxmlformats.org/drawingml/2006/main"/>
-                <a:p xmlns:a="http://schemas.openxmlformats.org/drawingml/2006/main">
-                  <a:pPr>
-                    <a:defRPr sz="2100">
-                      <a:latin typeface="Arial"/>
-                      <a:ea typeface="Arial"/>
-                      <a:cs typeface="Arial"/>
-                    </a:defRPr>
-                  </a:pPr>
-                </a:p>
-              </c:txPr>
-              <c:showLegendKey val="0"/>
-              <c:showVal val="0"/>
-              <c:showCatName val="0"/>
-              <c:showSerName val="0"/>
-              <c:showPercent val="0"/>
-              <c:showBubbleSize val="0"/>
-            </c:dLbl>
-            <c:dLbl>
-              <c:idx val="1"/>
-              <c:tx>
-                <c:rich>
-                  <a:bodyPr xmlns:a="http://schemas.openxmlformats.org/drawingml/2006/main"/>
-                  <a:lstStyle xmlns:a="http://schemas.openxmlformats.org/drawingml/2006/main"/>
-                  <a:p xmlns:a="http://schemas.openxmlformats.org/drawingml/2006/main">
-                    <a:r>
-                      <a:rPr sz="2100">
-                        <a:latin typeface="Arial"/>
-                        <a:ea typeface="Arial"/>
-                        <a:cs typeface="Arial"/>
-                      </a:rPr>
-                      <a:t>72.5%</a:t>
-                    </a:r>
-                  </a:p>
-                </c:rich>
-              </c:tx>
-              <c:txPr>
-                <a:bodyPr xmlns:a="http://schemas.openxmlformats.org/drawingml/2006/main" anchorCtr="1"/>
-                <a:lstStyle xmlns:a="http://schemas.openxmlformats.org/drawingml/2006/main"/>
-                <a:p xmlns:a="http://schemas.openxmlformats.org/drawingml/2006/main">
-                  <a:pPr>
-                    <a:defRPr sz="2100">
-                      <a:latin typeface="Arial"/>
-                      <a:ea typeface="Arial"/>
-                      <a:cs typeface="Arial"/>
-                    </a:defRPr>
-                  </a:pPr>
-                </a:p>
-              </c:txPr>
-              <c:showLegendKey val="0"/>
-              <c:showVal val="0"/>
-              <c:showCatName val="0"/>
-              <c:showSerName val="0"/>
-              <c:showPercent val="0"/>
-              <c:showBubbleSize val="0"/>
-            </c:dLbl>
-          </c:dLbls>
-          <c:cat>
-            <c:strRef>
-              <c:f>'Chart Data'!$A$2:$A$3</c:f>
-              <c:strCache>
-                <c:ptCount val="2"/>
-                <c:pt idx="0">
-                  <c:v>Overall accuracy</c:v>
-                </c:pt>
-                <c:pt idx="1">
-                  <c:v>Equal weight per phase</c:v>
-                </c:pt>
-              </c:strCache>
-            </c:strRef>
-          </c:cat>
-          <c:val>
-            <c:numRef>
-              <c:f>'Chart Data'!$B$2:$B$3</c:f>
-              <c:numCache>
-                <c:formatCode>0.0%</c:formatCode>
-                <c:ptCount val="2"/>
-                <c:pt idx="0">
-                  <c:v>0.7937</c:v>
-                </c:pt>
-                <c:pt idx="1">
-                  <c:v>0.725</c:v>
-                </c:pt>
-              </c:numCache>
-            </c:numRef>
-          </c:val>
-        </c:ser>
-        <c:dLbls>
-          <c:txPr>
-            <a:bodyPr xmlns:a="http://schemas.openxmlformats.org/drawingml/2006/main" anchorCtr="1"/>
-            <a:lstStyle xmlns:a="http://schemas.openxmlformats.org/drawingml/2006/main"/>
-            <a:p xmlns:a="http://schemas.openxmlformats.org/drawingml/2006/main">
-              <a:pPr>
-                <a:defRPr sz="2100">
-                  <a:latin typeface="Arial"/>
-                  <a:ea typeface="Arial"/>
-                  <a:cs typeface="Arial"/>
-                </a:defRPr>
-              </a:pPr>
-            </a:p>
-          </c:txPr>
-          <c:dLblPos val="outEnd"/>
-          <c:showLegendKey val="0"/>
-          <c:showVal val="1"/>
-          <c:showCatName val="0"/>
-          <c:showSerName val="0"/>
-          <c:showPercent val="0"/>
-          <c:showBubbleSize val="0"/>
-          <c:showLeaderLines val="0"/>
-        </c:dLbls>
-        <c:gapWidth val="110"/>
-        <c:axId val="48650112"/>
-        <c:axId val="48672768"/>
-      </c:barChart>
-      <c:catAx>
-        <c:axId val="48650112"/>
-        <c:scaling>
-          <c:orientation val="minMax"/>
-        </c:scaling>
-        <c:delete val="0"/>
-        <c:axPos val="b"/>
-        <c:numFmt formatCode="General"/>
-        <c:majorTickMark val="none"/>
-        <c:minorTickMark val="none"/>
-        <c:spPr>
-          <a:ln xmlns:a="http://schemas.openxmlformats.org/drawingml/2006/main" w="9525">
-            <a:solidFill>
-              <a:srgbClr val="D4D4D4"/>
-            </a:solidFill>
-            <a:prstDash val="solid"/>
-          </a:ln>
-        </c:spPr>
-        <c:txPr>
-          <a:bodyPr xmlns:a="http://schemas.openxmlformats.org/drawingml/2006/main" anchorCtr="1"/>
-          <a:lstStyle xmlns:a="http://schemas.openxmlformats.org/drawingml/2006/main"/>
-          <a:p xmlns:a="http://schemas.openxmlformats.org/drawingml/2006/main">
-            <a:pPr>
-              <a:defRPr sz="1800">
-                <a:solidFill>
-                  <a:srgbClr val="666666"/>
-                </a:solidFill>
-                <a:latin typeface="Arial"/>
-                <a:ea typeface="Arial"/>
-                <a:cs typeface="Arial"/>
-              </a:defRPr>
-            </a:pPr>
-          </a:p>
-        </c:txPr>
-        <c:crossAx val="48672768"/>
-      </c:catAx>
-      <c:valAx>
-        <c:axId val="48672768"/>
-        <c:scaling>
-          <c:orientation val="minMax"/>
-          <c:max val="1"/>
-          <c:min val="0"/>
-        </c:scaling>
-        <c:delete val="0"/>
-        <c:axPos val="l"/>
-        <c:numFmt formatCode="0%"/>
-        <c:majorTickMark val="none"/>
-        <c:minorTickMark val="none"/>
-        <c:spPr>
-          <a:ln xmlns:a="http://schemas.openxmlformats.org/drawingml/2006/main" w="9525">
-            <a:solidFill>
-              <a:srgbClr val="D4D4D4"/>
-            </a:solidFill>
-            <a:prstDash val="solid"/>
-          </a:ln>
-        </c:spPr>
-        <c:txPr>
-          <a:bodyPr xmlns:a="http://schemas.openxmlformats.org/drawingml/2006/main" anchorCtr="1"/>
-          <a:lstStyle xmlns:a="http://schemas.openxmlformats.org/drawingml/2006/main"/>
-          <a:p xmlns:a="http://schemas.openxmlformats.org/drawingml/2006/main">
-            <a:pPr>
-              <a:defRPr sz="1650">
-                <a:solidFill>
-                  <a:srgbClr val="666666"/>
-                </a:solidFill>
-                <a:latin typeface="Arial"/>
-                <a:ea typeface="Arial"/>
-                <a:cs typeface="Arial"/>
-              </a:defRPr>
-            </a:pPr>
-          </a:p>
-        </c:txPr>
-        <c:crossAx val="48650112"/>
-        <c:crossBetween val="between"/>
-        <c:majorUnit val="0.25"/>
-      </c:valAx>
-    </c:plotArea>
-    <c:plotVisOnly val="1"/>
-  </c:chart>
-  <c:spPr>
-    <a:solidFill xmlns:a="http://schemas.openxmlformats.org/drawingml/2006/main">
-      <a:srgbClr val="FFFFFF"/>
-    </a:solidFill>
-  </c:spPr>
-  <c:externalData r:id="rIdChartSnapshot1">
-    <c:autoUpdate val="0"/>
-  </c:externalData>
-</c:chartSpace>
-</file>
-
 <file path=ppt/slides/charts/chart2.xml><?xml version="1.0" encoding="utf-8"?>
 <c:chartSpace xmlns:c="http://schemas.openxmlformats.org/drawingml/2006/chart" xmlns:r="http://schemas.openxmlformats.org/officeDocument/2006/relationships">
   <c:lang val="en-US"/>
@@ -8393,6 +8056,266 @@
 </file>
 
 <file path=ppt/slides/slide10.xml><?xml version="1.0" encoding="utf-8"?>
+<p:sld xmlns:a="http://schemas.openxmlformats.org/drawingml/2006/main" xmlns:p="http://schemas.openxmlformats.org/presentationml/2006/main" xmlns:r="http://schemas.openxmlformats.org/officeDocument/2006/relationships">
+  <p:cSld>
+    <p:spTree>
+      <p:nvGrpSpPr>
+        <p:cNvPr id="1" name=""/>
+        <p:cNvGrpSpPr/>
+        <p:nvPr/>
+      </p:nvGrpSpPr>
+      <p:grpSpPr/>
+      <p:sp>
+        <p:nvSpPr>
+          <p:cNvPr id="7" name="The task and laboratory prototype">
+            <a:extLst>
+              <a:ext uri="{FF2B5EF4-FFF2-40B4-BE49-F238E27FC236}">
+                <a16:creationId xmlns:a16="http://schemas.microsoft.com/office/drawing/2014/main" id="{DA806EAB-9D1F-4D99-9E8F-92CEBF025533}"/>
+              </a:ext>
+            </a:extLst>
+          </p:cNvPr>
+          <p:cNvSpPr>
+            <a:spLocks noGrp="1"/>
+          </p:cNvSpPr>
+          <p:nvPr/>
+        </p:nvSpPr>
+        <p:spPr>
+          <a:xfrm>
+            <a:off x="438150" y="381000"/>
+            <a:ext cx="11049000" cy="809625"/>
+          </a:xfrm>
+          <a:prstGeom prst="rect">
+            <a:avLst/>
+          </a:prstGeom>
+          <a:noFill/>
+          <a:ln w="0">
+            <a:noFill/>
+          </a:ln>
+        </p:spPr>
+        <p:txBody>
+          <a:bodyPr>
+            <a:noAutofit/>
+          </a:bodyPr>
+          <a:lstStyle/>
+          <a:p>
+            <a:pPr>
+              <a:defRPr sz="3300" b="1">
+                <a:solidFill>
+                  <a:srgbClr val="172D3D"/>
+                </a:solidFill>
+                <a:latin typeface="Arial"/>
+                <a:ea typeface="Arial"/>
+                <a:cs typeface="Arial"/>
+              </a:defRPr>
+            </a:pPr>
+            <a:r>
+              <a:rPr sz="3300" b="1">
+                <a:solidFill>
+                  <a:srgbClr val="172D3D"/>
+                </a:solidFill>
+                <a:latin typeface="Arial"/>
+                <a:ea typeface="Arial"/>
+                <a:cs typeface="Arial"/>
+              </a:rPr>
+              <a:t>Our trained task-phase model</a:t>
+            </a:r>
+          </a:p>
+        </p:txBody>
+      </p:sp>
+      <p:sp>
+        <p:nvSpPr>
+          <p:cNvPr id="2" name="03">
+            <a:extLst>
+              <a:ext uri="{FF2B5EF4-FFF2-40B4-BE49-F238E27FC236}">
+                <a16:creationId xmlns:a16="http://schemas.microsoft.com/office/drawing/2014/main" id="{CFB5FF92-5DE5-431F-B644-183C6C08DB02}"/>
+              </a:ext>
+            </a:extLst>
+          </p:cNvPr>
+          <p:cNvSpPr>
+            <a:spLocks noGrp="1"/>
+          </p:cNvSpPr>
+          <p:nvPr/>
+        </p:nvSpPr>
+        <p:spPr>
+          <a:xfrm>
+            <a:off x="466725" y="6362700"/>
+            <a:ext cx="476250" cy="228600"/>
+          </a:xfrm>
+          <a:prstGeom prst="rect">
+            <a:avLst/>
+          </a:prstGeom>
+          <a:noFill/>
+          <a:ln w="0">
+            <a:noFill/>
+          </a:ln>
+        </p:spPr>
+        <p:txBody>
+          <a:bodyPr>
+            <a:noAutofit/>
+          </a:bodyPr>
+          <a:lstStyle/>
+          <a:p>
+            <a:pPr>
+              <a:defRPr sz="1200" b="0">
+                <a:solidFill>
+                  <a:srgbClr val="536B79"/>
+                </a:solidFill>
+                <a:latin typeface="Arial"/>
+                <a:ea typeface="Arial"/>
+                <a:cs typeface="Arial"/>
+              </a:defRPr>
+            </a:pPr>
+            <a:r>
+              <a:rPr sz="1200" b="0">
+                <a:solidFill>
+                  <a:srgbClr val="536B79"/>
+                </a:solidFill>
+                <a:latin typeface="Arial"/>
+                <a:ea typeface="Arial"/>
+                <a:cs typeface="Arial"/>
+              </a:rPr>
+              <a:t>07</a:t>
+            </a:r>
+          </a:p>
+        </p:txBody>
+      </p:sp>
+      <p:pic>
+        <p:nvPicPr>
+          <p:cNvPr id="8" name="Picture 7" descr="held-out-trial.png"/>
+          <p:cNvPicPr>
+            <a:picLocks noChangeAspect="1"/>
+          </p:cNvPicPr>
+          <p:nvPr/>
+        </p:nvPicPr>
+        <p:blipFill>
+          <a:blip r:embed="rId2"/>
+          <a:stretch>
+            <a:fillRect/>
+          </a:stretch>
+        </p:blipFill>
+        <p:spPr>
+          <a:xfrm>
+            <a:off x="571500" y="1200000"/>
+            <a:ext cx="7400000" cy="2825455"/>
+          </a:xfrm>
+          <a:prstGeom prst="rect">
+            <a:avLst/>
+          </a:prstGeom>
+        </p:spPr>
+      </p:pic>
+      <p:pic>
+        <p:nvPicPr>
+          <p:cNvPr id="9" name="Picture 8" descr="confusion.png"/>
+          <p:cNvPicPr>
+            <a:picLocks noChangeAspect="1"/>
+          </p:cNvPicPr>
+          <p:nvPr/>
+        </p:nvPicPr>
+        <p:blipFill>
+          <a:blip r:embed="rId3"/>
+          <a:stretch>
+            <a:fillRect/>
+          </a:stretch>
+        </p:blipFill>
+        <p:spPr>
+          <a:xfrm>
+            <a:off x="8150000" y="1150000"/>
+            <a:ext cx="3616667" cy="3100000"/>
+          </a:xfrm>
+          <a:prstGeom prst="rect">
+            <a:avLst/>
+          </a:prstGeom>
+        </p:spPr>
+      </p:pic>
+      <p:sp>
+        <p:nvSpPr>
+          <p:cNvPr id="6" name="Schematic of the procedure; scale and motion are illustrativ">
+            <a:extLst>
+              <a:ext uri="{FF2B5EF4-FFF2-40B4-BE49-F238E27FC236}">
+                <a16:creationId xmlns:a16="http://schemas.microsoft.com/office/drawing/2014/main" id="{2BCF01A8-A812-4BB7-ADB0-153753A61F5C}"/>
+              </a:ext>
+            </a:extLst>
+          </p:cNvPr>
+          <p:cNvSpPr>
+            <a:spLocks noGrp="1"/>
+          </p:cNvSpPr>
+          <p:nvPr/>
+        </p:nvSpPr>
+        <p:spPr>
+          <a:xfrm>
+            <a:off x="571500" y="4500000"/>
+            <a:ext cx="10950000" cy="1500000"/>
+          </a:xfrm>
+          <a:prstGeom prst="rect">
+            <a:avLst/>
+          </a:prstGeom>
+          <a:noFill/>
+          <a:ln w="0">
+            <a:noFill/>
+          </a:ln>
+        </p:spPr>
+        <p:txBody>
+          <a:bodyPr>
+            <a:noAutofit/>
+          </a:bodyPr>
+          <a:lstStyle/>
+          <a:p>
+            <a:pPr>
+              <a:defRPr sz="1650" b="0">
+                <a:solidFill>
+                  <a:srgbClr val="536B79"/>
+                </a:solidFill>
+                <a:latin typeface="Arial"/>
+                <a:ea typeface="Arial"/>
+                <a:cs typeface="Arial"/>
+              </a:defRPr>
+            </a:pPr>
+            <a:r>
+              <a:rPr sz="1400" b="0">
+                <a:solidFill>
+                  <a:srgbClr val="536B79"/>
+                </a:solidFill>
+                <a:latin typeface="Arial"/>
+                <a:ea typeface="Arial"/>
+                <a:cs typeface="Arial"/>
+              </a:rPr>
+              <a:t>Trained by us on 32 labelled trials from 3 operators; tested on a person it never saw (left: live estimate vs actual).</a:t>
+            </a:r>
+          </a:p>
+          <a:p>
+            <a:pPr>
+              <a:defRPr sz="1650" b="0">
+                <a:solidFill>
+                  <a:srgbClr val="536B79"/>
+                </a:solidFill>
+                <a:latin typeface="Arial"/>
+                <a:ea typeface="Arial"/>
+                <a:cs typeface="Arial"/>
+              </a:defRPr>
+            </a:pPr>
+            <a:r>
+              <a:rPr sz="1400" b="0">
+                <a:solidFill>
+                  <a:srgbClr val="536B79"/>
+                </a:solidFill>
+                <a:latin typeface="Arial"/>
+                <a:ea typeface="Arial"/>
+                <a:cs typeface="Arial"/>
+              </a:rPr>
+              <a:t>Right: it recognises working reliably and hesitates mainly at phase changes, good enough to drive the controller in real time.</a:t>
+            </a:r>
+          </a:p>
+        </p:txBody>
+      </p:sp>
+    </p:spTree>
+  </p:cSld>
+  <p:clrMapOvr>
+    <a:masterClrMapping/>
+  </p:clrMapOvr>
+</p:sld>
+</file>
+
+<file path=ppt/slides/slide11.xml><?xml version="1.0" encoding="utf-8"?>
 <p:sld xmlns:p="http://schemas.openxmlformats.org/presentationml/2006/main">
   <p:cSld>
     <p:spTree>
@@ -8406,6 +8329,352 @@
       </p:grpSpPr>
       <p:sp>
         <p:nvSpPr>
+          <p:cNvPr id="7" name="Reported safety generally exceeded expectations">
+            <a:extLst xmlns:a="http://schemas.openxmlformats.org/drawingml/2006/main">
+              <a:ext uri="{FF2B5EF4-FFF2-40B4-BE49-F238E27FC236}">
+                <a16:creationId xmlns:a16="http://schemas.microsoft.com/office/drawing/2014/main" id="{5814CDDA-1AB1-4D61-8FAF-E713491B3C34}"/>
+              </a:ext>
+            </a:extLst>
+          </p:cNvPr>
+          <p:cNvSpPr>
+            <a:spLocks xmlns:a="http://schemas.openxmlformats.org/drawingml/2006/main" noGrp="1"/>
+          </p:cNvSpPr>
+          <p:nvPr/>
+        </p:nvSpPr>
+        <p:spPr>
+          <a:xfrm xmlns:a="http://schemas.openxmlformats.org/drawingml/2006/main">
+            <a:off x="438150" y="381000"/>
+            <a:ext cx="11049000" cy="809625"/>
+          </a:xfrm>
+          <a:prstGeom xmlns:a="http://schemas.openxmlformats.org/drawingml/2006/main" prst="rect">
+            <a:avLst/>
+          </a:prstGeom>
+          <a:noFill xmlns:a="http://schemas.openxmlformats.org/drawingml/2006/main"/>
+          <a:ln xmlns:a="http://schemas.openxmlformats.org/drawingml/2006/main" w="0">
+            <a:noFill/>
+          </a:ln>
+        </p:spPr>
+        <p:txBody>
+          <a:bodyPr xmlns:a="http://schemas.openxmlformats.org/drawingml/2006/main">
+            <a:noAutofit/>
+          </a:bodyPr>
+          <a:lstStyle xmlns:a="http://schemas.openxmlformats.org/drawingml/2006/main"/>
+          <a:p xmlns:a="http://schemas.openxmlformats.org/drawingml/2006/main">
+            <a:pPr>
+              <a:defRPr sz="3300" b="1">
+                <a:solidFill>
+                  <a:srgbClr val="172D3D"/>
+                </a:solidFill>
+                <a:latin typeface="Arial"/>
+                <a:ea typeface="Arial"/>
+                <a:cs typeface="Arial"/>
+              </a:defRPr>
+            </a:pPr>
+            <a:r>
+              <a:rPr sz="3300" b="1">
+                <a:solidFill>
+                  <a:srgbClr val="172D3D"/>
+                </a:solidFill>
+                <a:latin typeface="Arial"/>
+                <a:ea typeface="Arial"/>
+                <a:cs typeface="Arial"/>
+              </a:rPr>
+              <a:t>Reported safety generally exceeded expectations</a:t>
+            </a:r>
+          </a:p>
+        </p:txBody>
+      </p:sp>
+      <p:sp>
+        <p:nvSpPr>
+          <p:cNvPr id="2" name="07">
+            <a:extLst xmlns:a="http://schemas.openxmlformats.org/drawingml/2006/main">
+              <a:ext uri="{FF2B5EF4-FFF2-40B4-BE49-F238E27FC236}">
+                <a16:creationId xmlns:a16="http://schemas.microsoft.com/office/drawing/2014/main" id="{C4C99FBE-1199-451A-A032-F316AA2D1434}"/>
+              </a:ext>
+            </a:extLst>
+          </p:cNvPr>
+          <p:cNvSpPr>
+            <a:spLocks xmlns:a="http://schemas.openxmlformats.org/drawingml/2006/main" noGrp="1"/>
+          </p:cNvSpPr>
+          <p:nvPr/>
+        </p:nvSpPr>
+        <p:spPr>
+          <a:xfrm xmlns:a="http://schemas.openxmlformats.org/drawingml/2006/main">
+            <a:off x="466725" y="6362700"/>
+            <a:ext cx="476250" cy="228600"/>
+          </a:xfrm>
+          <a:prstGeom xmlns:a="http://schemas.openxmlformats.org/drawingml/2006/main" prst="rect">
+            <a:avLst/>
+          </a:prstGeom>
+          <a:noFill xmlns:a="http://schemas.openxmlformats.org/drawingml/2006/main"/>
+          <a:ln xmlns:a="http://schemas.openxmlformats.org/drawingml/2006/main" w="0">
+            <a:noFill/>
+          </a:ln>
+        </p:spPr>
+        <p:txBody>
+          <a:bodyPr xmlns:a="http://schemas.openxmlformats.org/drawingml/2006/main">
+            <a:noAutofit/>
+          </a:bodyPr>
+          <a:lstStyle xmlns:a="http://schemas.openxmlformats.org/drawingml/2006/main"/>
+          <a:p xmlns:a="http://schemas.openxmlformats.org/drawingml/2006/main">
+            <a:pPr>
+              <a:defRPr sz="1200" b="0">
+                <a:solidFill>
+                  <a:srgbClr val="536B79"/>
+                </a:solidFill>
+                <a:latin typeface="Arial"/>
+                <a:ea typeface="Arial"/>
+                <a:cs typeface="Arial"/>
+              </a:defRPr>
+            </a:pPr>
+            <a:r>
+              <a:rPr sz="1200" b="0">
+                <a:solidFill>
+                  <a:srgbClr val="536B79"/>
+                </a:solidFill>
+                <a:latin typeface="Arial"/>
+                <a:ea typeface="Arial"/>
+                <a:cs typeface="Arial"/>
+              </a:rPr>
+              <a:t>08</a:t>
+            </a:r>
+          </a:p>
+        </p:txBody>
+      </p:sp>
+      <p:sp>
+        <p:nvSpPr>
+          <p:cNvPr id="3" name="Changes between intake and end ratings">
+            <a:extLst xmlns:a="http://schemas.openxmlformats.org/drawingml/2006/main">
+              <a:ext uri="{FF2B5EF4-FFF2-40B4-BE49-F238E27FC236}">
+                <a16:creationId xmlns:a16="http://schemas.microsoft.com/office/drawing/2014/main" id="{2DFEBB9F-3B8E-435B-BEE5-DF4C4122DD86}"/>
+              </a:ext>
+            </a:extLst>
+          </p:cNvPr>
+          <p:cNvSpPr>
+            <a:spLocks xmlns:a="http://schemas.openxmlformats.org/drawingml/2006/main" noGrp="1"/>
+          </p:cNvSpPr>
+          <p:nvPr/>
+        </p:nvSpPr>
+        <p:spPr>
+          <a:xfrm xmlns:a="http://schemas.openxmlformats.org/drawingml/2006/main">
+            <a:off x="571500" y="1295400"/>
+            <a:ext cx="10763250" cy="476250"/>
+          </a:xfrm>
+          <a:prstGeom xmlns:a="http://schemas.openxmlformats.org/drawingml/2006/main" prst="rect">
+            <a:avLst/>
+          </a:prstGeom>
+          <a:noFill xmlns:a="http://schemas.openxmlformats.org/drawingml/2006/main"/>
+          <a:ln xmlns:a="http://schemas.openxmlformats.org/drawingml/2006/main" w="0">
+            <a:noFill/>
+          </a:ln>
+        </p:spPr>
+        <p:txBody>
+          <a:bodyPr xmlns:a="http://schemas.openxmlformats.org/drawingml/2006/main">
+            <a:noAutofit/>
+          </a:bodyPr>
+          <a:lstStyle xmlns:a="http://schemas.openxmlformats.org/drawingml/2006/main"/>
+          <a:p xmlns:a="http://schemas.openxmlformats.org/drawingml/2006/main">
+            <a:pPr>
+              <a:defRPr sz="2250" b="0">
+                <a:solidFill>
+                  <a:srgbClr val="172D3D"/>
+                </a:solidFill>
+                <a:latin typeface="Arial"/>
+                <a:ea typeface="Arial"/>
+                <a:cs typeface="Arial"/>
+              </a:defRPr>
+            </a:pPr>
+            <a:r>
+              <a:rPr sz="2250" b="0">
+                <a:solidFill>
+                  <a:srgbClr val="172D3D"/>
+                </a:solidFill>
+                <a:latin typeface="Arial"/>
+                <a:ea typeface="Arial"/>
+                <a:cs typeface="Arial"/>
+              </a:rPr>
+              <a:t>Changes between intake and end ratings</a:t>
+            </a:r>
+          </a:p>
+        </p:txBody>
+      </p:sp>
+      <p:graphicFrame>
+        <p:nvGraphicFramePr>
+          <p:cNvPr id="10" name="Chart"/>
+          <p:cNvGraphicFramePr/>
+          <p:nvPr/>
+        </p:nvGraphicFramePr>
+        <p:xfrm>
+          <a:off xmlns:a="http://schemas.openxmlformats.org/drawingml/2006/main" x="619125" y="1952625"/>
+          <a:ext xmlns:a="http://schemas.openxmlformats.org/drawingml/2006/main" cx="10715625" cy="2571750"/>
+        </p:xfrm>
+        <a:graphic xmlns:a="http://schemas.openxmlformats.org/drawingml/2006/main">
+          <a:graphicData uri="http://schemas.openxmlformats.org/drawingml/2006/chart">
+            <c:chart xmlns:r="http://schemas.openxmlformats.org/officeDocument/2006/relationships" xmlns:c="http://schemas.openxmlformats.org/drawingml/2006/chart" r:id="Rb2a10100880f4f5f"/>
+          </a:graphicData>
+        </a:graphic>
+      </p:graphicFrame>
+      <p:sp>
+        <p:nvSpPr>
+          <p:cNvPr id="5" name="8 of 11 safety ratings increased; trust responses were more ">
+            <a:extLst xmlns:a="http://schemas.openxmlformats.org/drawingml/2006/main">
+              <a:ext uri="{FF2B5EF4-FFF2-40B4-BE49-F238E27FC236}">
+                <a16:creationId xmlns:a16="http://schemas.microsoft.com/office/drawing/2014/main" id="{4C68F436-7C3E-4DDA-A61F-723CD0311D75}"/>
+              </a:ext>
+            </a:extLst>
+          </p:cNvPr>
+          <p:cNvSpPr>
+            <a:spLocks xmlns:a="http://schemas.openxmlformats.org/drawingml/2006/main" noGrp="1"/>
+          </p:cNvSpPr>
+          <p:nvPr/>
+        </p:nvSpPr>
+        <p:spPr>
+          <a:xfrm xmlns:a="http://schemas.openxmlformats.org/drawingml/2006/main">
+            <a:off x="571500" y="4695825"/>
+            <a:ext cx="10763250" cy="552450"/>
+          </a:xfrm>
+          <a:prstGeom xmlns:a="http://schemas.openxmlformats.org/drawingml/2006/main" prst="rect">
+            <a:avLst/>
+          </a:prstGeom>
+          <a:noFill xmlns:a="http://schemas.openxmlformats.org/drawingml/2006/main"/>
+          <a:ln xmlns:a="http://schemas.openxmlformats.org/drawingml/2006/main" w="0">
+            <a:noFill/>
+          </a:ln>
+        </p:spPr>
+        <p:txBody>
+          <a:bodyPr xmlns:a="http://schemas.openxmlformats.org/drawingml/2006/main">
+            <a:noAutofit/>
+          </a:bodyPr>
+          <a:lstStyle xmlns:a="http://schemas.openxmlformats.org/drawingml/2006/main"/>
+          <a:p xmlns:a="http://schemas.openxmlformats.org/drawingml/2006/main">
+            <a:pPr>
+              <a:defRPr sz="2250" b="1">
+                <a:solidFill>
+                  <a:srgbClr val="006DAE"/>
+                </a:solidFill>
+                <a:latin typeface="Arial"/>
+                <a:ea typeface="Arial"/>
+                <a:cs typeface="Arial"/>
+              </a:defRPr>
+            </a:pPr>
+            <a:r>
+              <a:rPr sz="2250" b="1">
+                <a:solidFill>
+                  <a:srgbClr val="006DAE"/>
+                </a:solidFill>
+                <a:latin typeface="Arial"/>
+                <a:ea typeface="Arial"/>
+                <a:cs typeface="Arial"/>
+              </a:rPr>
+              <a:t>8 of 11 safety ratings increased; trust responses were more mixed.</a:t>
+            </a:r>
+          </a:p>
+        </p:txBody>
+      </p:sp>
+      <p:sp>
+        <p:nvSpPr>
+          <p:cNvPr id="6" name="Matched response sets, not a confirmed count of distinct peo">
+            <a:extLst xmlns:a="http://schemas.openxmlformats.org/drawingml/2006/main">
+              <a:ext uri="{FF2B5EF4-FFF2-40B4-BE49-F238E27FC236}">
+                <a16:creationId xmlns:a16="http://schemas.microsoft.com/office/drawing/2014/main" id="{DD433E31-694F-46D7-9C78-BABB08EABEFF}"/>
+              </a:ext>
+            </a:extLst>
+          </p:cNvPr>
+          <p:cNvSpPr>
+            <a:spLocks xmlns:a="http://schemas.openxmlformats.org/drawingml/2006/main" noGrp="1"/>
+          </p:cNvSpPr>
+          <p:nvPr/>
+        </p:nvSpPr>
+        <p:spPr>
+          <a:xfrm xmlns:a="http://schemas.openxmlformats.org/drawingml/2006/main">
+            <a:off x="571500" y="5286375"/>
+            <a:ext cx="10763250" cy="628650"/>
+          </a:xfrm>
+          <a:prstGeom xmlns:a="http://schemas.openxmlformats.org/drawingml/2006/main" prst="rect">
+            <a:avLst/>
+          </a:prstGeom>
+          <a:noFill xmlns:a="http://schemas.openxmlformats.org/drawingml/2006/main"/>
+          <a:ln xmlns:a="http://schemas.openxmlformats.org/drawingml/2006/main" w="0">
+            <a:noFill/>
+          </a:ln>
+        </p:spPr>
+        <p:txBody>
+          <a:bodyPr xmlns:a="http://schemas.openxmlformats.org/drawingml/2006/main">
+            <a:noAutofit/>
+          </a:bodyPr>
+          <a:lstStyle xmlns:a="http://schemas.openxmlformats.org/drawingml/2006/main"/>
+          <a:p xmlns:a="http://schemas.openxmlformats.org/drawingml/2006/main">
+            <a:pPr>
+              <a:defRPr sz="1800" b="0">
+                <a:solidFill>
+                  <a:srgbClr val="536B79"/>
+                </a:solidFill>
+                <a:latin typeface="Arial"/>
+                <a:ea typeface="Arial"/>
+                <a:cs typeface="Arial"/>
+              </a:defRPr>
+            </a:pPr>
+            <a:r>
+              <a:rPr sz="1800" b="0">
+                <a:solidFill>
+                  <a:srgbClr val="536B79"/>
+                </a:solidFill>
+                <a:latin typeface="Arial"/>
+                <a:ea typeface="Arial"/>
+                <a:cs typeface="Arial"/>
+              </a:rPr>
+              <a:t>Matched response sets, not a confirmed count of distinct people.</a:t>
+            </a:r>
+          </a:p>
+          <a:p xmlns:a="http://schemas.openxmlformats.org/drawingml/2006/main">
+            <a:pPr>
+              <a:defRPr sz="1800" b="0">
+                <a:solidFill>
+                  <a:srgbClr val="536B79"/>
+                </a:solidFill>
+                <a:latin typeface="Arial"/>
+                <a:ea typeface="Arial"/>
+                <a:cs typeface="Arial"/>
+              </a:defRPr>
+            </a:pPr>
+            <a:r>
+              <a:rPr sz="1800" b="0">
+                <a:solidFill>
+                  <a:srgbClr val="536B79"/>
+                </a:solidFill>
+                <a:latin typeface="Arial"/>
+                <a:ea typeface="Arial"/>
+                <a:cs typeface="Arial"/>
+              </a:rPr>
+              <a:t>Expected and experienced ratings do not identify a controller effect.</a:t>
+            </a:r>
+          </a:p>
+        </p:txBody>
+      </p:sp>
+    </p:spTree>
+    <p:extLst>
+      <p:ext uri="{BB962C8B-B14F-4D97-AF65-F5344CB8AC3E}">
+        <p14:creationId xmlns:p14="http://schemas.microsoft.com/office/powerpoint/2010/main" val="1512327385"/>
+      </p:ext>
+    </p:extLst>
+  </p:cSld>
+</p:sld>
+</file>
+
+<file path=ppt/slides/slide12.xml><?xml version="1.0" encoding="utf-8"?>
+<p:sld xmlns:p="http://schemas.openxmlformats.org/presentationml/2006/main">
+  <p:cSld>
+    <p:spTree>
+      <p:nvGrpSpPr>
+        <p:cNvPr id="1" name=""/>
+        <p:cNvGrpSpPr/>
+        <p:nvPr/>
+      </p:nvGrpSpPr>
+      <p:grpSpPr>
+        <a:xfrm xmlns:a="http://schemas.openxmlformats.org/drawingml/2006/main"/>
+      </p:grpSpPr>
+      <p:sp>
+        <p:nvSpPr>
           <p:cNvPr id="7" name="Distance measurement affects interpretation">
             <a:extLst xmlns:a="http://schemas.openxmlformats.org/drawingml/2006/main">
               <a:ext uri="{FF2B5EF4-FFF2-40B4-BE49-F238E27FC236}">
@@ -8513,7 +8782,7 @@
                 <a:ea typeface="Arial"/>
                 <a:cs typeface="Arial"/>
               </a:rPr>
-              <a:t>12</a:t>
+              <a:t>09</a:t>
             </a:r>
           </a:p>
         </p:txBody>
@@ -8738,7 +9007,7 @@
 </p:sld>
 </file>
 
-<file path=ppt/slides/slide11.xml><?xml version="1.0" encoding="utf-8"?>
+<file path=ppt/slides/slide14.xml><?xml version="1.0" encoding="utf-8"?>
 <p:sld xmlns:a="http://schemas.openxmlformats.org/drawingml/2006/main" xmlns:p="http://schemas.openxmlformats.org/presentationml/2006/main" xmlns:r="http://schemas.openxmlformats.org/officeDocument/2006/relationships">
   <p:cSld>
     <p:spTree>
@@ -8800,7 +9069,7 @@
                 <a:ea typeface="Arial"/>
                 <a:cs typeface="Arial"/>
               </a:rPr>
-              <a:t>One real trial, as the controller saw it</a:t>
+              <a:t>Results answer the research question</a:t>
             </a:r>
           </a:p>
         </p:txBody>
@@ -8858,219 +9127,6 @@
                 <a:cs typeface="Arial"/>
               </a:rPr>
               <a:t>13</a:t>
-            </a:r>
-          </a:p>
-        </p:txBody>
-      </p:sp>
-      <p:pic>
-        <p:nvPicPr>
-          <p:cNvPr id="8" name="Picture 7" descr="representative-trace-full.png"/>
-          <p:cNvPicPr>
-            <a:picLocks noChangeAspect="1"/>
-          </p:cNvPicPr>
-          <p:nvPr/>
-        </p:nvPicPr>
-        <p:blipFill>
-          <a:blip r:embed="rId2"/>
-          <a:stretch>
-            <a:fillRect/>
-          </a:stretch>
-        </p:blipFill>
-        <p:spPr>
-          <a:xfrm>
-            <a:off x="571500" y="1250000"/>
-            <a:ext cx="8541000" cy="4242253"/>
-          </a:xfrm>
-          <a:prstGeom prst="rect">
-            <a:avLst/>
-          </a:prstGeom>
-        </p:spPr>
-      </p:pic>
-      <p:sp>
-        <p:nvSpPr>
-          <p:cNvPr id="6" name="Schematic of the procedure; scale and motion are illustrativ">
-            <a:extLst>
-              <a:ext uri="{FF2B5EF4-FFF2-40B4-BE49-F238E27FC236}">
-                <a16:creationId xmlns:a16="http://schemas.microsoft.com/office/drawing/2014/main" id="{2BCF01A8-A812-4BB7-ADB0-153753A61F5C}"/>
-              </a:ext>
-            </a:extLst>
-          </p:cNvPr>
-          <p:cNvSpPr>
-            <a:spLocks noGrp="1"/>
-          </p:cNvSpPr>
-          <p:nvPr/>
-        </p:nvSpPr>
-        <p:spPr>
-          <a:xfrm>
-            <a:off x="571500" y="5500000"/>
-            <a:ext cx="10950000" cy="700000"/>
-          </a:xfrm>
-          <a:prstGeom prst="rect">
-            <a:avLst/>
-          </a:prstGeom>
-          <a:noFill/>
-          <a:ln w="0">
-            <a:noFill/>
-          </a:ln>
-        </p:spPr>
-        <p:txBody>
-          <a:bodyPr>
-            <a:noAutofit/>
-          </a:bodyPr>
-          <a:lstStyle/>
-          <a:p>
-            <a:pPr>
-              <a:defRPr sz="1650" b="0">
-                <a:solidFill>
-                  <a:srgbClr val="536B79"/>
-                </a:solidFill>
-                <a:latin typeface="Arial"/>
-                <a:ea typeface="Arial"/>
-                <a:cs typeface="Arial"/>
-              </a:defRPr>
-            </a:pPr>
-            <a:r>
-              <a:rPr sz="1300" b="0">
-                <a:solidFill>
-                  <a:srgbClr val="536B79"/>
-                </a:solidFill>
-                <a:latin typeface="Arial"/>
-                <a:ea typeface="Arial"/>
-                <a:cs typeface="Arial"/>
-              </a:rPr>
-              <a:t>Distance to the robot, closing speed, speed command and joint speed from one predictive trial. The robot stops every time the worker comes close; the rapid on/off flicker is the predictor switching we identify as the fix.</a:t>
-            </a:r>
-          </a:p>
-        </p:txBody>
-      </p:sp>
-    </p:spTree>
-  </p:cSld>
-  <p:clrMapOvr>
-    <a:masterClrMapping/>
-  </p:clrMapOvr>
-</p:sld>
-</file>
-
-<file path=ppt/slides/slide12.xml><?xml version="1.0" encoding="utf-8"?>
-<p:sld xmlns:a="http://schemas.openxmlformats.org/drawingml/2006/main" xmlns:p="http://schemas.openxmlformats.org/presentationml/2006/main" xmlns:r="http://schemas.openxmlformats.org/officeDocument/2006/relationships">
-  <p:cSld>
-    <p:spTree>
-      <p:nvGrpSpPr>
-        <p:cNvPr id="1" name=""/>
-        <p:cNvGrpSpPr/>
-        <p:nvPr/>
-      </p:nvGrpSpPr>
-      <p:grpSpPr/>
-      <p:sp>
-        <p:nvSpPr>
-          <p:cNvPr id="7" name="The task and laboratory prototype">
-            <a:extLst>
-              <a:ext uri="{FF2B5EF4-FFF2-40B4-BE49-F238E27FC236}">
-                <a16:creationId xmlns:a16="http://schemas.microsoft.com/office/drawing/2014/main" id="{DA806EAB-9D1F-4D99-9E8F-92CEBF025533}"/>
-              </a:ext>
-            </a:extLst>
-          </p:cNvPr>
-          <p:cNvSpPr>
-            <a:spLocks noGrp="1"/>
-          </p:cNvSpPr>
-          <p:nvPr/>
-        </p:nvSpPr>
-        <p:spPr>
-          <a:xfrm>
-            <a:off x="438150" y="381000"/>
-            <a:ext cx="11049000" cy="809625"/>
-          </a:xfrm>
-          <a:prstGeom prst="rect">
-            <a:avLst/>
-          </a:prstGeom>
-          <a:noFill/>
-          <a:ln w="0">
-            <a:noFill/>
-          </a:ln>
-        </p:spPr>
-        <p:txBody>
-          <a:bodyPr>
-            <a:noAutofit/>
-          </a:bodyPr>
-          <a:lstStyle/>
-          <a:p>
-            <a:pPr>
-              <a:defRPr sz="3300" b="1">
-                <a:solidFill>
-                  <a:srgbClr val="172D3D"/>
-                </a:solidFill>
-                <a:latin typeface="Arial"/>
-                <a:ea typeface="Arial"/>
-                <a:cs typeface="Arial"/>
-              </a:defRPr>
-            </a:pPr>
-            <a:r>
-              <a:rPr sz="3300" b="1">
-                <a:solidFill>
-                  <a:srgbClr val="172D3D"/>
-                </a:solidFill>
-                <a:latin typeface="Arial"/>
-                <a:ea typeface="Arial"/>
-                <a:cs typeface="Arial"/>
-              </a:rPr>
-              <a:t>Results answer the research question</a:t>
-            </a:r>
-          </a:p>
-        </p:txBody>
-      </p:sp>
-      <p:sp>
-        <p:nvSpPr>
-          <p:cNvPr id="2" name="03">
-            <a:extLst>
-              <a:ext uri="{FF2B5EF4-FFF2-40B4-BE49-F238E27FC236}">
-                <a16:creationId xmlns:a16="http://schemas.microsoft.com/office/drawing/2014/main" id="{CFB5FF92-5DE5-431F-B644-183C6C08DB02}"/>
-              </a:ext>
-            </a:extLst>
-          </p:cNvPr>
-          <p:cNvSpPr>
-            <a:spLocks noGrp="1"/>
-          </p:cNvSpPr>
-          <p:nvPr/>
-        </p:nvSpPr>
-        <p:spPr>
-          <a:xfrm>
-            <a:off x="466725" y="6362700"/>
-            <a:ext cx="476250" cy="228600"/>
-          </a:xfrm>
-          <a:prstGeom prst="rect">
-            <a:avLst/>
-          </a:prstGeom>
-          <a:noFill/>
-          <a:ln w="0">
-            <a:noFill/>
-          </a:ln>
-        </p:spPr>
-        <p:txBody>
-          <a:bodyPr>
-            <a:noAutofit/>
-          </a:bodyPr>
-          <a:lstStyle/>
-          <a:p>
-            <a:pPr>
-              <a:defRPr sz="1200" b="0">
-                <a:solidFill>
-                  <a:srgbClr val="536B79"/>
-                </a:solidFill>
-                <a:latin typeface="Arial"/>
-                <a:ea typeface="Arial"/>
-                <a:cs typeface="Arial"/>
-              </a:defRPr>
-            </a:pPr>
-            <a:r>
-              <a:rPr sz="1200" b="0">
-                <a:solidFill>
-                  <a:srgbClr val="536B79"/>
-                </a:solidFill>
-                <a:latin typeface="Arial"/>
-                <a:ea typeface="Arial"/>
-                <a:cs typeface="Arial"/>
-              </a:rPr>
-              <a:t>14</a:t>
             </a:r>
           </a:p>
         </p:txBody>
@@ -9459,7 +9515,7 @@
 </p:sld>
 </file>
 
-<file path=ppt/slides/slide13.xml><?xml version="1.0" encoding="utf-8"?>
+<file path=ppt/slides/slide15.xml><?xml version="1.0" encoding="utf-8"?>
 <p:sld xmlns:p="http://schemas.openxmlformats.org/presentationml/2006/main">
   <p:cSld>
     <p:spTree>
@@ -9580,7 +9636,7 @@
                 <a:ea typeface="Arial"/>
                 <a:cs typeface="Arial"/>
               </a:rPr>
-              <a:t>15</a:t>
+              <a:t>10</a:t>
             </a:r>
           </a:p>
         </p:txBody>
@@ -9936,7 +9992,7 @@
 </p:sld>
 </file>
 
-<file path=ppt/slides/slide14.xml><?xml version="1.0" encoding="utf-8"?>
+<file path=ppt/slides/slide16.xml><?xml version="1.0" encoding="utf-8"?>
 <p:sld xmlns:p="http://schemas.openxmlformats.org/presentationml/2006/main">
   <p:cSld>
     <p:spTree>
@@ -10057,7 +10113,7 @@
                 <a:ea typeface="Arial"/>
                 <a:cs typeface="Arial"/>
               </a:rPr>
-              <a:t>16</a:t>
+              <a:t>11</a:t>
             </a:r>
           </a:p>
         </p:txBody>
@@ -10453,7 +10509,7 @@
 </p:sld>
 </file>
 
-<file path=ppt/slides/slide15.xml><?xml version="1.0" encoding="utf-8"?>
+<file path=ppt/slides/slide17.xml><?xml version="1.0" encoding="utf-8"?>
 <p:sld xmlns:p="http://schemas.openxmlformats.org/presentationml/2006/main">
   <p:cSld>
     <p:spTree>
@@ -10574,7 +10630,7 @@
                 <a:ea typeface="Arial"/>
                 <a:cs typeface="Arial"/>
               </a:rPr>
-              <a:t>17</a:t>
+              <a:t>12</a:t>
             </a:r>
           </a:p>
         </p:txBody>
@@ -10961,7 +11017,7 @@
 </p:sld>
 </file>
 
-<file path=ppt/slides/slide16.xml><?xml version="1.0" encoding="utf-8"?>
+<file path=ppt/slides/slide18.xml><?xml version="1.0" encoding="utf-8"?>
 <p:sld xmlns:p="http://schemas.openxmlformats.org/presentationml/2006/main">
   <p:cSld>
     <p:spTree>
@@ -11082,7 +11138,7 @@
                 <a:ea typeface="Arial"/>
                 <a:cs typeface="Arial"/>
               </a:rPr>
-              <a:t>18</a:t>
+              <a:t>14</a:t>
             </a:r>
           </a:p>
         </p:txBody>
@@ -11368,572 +11424,6 @@
       </p:ext>
     </p:extLst>
   </p:cSld>
-</p:sld>
-</file>
-
-<file path=ppt/slides/slide17.xml><?xml version="1.0" encoding="utf-8"?>
-<p:sld xmlns:a="http://schemas.openxmlformats.org/drawingml/2006/main" xmlns:p="http://schemas.openxmlformats.org/presentationml/2006/main" xmlns:r="http://schemas.openxmlformats.org/officeDocument/2006/relationships">
-  <p:cSld>
-    <p:spTree>
-      <p:nvGrpSpPr>
-        <p:cNvPr id="1" name=""/>
-        <p:cNvGrpSpPr/>
-        <p:nvPr/>
-      </p:nvGrpSpPr>
-      <p:grpSpPr/>
-      <p:sp>
-        <p:nvSpPr>
-          <p:cNvPr id="7" name="The task and laboratory prototype">
-            <a:extLst>
-              <a:ext uri="{FF2B5EF4-FFF2-40B4-BE49-F238E27FC236}">
-                <a16:creationId xmlns:a16="http://schemas.microsoft.com/office/drawing/2014/main" id="{DA806EAB-9D1F-4D99-9E8F-92CEBF025533}"/>
-              </a:ext>
-            </a:extLst>
-          </p:cNvPr>
-          <p:cNvSpPr>
-            <a:spLocks noGrp="1"/>
-          </p:cNvSpPr>
-          <p:nvPr/>
-        </p:nvSpPr>
-        <p:spPr>
-          <a:xfrm>
-            <a:off x="438150" y="381000"/>
-            <a:ext cx="11049000" cy="809625"/>
-          </a:xfrm>
-          <a:prstGeom prst="rect">
-            <a:avLst/>
-          </a:prstGeom>
-          <a:noFill/>
-          <a:ln w="0">
-            <a:noFill/>
-          </a:ln>
-        </p:spPr>
-        <p:txBody>
-          <a:bodyPr>
-            <a:noAutofit/>
-          </a:bodyPr>
-          <a:lstStyle/>
-          <a:p>
-            <a:pPr>
-              <a:defRPr sz="3300" b="1">
-                <a:solidFill>
-                  <a:srgbClr val="172D3D"/>
-                </a:solidFill>
-                <a:latin typeface="Arial"/>
-                <a:ea typeface="Arial"/>
-                <a:cs typeface="Arial"/>
-              </a:defRPr>
-            </a:pPr>
-            <a:r>
-              <a:rPr sz="3300" b="1">
-                <a:solidFill>
-                  <a:srgbClr val="172D3D"/>
-                </a:solidFill>
-                <a:latin typeface="Arial"/>
-                <a:ea typeface="Arial"/>
-                <a:cs typeface="Arial"/>
-              </a:rPr>
-              <a:t>Inside our trained model</a:t>
-            </a:r>
-          </a:p>
-        </p:txBody>
-      </p:sp>
-      <p:sp>
-        <p:nvSpPr>
-          <p:cNvPr id="2" name="03">
-            <a:extLst>
-              <a:ext uri="{FF2B5EF4-FFF2-40B4-BE49-F238E27FC236}">
-                <a16:creationId xmlns:a16="http://schemas.microsoft.com/office/drawing/2014/main" id="{CFB5FF92-5DE5-431F-B644-183C6C08DB02}"/>
-              </a:ext>
-            </a:extLst>
-          </p:cNvPr>
-          <p:cNvSpPr>
-            <a:spLocks noGrp="1"/>
-          </p:cNvSpPr>
-          <p:nvPr/>
-        </p:nvSpPr>
-        <p:spPr>
-          <a:xfrm>
-            <a:off x="466725" y="6362700"/>
-            <a:ext cx="476250" cy="228600"/>
-          </a:xfrm>
-          <a:prstGeom prst="rect">
-            <a:avLst/>
-          </a:prstGeom>
-          <a:noFill/>
-          <a:ln w="0">
-            <a:noFill/>
-          </a:ln>
-        </p:spPr>
-        <p:txBody>
-          <a:bodyPr>
-            <a:noAutofit/>
-          </a:bodyPr>
-          <a:lstStyle/>
-          <a:p>
-            <a:pPr>
-              <a:defRPr sz="1200" b="0">
-                <a:solidFill>
-                  <a:srgbClr val="536B79"/>
-                </a:solidFill>
-                <a:latin typeface="Arial"/>
-                <a:ea typeface="Arial"/>
-                <a:cs typeface="Arial"/>
-              </a:defRPr>
-            </a:pPr>
-            <a:r>
-              <a:rPr sz="1200" b="0">
-                <a:solidFill>
-                  <a:srgbClr val="536B79"/>
-                </a:solidFill>
-                <a:latin typeface="Arial"/>
-                <a:ea typeface="Arial"/>
-                <a:cs typeface="Arial"/>
-              </a:rPr>
-              <a:t>09</a:t>
-            </a:r>
-          </a:p>
-        </p:txBody>
-      </p:sp>
-      <p:pic>
-        <p:nvPicPr>
-          <p:cNvPr id="8" name="Picture 7" descr="pipeline.png"/>
-          <p:cNvPicPr>
-            <a:picLocks noChangeAspect="1"/>
-          </p:cNvPicPr>
-          <p:nvPr/>
-        </p:nvPicPr>
-        <p:blipFill>
-          <a:blip r:embed="rId2"/>
-          <a:stretch>
-            <a:fillRect/>
-          </a:stretch>
-        </p:blipFill>
-        <p:spPr>
-          <a:xfrm>
-            <a:off x="571500" y="1200000"/>
-            <a:ext cx="6900000" cy="2258182"/>
-          </a:xfrm>
-          <a:prstGeom prst="rect">
-            <a:avLst/>
-          </a:prstGeom>
-        </p:spPr>
-      </p:pic>
-      <p:pic>
-        <p:nvPicPr>
-          <p:cNvPr id="9" name="Picture 8" descr="feature-space.png"/>
-          <p:cNvPicPr>
-            <a:picLocks noChangeAspect="1"/>
-          </p:cNvPicPr>
-          <p:nvPr/>
-        </p:nvPicPr>
-        <p:blipFill>
-          <a:blip r:embed="rId3"/>
-          <a:stretch>
-            <a:fillRect/>
-          </a:stretch>
-        </p:blipFill>
-        <p:spPr>
-          <a:xfrm>
-            <a:off x="7650000" y="1150000"/>
-            <a:ext cx="4266667" cy="3200000"/>
-          </a:xfrm>
-          <a:prstGeom prst="rect">
-            <a:avLst/>
-          </a:prstGeom>
-        </p:spPr>
-      </p:pic>
-      <p:sp>
-        <p:nvSpPr>
-          <p:cNvPr id="6" name="Schematic of the procedure; scale and motion are illustrativ">
-            <a:extLst>
-              <a:ext uri="{FF2B5EF4-FFF2-40B4-BE49-F238E27FC236}">
-                <a16:creationId xmlns:a16="http://schemas.microsoft.com/office/drawing/2014/main" id="{2BCF01A8-A812-4BB7-ADB0-153753A61F5C}"/>
-              </a:ext>
-            </a:extLst>
-          </p:cNvPr>
-          <p:cNvSpPr>
-            <a:spLocks noGrp="1"/>
-          </p:cNvSpPr>
-          <p:nvPr/>
-        </p:nvSpPr>
-        <p:spPr>
-          <a:xfrm>
-            <a:off x="571500" y="4500000"/>
-            <a:ext cx="10950000" cy="1500000"/>
-          </a:xfrm>
-          <a:prstGeom prst="rect">
-            <a:avLst/>
-          </a:prstGeom>
-          <a:noFill/>
-          <a:ln w="0">
-            <a:noFill/>
-          </a:ln>
-        </p:spPr>
-        <p:txBody>
-          <a:bodyPr>
-            <a:noAutofit/>
-          </a:bodyPr>
-          <a:lstStyle/>
-          <a:p>
-            <a:pPr>
-              <a:defRPr sz="1650" b="0">
-                <a:solidFill>
-                  <a:srgbClr val="536B79"/>
-                </a:solidFill>
-                <a:latin typeface="Arial"/>
-                <a:ea typeface="Arial"/>
-                <a:cs typeface="Arial"/>
-              </a:defRPr>
-            </a:pPr>
-            <a:r>
-              <a:rPr sz="1400" b="0">
-                <a:solidFill>
-                  <a:srgbClr val="536B79"/>
-                </a:solidFill>
-                <a:latin typeface="Arial"/>
-                <a:ea typeface="Arial"/>
-                <a:cs typeface="Arial"/>
-              </a:rPr>
-              <a:t>Trained by us on 32 labelled trials from three operators (about 90,000 motion frames).</a:t>
-            </a:r>
-          </a:p>
-          <a:p>
-            <a:pPr>
-              <a:defRPr sz="1650" b="0">
-                <a:solidFill>
-                  <a:srgbClr val="536B79"/>
-                </a:solidFill>
-                <a:latin typeface="Arial"/>
-                <a:ea typeface="Arial"/>
-                <a:cs typeface="Arial"/>
-              </a:defRPr>
-            </a:pPr>
-            <a:r>
-              <a:rPr sz="1400" b="0">
-                <a:solidFill>
-                  <a:srgbClr val="536B79"/>
-                </a:solidFill>
-                <a:latin typeface="Arial"/>
-                <a:ea typeface="Arial"/>
-                <a:cs typeface="Arial"/>
-              </a:rPr>
-              <a:t>Four body-motion signals feed a hidden Markov model that learned what approaching, working and retreating look like.</a:t>
-            </a:r>
-          </a:p>
-          <a:p>
-            <a:pPr>
-              <a:defRPr sz="1650" b="0">
-                <a:solidFill>
-                  <a:srgbClr val="536B79"/>
-                </a:solidFill>
-                <a:latin typeface="Arial"/>
-                <a:ea typeface="Arial"/>
-                <a:cs typeface="Arial"/>
-              </a:defRPr>
-            </a:pPr>
-            <a:r>
-              <a:rPr sz="1400" b="0">
-                <a:solidFill>
-                  <a:srgbClr val="536B79"/>
-                </a:solidFill>
-                <a:latin typeface="Arial"/>
-                <a:ea typeface="Arial"/>
-                <a:cs typeface="Arial"/>
-              </a:rPr>
-              <a:t>Right: every dot is a real frame. The phases separate by distance and approach direction, which is what the model exploits.</a:t>
-            </a:r>
-          </a:p>
-        </p:txBody>
-      </p:sp>
-    </p:spTree>
-  </p:cSld>
-  <p:clrMapOvr>
-    <a:masterClrMapping/>
-  </p:clrMapOvr>
-</p:sld>
-</file>
-
-<file path=ppt/slides/slide18.xml><?xml version="1.0" encoding="utf-8"?>
-<p:sld xmlns:a="http://schemas.openxmlformats.org/drawingml/2006/main" xmlns:p="http://schemas.openxmlformats.org/presentationml/2006/main" xmlns:r="http://schemas.openxmlformats.org/officeDocument/2006/relationships">
-  <p:cSld>
-    <p:spTree>
-      <p:nvGrpSpPr>
-        <p:cNvPr id="1" name=""/>
-        <p:cNvGrpSpPr/>
-        <p:nvPr/>
-      </p:nvGrpSpPr>
-      <p:grpSpPr/>
-      <p:sp>
-        <p:nvSpPr>
-          <p:cNvPr id="7" name="The task and laboratory prototype">
-            <a:extLst>
-              <a:ext uri="{FF2B5EF4-FFF2-40B4-BE49-F238E27FC236}">
-                <a16:creationId xmlns:a16="http://schemas.microsoft.com/office/drawing/2014/main" id="{DA806EAB-9D1F-4D99-9E8F-92CEBF025533}"/>
-              </a:ext>
-            </a:extLst>
-          </p:cNvPr>
-          <p:cNvSpPr>
-            <a:spLocks noGrp="1"/>
-          </p:cNvSpPr>
-          <p:nvPr/>
-        </p:nvSpPr>
-        <p:spPr>
-          <a:xfrm>
-            <a:off x="438150" y="381000"/>
-            <a:ext cx="11049000" cy="809625"/>
-          </a:xfrm>
-          <a:prstGeom prst="rect">
-            <a:avLst/>
-          </a:prstGeom>
-          <a:noFill/>
-          <a:ln w="0">
-            <a:noFill/>
-          </a:ln>
-        </p:spPr>
-        <p:txBody>
-          <a:bodyPr>
-            <a:noAutofit/>
-          </a:bodyPr>
-          <a:lstStyle/>
-          <a:p>
-            <a:pPr>
-              <a:defRPr sz="3300" b="1">
-                <a:solidFill>
-                  <a:srgbClr val="172D3D"/>
-                </a:solidFill>
-                <a:latin typeface="Arial"/>
-                <a:ea typeface="Arial"/>
-                <a:cs typeface="Arial"/>
-              </a:defRPr>
-            </a:pPr>
-            <a:r>
-              <a:rPr sz="3300" b="1">
-                <a:solidFill>
-                  <a:srgbClr val="172D3D"/>
-                </a:solidFill>
-                <a:latin typeface="Arial"/>
-                <a:ea typeface="Arial"/>
-                <a:cs typeface="Arial"/>
-              </a:rPr>
-              <a:t>Watching the model work on a new person</a:t>
-            </a:r>
-          </a:p>
-        </p:txBody>
-      </p:sp>
-      <p:sp>
-        <p:nvSpPr>
-          <p:cNvPr id="2" name="03">
-            <a:extLst>
-              <a:ext uri="{FF2B5EF4-FFF2-40B4-BE49-F238E27FC236}">
-                <a16:creationId xmlns:a16="http://schemas.microsoft.com/office/drawing/2014/main" id="{CFB5FF92-5DE5-431F-B644-183C6C08DB02}"/>
-              </a:ext>
-            </a:extLst>
-          </p:cNvPr>
-          <p:cNvSpPr>
-            <a:spLocks noGrp="1"/>
-          </p:cNvSpPr>
-          <p:nvPr/>
-        </p:nvSpPr>
-        <p:spPr>
-          <a:xfrm>
-            <a:off x="466725" y="6362700"/>
-            <a:ext cx="476250" cy="228600"/>
-          </a:xfrm>
-          <a:prstGeom prst="rect">
-            <a:avLst/>
-          </a:prstGeom>
-          <a:noFill/>
-          <a:ln w="0">
-            <a:noFill/>
-          </a:ln>
-        </p:spPr>
-        <p:txBody>
-          <a:bodyPr>
-            <a:noAutofit/>
-          </a:bodyPr>
-          <a:lstStyle/>
-          <a:p>
-            <a:pPr>
-              <a:defRPr sz="1200" b="0">
-                <a:solidFill>
-                  <a:srgbClr val="536B79"/>
-                </a:solidFill>
-                <a:latin typeface="Arial"/>
-                <a:ea typeface="Arial"/>
-                <a:cs typeface="Arial"/>
-              </a:defRPr>
-            </a:pPr>
-            <a:r>
-              <a:rPr sz="1200" b="0">
-                <a:solidFill>
-                  <a:srgbClr val="536B79"/>
-                </a:solidFill>
-                <a:latin typeface="Arial"/>
-                <a:ea typeface="Arial"/>
-                <a:cs typeface="Arial"/>
-              </a:rPr>
-              <a:t>10</a:t>
-            </a:r>
-          </a:p>
-        </p:txBody>
-      </p:sp>
-      <p:pic>
-        <p:nvPicPr>
-          <p:cNvPr id="8" name="Picture 7" descr="held-out-trial.png"/>
-          <p:cNvPicPr>
-            <a:picLocks noChangeAspect="1"/>
-          </p:cNvPicPr>
-          <p:nvPr/>
-        </p:nvPicPr>
-        <p:blipFill>
-          <a:blip r:embed="rId2"/>
-          <a:stretch>
-            <a:fillRect/>
-          </a:stretch>
-        </p:blipFill>
-        <p:spPr>
-          <a:xfrm>
-            <a:off x="571500" y="1200000"/>
-            <a:ext cx="7400000" cy="2825455"/>
-          </a:xfrm>
-          <a:prstGeom prst="rect">
-            <a:avLst/>
-          </a:prstGeom>
-        </p:spPr>
-      </p:pic>
-      <p:pic>
-        <p:nvPicPr>
-          <p:cNvPr id="9" name="Picture 8" descr="confusion.png"/>
-          <p:cNvPicPr>
-            <a:picLocks noChangeAspect="1"/>
-          </p:cNvPicPr>
-          <p:nvPr/>
-        </p:nvPicPr>
-        <p:blipFill>
-          <a:blip r:embed="rId3"/>
-          <a:stretch>
-            <a:fillRect/>
-          </a:stretch>
-        </p:blipFill>
-        <p:spPr>
-          <a:xfrm>
-            <a:off x="8150000" y="1150000"/>
-            <a:ext cx="3616667" cy="3100000"/>
-          </a:xfrm>
-          <a:prstGeom prst="rect">
-            <a:avLst/>
-          </a:prstGeom>
-        </p:spPr>
-      </p:pic>
-      <p:sp>
-        <p:nvSpPr>
-          <p:cNvPr id="6" name="Schematic of the procedure; scale and motion are illustrativ">
-            <a:extLst>
-              <a:ext uri="{FF2B5EF4-FFF2-40B4-BE49-F238E27FC236}">
-                <a16:creationId xmlns:a16="http://schemas.microsoft.com/office/drawing/2014/main" id="{2BCF01A8-A812-4BB7-ADB0-153753A61F5C}"/>
-              </a:ext>
-            </a:extLst>
-          </p:cNvPr>
-          <p:cNvSpPr>
-            <a:spLocks noGrp="1"/>
-          </p:cNvSpPr>
-          <p:nvPr/>
-        </p:nvSpPr>
-        <p:spPr>
-          <a:xfrm>
-            <a:off x="571500" y="4500000"/>
-            <a:ext cx="10950000" cy="1500000"/>
-          </a:xfrm>
-          <a:prstGeom prst="rect">
-            <a:avLst/>
-          </a:prstGeom>
-          <a:noFill/>
-          <a:ln w="0">
-            <a:noFill/>
-          </a:ln>
-        </p:spPr>
-        <p:txBody>
-          <a:bodyPr>
-            <a:noAutofit/>
-          </a:bodyPr>
-          <a:lstStyle/>
-          <a:p>
-            <a:pPr>
-              <a:defRPr sz="1650" b="0">
-                <a:solidFill>
-                  <a:srgbClr val="536B79"/>
-                </a:solidFill>
-                <a:latin typeface="Arial"/>
-                <a:ea typeface="Arial"/>
-                <a:cs typeface="Arial"/>
-              </a:defRPr>
-            </a:pPr>
-            <a:r>
-              <a:rPr sz="1400" b="0">
-                <a:solidFill>
-                  <a:srgbClr val="536B79"/>
-                </a:solidFill>
-                <a:latin typeface="Arial"/>
-                <a:ea typeface="Arial"/>
-                <a:cs typeface="Arial"/>
-              </a:rPr>
-              <a:t>A typical trial from an operator the model never saw in training: live estimate (bottom) against what the person was doing (top).</a:t>
-            </a:r>
-          </a:p>
-          <a:p>
-            <a:pPr>
-              <a:defRPr sz="1650" b="0">
-                <a:solidFill>
-                  <a:srgbClr val="536B79"/>
-                </a:solidFill>
-                <a:latin typeface="Arial"/>
-                <a:ea typeface="Arial"/>
-                <a:cs typeface="Arial"/>
-              </a:defRPr>
-            </a:pPr>
-            <a:r>
-              <a:rPr sz="1400" b="0">
-                <a:solidFill>
-                  <a:srgbClr val="536B79"/>
-                </a:solidFill>
-                <a:latin typeface="Arial"/>
-                <a:ea typeface="Arial"/>
-                <a:cs typeface="Arial"/>
-              </a:rPr>
-              <a:t>It tracks the long working phase well and briefly hesitates at phase changes, where most errors fall.</a:t>
-            </a:r>
-          </a:p>
-          <a:p>
-            <a:pPr>
-              <a:defRPr sz="1650" b="0">
-                <a:solidFill>
-                  <a:srgbClr val="536B79"/>
-                </a:solidFill>
-                <a:latin typeface="Arial"/>
-                <a:ea typeface="Arial"/>
-                <a:cs typeface="Arial"/>
-              </a:defRPr>
-            </a:pPr>
-            <a:r>
-              <a:rPr sz="1400" b="0">
-                <a:solidFill>
-                  <a:srgbClr val="536B79"/>
-                </a:solidFill>
-                <a:latin typeface="Arial"/>
-                <a:ea typeface="Arial"/>
-                <a:cs typeface="Arial"/>
-              </a:rPr>
-              <a:t>Right: across all held-out operators, which phase the model chose for each true phase.</a:t>
-            </a:r>
-          </a:p>
-        </p:txBody>
-      </p:sp>
-    </p:spTree>
-  </p:cSld>
-  <p:clrMapOvr>
-    <a:masterClrMapping/>
-  </p:clrMapOvr>
 </p:sld>
 </file>
 
@@ -12752,8 +12242,41 @@
         </p:blipFill>
         <p:spPr>
           <a:xfrm>
-            <a:off x="1214438" y="1266825"/>
-            <a:ext cx="6096000" cy="3429000"/>
+            <a:off x="571500" y="1300000"/>
+            <a:ext cx="3900000" cy="2193750"/>
+          </a:xfrm>
+          <a:prstGeom prst="rect">
+            <a:avLst/>
+          </a:prstGeom>
+        </p:spPr>
+      </p:pic>
+      <p:pic xmlns:a="http://schemas.openxmlformats.org/drawingml/2006/main" xmlns:r="http://schemas.openxmlformats.org/officeDocument/2006/relationships">
+        <p:nvPicPr>
+          <p:cNvPr id="9" name="clip-approach-xsens.mp4">
+            <a:hlinkClick r:id="" action="ppaction://media"/>
+          </p:cNvPr>
+          <p:cNvPicPr>
+            <a:picLocks noChangeAspect="1"/>
+          </p:cNvPicPr>
+          <p:nvPr>
+            <a:videoFile r:link="rId7"/>
+            <p:extLst>
+              <p:ext uri="{DAA4B4D4-6D71-4841-9C94-3DE7FCFB9230}">
+                <p14:media xmlns:p14="http://schemas.microsoft.com/office/powerpoint/2010/main" r:embed="rId6"/>
+              </p:ext>
+            </p:extLst>
+          </p:nvPr>
+        </p:nvPicPr>
+        <p:blipFill>
+          <a:blip r:embed="rId8"/>
+          <a:stretch>
+            <a:fillRect/>
+          </a:stretch>
+        </p:blipFill>
+        <p:spPr>
+          <a:xfrm>
+            <a:off x="4600000" y="1300000"/>
+            <a:ext cx="3550000" cy="1996875"/>
           </a:xfrm>
           <a:prstGeom prst="rect">
             <a:avLst/>
@@ -12767,323 +12290,6 @@
       </p:ext>
     </p:extLst>
   </p:cSld>
-</p:sld>
-</file>
-
-<file path=ppt/slides/slide4.xml><?xml version="1.0" encoding="utf-8"?>
-<p:sld xmlns:a="http://schemas.openxmlformats.org/drawingml/2006/main" xmlns:p="http://schemas.openxmlformats.org/presentationml/2006/main" xmlns:r="http://schemas.openxmlformats.org/officeDocument/2006/relationships">
-  <p:cSld>
-    <p:spTree>
-      <p:nvGrpSpPr>
-        <p:cNvPr id="1" name=""/>
-        <p:cNvGrpSpPr/>
-        <p:nvPr/>
-      </p:nvGrpSpPr>
-      <p:grpSpPr/>
-      <p:sp>
-        <p:nvSpPr>
-          <p:cNvPr id="7" name="The task and laboratory prototype">
-            <a:extLst>
-              <a:ext uri="{FF2B5EF4-FFF2-40B4-BE49-F238E27FC236}">
-                <a16:creationId xmlns:a16="http://schemas.microsoft.com/office/drawing/2014/main" id="{DA806EAB-9D1F-4D99-9E8F-92CEBF025533}"/>
-              </a:ext>
-            </a:extLst>
-          </p:cNvPr>
-          <p:cNvSpPr>
-            <a:spLocks noGrp="1"/>
-          </p:cNvSpPr>
-          <p:nvPr/>
-        </p:nvSpPr>
-        <p:spPr>
-          <a:xfrm>
-            <a:off x="438150" y="381000"/>
-            <a:ext cx="11049000" cy="809625"/>
-          </a:xfrm>
-          <a:prstGeom prst="rect">
-            <a:avLst/>
-          </a:prstGeom>
-          <a:noFill/>
-          <a:ln w="0">
-            <a:noFill/>
-          </a:ln>
-        </p:spPr>
-        <p:txBody>
-          <a:bodyPr>
-            <a:noAutofit/>
-          </a:bodyPr>
-          <a:lstStyle/>
-          <a:p>
-            <a:pPr>
-              <a:defRPr sz="3300" b="1">
-                <a:solidFill>
-                  <a:srgbClr val="172D3D"/>
-                </a:solidFill>
-                <a:latin typeface="Arial"/>
-                <a:ea typeface="Arial"/>
-                <a:cs typeface="Arial"/>
-              </a:defRPr>
-            </a:pPr>
-            <a:r>
-              <a:rPr sz="3300" b="1">
-                <a:solidFill>
-                  <a:srgbClr val="172D3D"/>
-                </a:solidFill>
-                <a:latin typeface="Arial"/>
-                <a:ea typeface="Arial"/>
-                <a:cs typeface="Arial"/>
-              </a:rPr>
-              <a:t>What we built: the physical rig</a:t>
-            </a:r>
-          </a:p>
-        </p:txBody>
-      </p:sp>
-      <p:sp>
-        <p:nvSpPr>
-          <p:cNvPr id="2" name="03">
-            <a:extLst>
-              <a:ext uri="{FF2B5EF4-FFF2-40B4-BE49-F238E27FC236}">
-                <a16:creationId xmlns:a16="http://schemas.microsoft.com/office/drawing/2014/main" id="{CFB5FF92-5DE5-431F-B644-183C6C08DB02}"/>
-              </a:ext>
-            </a:extLst>
-          </p:cNvPr>
-          <p:cNvSpPr>
-            <a:spLocks noGrp="1"/>
-          </p:cNvSpPr>
-          <p:nvPr/>
-        </p:nvSpPr>
-        <p:spPr>
-          <a:xfrm>
-            <a:off x="466725" y="6362700"/>
-            <a:ext cx="476250" cy="228600"/>
-          </a:xfrm>
-          <a:prstGeom prst="rect">
-            <a:avLst/>
-          </a:prstGeom>
-          <a:noFill/>
-          <a:ln w="0">
-            <a:noFill/>
-          </a:ln>
-        </p:spPr>
-        <p:txBody>
-          <a:bodyPr>
-            <a:noAutofit/>
-          </a:bodyPr>
-          <a:lstStyle/>
-          <a:p>
-            <a:pPr>
-              <a:defRPr sz="1200" b="0">
-                <a:solidFill>
-                  <a:srgbClr val="536B79"/>
-                </a:solidFill>
-                <a:latin typeface="Arial"/>
-                <a:ea typeface="Arial"/>
-                <a:cs typeface="Arial"/>
-              </a:defRPr>
-            </a:pPr>
-            <a:r>
-              <a:rPr sz="1200" b="0">
-                <a:solidFill>
-                  <a:srgbClr val="536B79"/>
-                </a:solidFill>
-                <a:latin typeface="Arial"/>
-                <a:ea typeface="Arial"/>
-                <a:cs typeface="Arial"/>
-              </a:rPr>
-              <a:t>04</a:t>
-            </a:r>
-          </a:p>
-        </p:txBody>
-      </p:sp>
-      <p:pic>
-        <p:nvPicPr>
-          <p:cNvPr id="8" name="Picture 7" descr="image.jpg"/>
-          <p:cNvPicPr>
-            <a:picLocks noChangeAspect="1"/>
-          </p:cNvPicPr>
-          <p:nvPr/>
-        </p:nvPicPr>
-        <p:blipFill>
-          <a:blip r:embed="rId2"/>
-          <a:stretch>
-            <a:fillRect/>
-          </a:stretch>
-        </p:blipFill>
-        <p:spPr>
-          <a:xfrm>
-            <a:off x="571500" y="1300000"/>
-            <a:ext cx="2650000" cy="1490625"/>
-          </a:xfrm>
-          <a:prstGeom prst="rect">
-            <a:avLst/>
-          </a:prstGeom>
-        </p:spPr>
-      </p:pic>
-      <p:pic>
-        <p:nvPicPr>
-          <p:cNvPr id="9" name="Picture 8" descr="apparatus-b.jpg"/>
-          <p:cNvPicPr>
-            <a:picLocks noChangeAspect="1"/>
-          </p:cNvPicPr>
-          <p:nvPr/>
-        </p:nvPicPr>
-        <p:blipFill>
-          <a:blip r:embed="rId3"/>
-          <a:stretch>
-            <a:fillRect/>
-          </a:stretch>
-        </p:blipFill>
-        <p:spPr>
-          <a:xfrm>
-            <a:off x="3341500" y="1300000"/>
-            <a:ext cx="2650000" cy="1488417"/>
-          </a:xfrm>
-          <a:prstGeom prst="rect">
-            <a:avLst/>
-          </a:prstGeom>
-        </p:spPr>
-      </p:pic>
-      <p:pic>
-        <p:nvPicPr>
-          <p:cNvPr id="10" name="Picture 9" descr="apparatus-c.jpg"/>
-          <p:cNvPicPr>
-            <a:picLocks noChangeAspect="1"/>
-          </p:cNvPicPr>
-          <p:nvPr/>
-        </p:nvPicPr>
-        <p:blipFill>
-          <a:blip r:embed="rId4"/>
-          <a:stretch>
-            <a:fillRect/>
-          </a:stretch>
-        </p:blipFill>
-        <p:spPr>
-          <a:xfrm>
-            <a:off x="6111500" y="1300000"/>
-            <a:ext cx="2650000" cy="1490625"/>
-          </a:xfrm>
-          <a:prstGeom prst="rect">
-            <a:avLst/>
-          </a:prstGeom>
-        </p:spPr>
-      </p:pic>
-      <p:pic>
-        <p:nvPicPr>
-          <p:cNvPr id="11" name="clip-approach-xsens.mp4">
-            <a:hlinkClick r:id="" action="ppaction://media"/>
-          </p:cNvPr>
-          <p:cNvPicPr>
-            <a:picLocks noChangeAspect="1"/>
-          </p:cNvPicPr>
-          <p:nvPr>
-            <a:videoFile r:link="rId6"/>
-            <p:extLst>
-              <p:ext uri="{DAA4B4D4-6D71-4841-9C94-3DE7FCFB9230}">
-                <p14:media xmlns:p14="http://schemas.microsoft.com/office/powerpoint/2010/main" r:embed="rId5"/>
-              </p:ext>
-            </p:extLst>
-          </p:nvPr>
-        </p:nvPicPr>
-        <p:blipFill>
-          <a:blip r:embed="rId7"/>
-          <a:stretch>
-            <a:fillRect/>
-          </a:stretch>
-        </p:blipFill>
-        <p:spPr>
-          <a:xfrm>
-            <a:off x="8900000" y="1300000"/>
-            <a:ext cx="2750000" cy="1546875"/>
-          </a:xfrm>
-          <a:prstGeom prst="rect">
-            <a:avLst/>
-          </a:prstGeom>
-        </p:spPr>
-      </p:pic>
-      <p:sp>
-        <p:nvSpPr>
-          <p:cNvPr id="6" name="Schematic of the procedure; scale and motion are illustrativ">
-            <a:extLst>
-              <a:ext uri="{FF2B5EF4-FFF2-40B4-BE49-F238E27FC236}">
-                <a16:creationId xmlns:a16="http://schemas.microsoft.com/office/drawing/2014/main" id="{2BCF01A8-A812-4BB7-ADB0-153753A61F5C}"/>
-              </a:ext>
-            </a:extLst>
-          </p:cNvPr>
-          <p:cNvSpPr>
-            <a:spLocks noGrp="1"/>
-          </p:cNvSpPr>
-          <p:nvPr/>
-        </p:nvSpPr>
-        <p:spPr>
-          <a:xfrm>
-            <a:off x="571500" y="4500000"/>
-            <a:ext cx="10950000" cy="1300000"/>
-          </a:xfrm>
-          <a:prstGeom prst="rect">
-            <a:avLst/>
-          </a:prstGeom>
-          <a:noFill/>
-          <a:ln w="0">
-            <a:noFill/>
-          </a:ln>
-        </p:spPr>
-        <p:txBody>
-          <a:bodyPr>
-            <a:noAutofit/>
-          </a:bodyPr>
-          <a:lstStyle/>
-          <a:p>
-            <a:pPr>
-              <a:defRPr sz="1650" b="0">
-                <a:solidFill>
-                  <a:srgbClr val="536B79"/>
-                </a:solidFill>
-                <a:latin typeface="Arial"/>
-                <a:ea typeface="Arial"/>
-                <a:cs typeface="Arial"/>
-              </a:defRPr>
-            </a:pPr>
-            <a:r>
-              <a:rPr sz="1400" b="0">
-                <a:solidFill>
-                  <a:srgbClr val="536B79"/>
-                </a:solidFill>
-                <a:latin typeface="Arial"/>
-                <a:ea typeface="Arial"/>
-                <a:cs typeface="Arial"/>
-              </a:rPr>
-              <a:t>UR10 holding a full-size panel at ceiling height, OptiTrack cameras around the cell, operator in an Xsens suit.</a:t>
-            </a:r>
-          </a:p>
-          <a:p>
-            <a:pPr>
-              <a:defRPr sz="1650" b="0">
-                <a:solidFill>
-                  <a:srgbClr val="536B79"/>
-                </a:solidFill>
-                <a:latin typeface="Arial"/>
-                <a:ea typeface="Arial"/>
-                <a:cs typeface="Arial"/>
-              </a:defRPr>
-            </a:pPr>
-            <a:r>
-              <a:rPr sz="1400" b="0">
-                <a:solidFill>
-                  <a:srgbClr val="536B79"/>
-                </a:solidFill>
-                <a:latin typeface="Arial"/>
-                <a:ea typeface="Arial"/>
-                <a:cs typeface="Arial"/>
-              </a:rPr>
-              <a:t>Video: a participant approaching the robot while the suit streams every body segment to the controller in real time.</a:t>
-            </a:r>
-          </a:p>
-        </p:txBody>
-      </p:sp>
-    </p:spTree>
-  </p:cSld>
-  <p:clrMapOvr>
-    <a:masterClrMapping/>
-  </p:clrMapOvr>
   <p:timing>
     <p:tnLst>
       <p:par>
@@ -13097,7 +12303,7 @@
                   </p:stCondLst>
                 </p:cTn>
                 <p:tgtEl>
-                  <p:spTgt spid="11"/>
+                  <p:spTgt spid="9"/>
                 </p:tgtEl>
               </p:cMediaNode>
             </p:video>
@@ -13228,7 +12434,7 @@
                 <a:ea typeface="Arial"/>
                 <a:cs typeface="Arial"/>
               </a:rPr>
-              <a:t>05</a:t>
+              <a:t>04</a:t>
             </a:r>
           </a:p>
         </p:txBody>
@@ -13513,7 +12719,7 @@
                 <a:ea typeface="Arial"/>
                 <a:cs typeface="Arial"/>
               </a:rPr>
-              <a:t>06</a:t>
+              <a:t>05</a:t>
             </a:r>
           </a:p>
         </p:txBody>
@@ -14118,7 +13324,7 @@
                 <a:ea typeface="Arial"/>
                 <a:cs typeface="Arial"/>
               </a:rPr>
-              <a:t>07</a:t>
+              <a:t>06</a:t>
             </a:r>
           </a:p>
         </p:txBody>
@@ -14535,824 +13741,6 @@
                 <a:cs typeface="Arial"/>
               </a:rPr>
               <a:t>11 matched intake/end sets. Complete individual linkage is unavailable.</a:t>
-            </a:r>
-          </a:p>
-        </p:txBody>
-      </p:sp>
-    </p:spTree>
-    <p:extLst>
-      <p:ext uri="{BB962C8B-B14F-4D97-AF65-F5344CB8AC3E}">
-        <p14:creationId xmlns:p14="http://schemas.microsoft.com/office/powerpoint/2010/main" val="1512327385"/>
-      </p:ext>
-    </p:extLst>
-  </p:cSld>
-</p:sld>
-</file>
-
-<file path=ppt/slides/slide8.xml><?xml version="1.0" encoding="utf-8"?>
-<p:sld xmlns:p="http://schemas.openxmlformats.org/presentationml/2006/main">
-  <p:cSld>
-    <p:spTree>
-      <p:nvGrpSpPr>
-        <p:cNvPr id="1" name=""/>
-        <p:cNvGrpSpPr/>
-        <p:nvPr/>
-      </p:nvGrpSpPr>
-      <p:grpSpPr>
-        <a:xfrm xmlns:a="http://schemas.openxmlformats.org/drawingml/2006/main"/>
-      </p:grpSpPr>
-      <p:sp>
-        <p:nvSpPr>
-          <p:cNvPr id="8" name="Task-phase recognition">
-            <a:extLst xmlns:a="http://schemas.openxmlformats.org/drawingml/2006/main">
-              <a:ext uri="{FF2B5EF4-FFF2-40B4-BE49-F238E27FC236}">
-                <a16:creationId xmlns:a16="http://schemas.microsoft.com/office/drawing/2014/main" id="{96A2AFE6-22E8-453C-8953-0DBB4028953C}"/>
-              </a:ext>
-            </a:extLst>
-          </p:cNvPr>
-          <p:cNvSpPr>
-            <a:spLocks xmlns:a="http://schemas.openxmlformats.org/drawingml/2006/main" noGrp="1"/>
-          </p:cNvSpPr>
-          <p:nvPr/>
-        </p:nvSpPr>
-        <p:spPr>
-          <a:xfrm xmlns:a="http://schemas.openxmlformats.org/drawingml/2006/main">
-            <a:off x="438150" y="381000"/>
-            <a:ext cx="11049000" cy="809625"/>
-          </a:xfrm>
-          <a:prstGeom xmlns:a="http://schemas.openxmlformats.org/drawingml/2006/main" prst="rect">
-            <a:avLst/>
-          </a:prstGeom>
-          <a:noFill xmlns:a="http://schemas.openxmlformats.org/drawingml/2006/main"/>
-          <a:ln xmlns:a="http://schemas.openxmlformats.org/drawingml/2006/main" w="0">
-            <a:noFill/>
-          </a:ln>
-        </p:spPr>
-        <p:txBody>
-          <a:bodyPr xmlns:a="http://schemas.openxmlformats.org/drawingml/2006/main">
-            <a:noAutofit/>
-          </a:bodyPr>
-          <a:lstStyle xmlns:a="http://schemas.openxmlformats.org/drawingml/2006/main"/>
-          <a:p xmlns:a="http://schemas.openxmlformats.org/drawingml/2006/main">
-            <a:pPr>
-              <a:defRPr sz="3300" b="1">
-                <a:solidFill>
-                  <a:srgbClr val="172D3D"/>
-                </a:solidFill>
-                <a:latin typeface="Arial"/>
-                <a:ea typeface="Arial"/>
-                <a:cs typeface="Arial"/>
-              </a:defRPr>
-            </a:pPr>
-            <a:r>
-              <a:rPr sz="3300" b="1">
-                <a:solidFill>
-                  <a:srgbClr val="172D3D"/>
-                </a:solidFill>
-                <a:latin typeface="Arial"/>
-                <a:ea typeface="Arial"/>
-                <a:cs typeface="Arial"/>
-              </a:rPr>
-              <a:t>Task-phase recognition</a:t>
-            </a:r>
-          </a:p>
-        </p:txBody>
-      </p:sp>
-      <p:sp>
-        <p:nvSpPr>
-          <p:cNvPr id="2" name="06">
-            <a:extLst xmlns:a="http://schemas.openxmlformats.org/drawingml/2006/main">
-              <a:ext uri="{FF2B5EF4-FFF2-40B4-BE49-F238E27FC236}">
-                <a16:creationId xmlns:a16="http://schemas.microsoft.com/office/drawing/2014/main" id="{AC64141E-F65C-4F79-B767-F9AB54E188D9}"/>
-              </a:ext>
-            </a:extLst>
-          </p:cNvPr>
-          <p:cNvSpPr>
-            <a:spLocks xmlns:a="http://schemas.openxmlformats.org/drawingml/2006/main" noGrp="1"/>
-          </p:cNvSpPr>
-          <p:nvPr/>
-        </p:nvSpPr>
-        <p:spPr>
-          <a:xfrm xmlns:a="http://schemas.openxmlformats.org/drawingml/2006/main">
-            <a:off x="466725" y="6362700"/>
-            <a:ext cx="476250" cy="228600"/>
-          </a:xfrm>
-          <a:prstGeom xmlns:a="http://schemas.openxmlformats.org/drawingml/2006/main" prst="rect">
-            <a:avLst/>
-          </a:prstGeom>
-          <a:noFill xmlns:a="http://schemas.openxmlformats.org/drawingml/2006/main"/>
-          <a:ln xmlns:a="http://schemas.openxmlformats.org/drawingml/2006/main" w="0">
-            <a:noFill/>
-          </a:ln>
-        </p:spPr>
-        <p:txBody>
-          <a:bodyPr xmlns:a="http://schemas.openxmlformats.org/drawingml/2006/main">
-            <a:noAutofit/>
-          </a:bodyPr>
-          <a:lstStyle xmlns:a="http://schemas.openxmlformats.org/drawingml/2006/main"/>
-          <a:p xmlns:a="http://schemas.openxmlformats.org/drawingml/2006/main">
-            <a:pPr>
-              <a:defRPr sz="1200" b="0">
-                <a:solidFill>
-                  <a:srgbClr val="536B79"/>
-                </a:solidFill>
-                <a:latin typeface="Arial"/>
-                <a:ea typeface="Arial"/>
-                <a:cs typeface="Arial"/>
-              </a:defRPr>
-            </a:pPr>
-            <a:r>
-              <a:rPr sz="1200" b="0">
-                <a:solidFill>
-                  <a:srgbClr val="536B79"/>
-                </a:solidFill>
-                <a:latin typeface="Arial"/>
-                <a:ea typeface="Arial"/>
-                <a:cs typeface="Arial"/>
-              </a:rPr>
-              <a:t>08</a:t>
-            </a:r>
-          </a:p>
-        </p:txBody>
-      </p:sp>
-      <p:sp>
-        <p:nvSpPr>
-          <p:cNvPr id="3" name="The model recognises approaching, working and retreating">
-            <a:extLst xmlns:a="http://schemas.openxmlformats.org/drawingml/2006/main">
-              <a:ext uri="{FF2B5EF4-FFF2-40B4-BE49-F238E27FC236}">
-                <a16:creationId xmlns:a16="http://schemas.microsoft.com/office/drawing/2014/main" id="{688F278D-A7FA-4FF6-BC11-CA003FC63529}"/>
-              </a:ext>
-            </a:extLst>
-          </p:cNvPr>
-          <p:cNvSpPr>
-            <a:spLocks xmlns:a="http://schemas.openxmlformats.org/drawingml/2006/main" noGrp="1"/>
-          </p:cNvSpPr>
-          <p:nvPr/>
-        </p:nvSpPr>
-        <p:spPr>
-          <a:xfrm xmlns:a="http://schemas.openxmlformats.org/drawingml/2006/main">
-            <a:off x="571500" y="1285875"/>
-            <a:ext cx="10858500" cy="590550"/>
-          </a:xfrm>
-          <a:prstGeom xmlns:a="http://schemas.openxmlformats.org/drawingml/2006/main" prst="rect">
-            <a:avLst/>
-          </a:prstGeom>
-          <a:noFill xmlns:a="http://schemas.openxmlformats.org/drawingml/2006/main"/>
-          <a:ln xmlns:a="http://schemas.openxmlformats.org/drawingml/2006/main" w="0">
-            <a:noFill/>
-          </a:ln>
-        </p:spPr>
-        <p:txBody>
-          <a:bodyPr xmlns:a="http://schemas.openxmlformats.org/drawingml/2006/main">
-            <a:noAutofit/>
-          </a:bodyPr>
-          <a:lstStyle xmlns:a="http://schemas.openxmlformats.org/drawingml/2006/main"/>
-          <a:p xmlns:a="http://schemas.openxmlformats.org/drawingml/2006/main">
-            <a:pPr>
-              <a:defRPr sz="2325" b="1">
-                <a:solidFill>
-                  <a:srgbClr val="006DAE"/>
-                </a:solidFill>
-                <a:latin typeface="Arial"/>
-                <a:ea typeface="Arial"/>
-                <a:cs typeface="Arial"/>
-              </a:defRPr>
-            </a:pPr>
-            <a:r>
-              <a:rPr sz="2325" b="1">
-                <a:solidFill>
-                  <a:srgbClr val="006DAE"/>
-                </a:solidFill>
-                <a:latin typeface="Arial"/>
-                <a:ea typeface="Arial"/>
-                <a:cs typeface="Arial"/>
-              </a:rPr>
-              <a:t>The model recognises approaching, working and retreating</a:t>
-            </a:r>
-          </a:p>
-        </p:txBody>
-      </p:sp>
-      <p:graphicFrame>
-        <p:nvGraphicFramePr>
-          <p:cNvPr id="11" name="Chart"/>
-          <p:cNvGraphicFramePr/>
-          <p:nvPr/>
-        </p:nvGraphicFramePr>
-        <p:xfrm>
-          <a:off xmlns:a="http://schemas.openxmlformats.org/drawingml/2006/main" x="619125" y="2038350"/>
-          <a:ext xmlns:a="http://schemas.openxmlformats.org/drawingml/2006/main" cx="6667500" cy="2952750"/>
-        </p:xfrm>
-        <a:graphic xmlns:a="http://schemas.openxmlformats.org/drawingml/2006/main">
-          <a:graphicData uri="http://schemas.openxmlformats.org/drawingml/2006/chart">
-            <c:chart xmlns:r="http://schemas.openxmlformats.org/officeDocument/2006/relationships" xmlns:c="http://schemas.openxmlformats.org/drawingml/2006/chart" r:id="Rf75f28609aee42cb"/>
-          </a:graphicData>
-        </a:graphic>
-      </p:graphicFrame>
-      <p:sp>
-        <p:nvSpPr>
-          <p:cNvPr id="5" name="32 development trials&#10;from 3 operators">
-            <a:extLst xmlns:a="http://schemas.openxmlformats.org/drawingml/2006/main">
-              <a:ext uri="{FF2B5EF4-FFF2-40B4-BE49-F238E27FC236}">
-                <a16:creationId xmlns:a16="http://schemas.microsoft.com/office/drawing/2014/main" id="{1D5C0430-4D0E-4A82-A702-E802FCCA0569}"/>
-              </a:ext>
-            </a:extLst>
-          </p:cNvPr>
-          <p:cNvSpPr>
-            <a:spLocks xmlns:a="http://schemas.openxmlformats.org/drawingml/2006/main" noGrp="1"/>
-          </p:cNvSpPr>
-          <p:nvPr/>
-        </p:nvSpPr>
-        <p:spPr>
-          <a:xfrm xmlns:a="http://schemas.openxmlformats.org/drawingml/2006/main">
-            <a:off x="7953375" y="2314575"/>
-            <a:ext cx="3524250" cy="914400"/>
-          </a:xfrm>
-          <a:prstGeom xmlns:a="http://schemas.openxmlformats.org/drawingml/2006/main" prst="rect">
-            <a:avLst/>
-          </a:prstGeom>
-          <a:noFill xmlns:a="http://schemas.openxmlformats.org/drawingml/2006/main"/>
-          <a:ln xmlns:a="http://schemas.openxmlformats.org/drawingml/2006/main" w="0">
-            <a:noFill/>
-          </a:ln>
-        </p:spPr>
-        <p:txBody>
-          <a:bodyPr xmlns:a="http://schemas.openxmlformats.org/drawingml/2006/main">
-            <a:noAutofit/>
-          </a:bodyPr>
-          <a:lstStyle xmlns:a="http://schemas.openxmlformats.org/drawingml/2006/main"/>
-          <a:p xmlns:a="http://schemas.openxmlformats.org/drawingml/2006/main">
-            <a:pPr>
-              <a:defRPr sz="2400" b="1">
-                <a:solidFill>
-                  <a:srgbClr val="172D3D"/>
-                </a:solidFill>
-                <a:latin typeface="Arial"/>
-                <a:ea typeface="Arial"/>
-                <a:cs typeface="Arial"/>
-              </a:defRPr>
-            </a:pPr>
-            <a:r>
-              <a:rPr sz="2400" b="1">
-                <a:solidFill>
-                  <a:srgbClr val="172D3D"/>
-                </a:solidFill>
-                <a:latin typeface="Arial"/>
-                <a:ea typeface="Arial"/>
-                <a:cs typeface="Arial"/>
-              </a:rPr>
-              <a:t>32 development trials</a:t>
-            </a:r>
-          </a:p>
-          <a:p xmlns:a="http://schemas.openxmlformats.org/drawingml/2006/main">
-            <a:pPr>
-              <a:defRPr sz="2400" b="1">
-                <a:solidFill>
-                  <a:srgbClr val="172D3D"/>
-                </a:solidFill>
-                <a:latin typeface="Arial"/>
-                <a:ea typeface="Arial"/>
-                <a:cs typeface="Arial"/>
-              </a:defRPr>
-            </a:pPr>
-            <a:r>
-              <a:rPr sz="2400" b="1">
-                <a:solidFill>
-                  <a:srgbClr val="172D3D"/>
-                </a:solidFill>
-                <a:latin typeface="Arial"/>
-                <a:ea typeface="Arial"/>
-                <a:cs typeface="Arial"/>
-              </a:rPr>
-              <a:t>from 3 operators</a:t>
-            </a:r>
-          </a:p>
-        </p:txBody>
-      </p:sp>
-      <p:sp>
-        <p:nvSpPr>
-          <p:cNvPr id="6" name="Each operator was held&#10;out in turn during&#10;validation.">
-            <a:extLst xmlns:a="http://schemas.openxmlformats.org/drawingml/2006/main">
-              <a:ext uri="{FF2B5EF4-FFF2-40B4-BE49-F238E27FC236}">
-                <a16:creationId xmlns:a16="http://schemas.microsoft.com/office/drawing/2014/main" id="{1CD572CB-78F6-4641-B899-95899A8F497E}"/>
-              </a:ext>
-            </a:extLst>
-          </p:cNvPr>
-          <p:cNvSpPr>
-            <a:spLocks xmlns:a="http://schemas.openxmlformats.org/drawingml/2006/main" noGrp="1"/>
-          </p:cNvSpPr>
-          <p:nvPr/>
-        </p:nvSpPr>
-        <p:spPr>
-          <a:xfrm xmlns:a="http://schemas.openxmlformats.org/drawingml/2006/main">
-            <a:off x="7953375" y="3505200"/>
-            <a:ext cx="3524250" cy="1200150"/>
-          </a:xfrm>
-          <a:prstGeom xmlns:a="http://schemas.openxmlformats.org/drawingml/2006/main" prst="rect">
-            <a:avLst/>
-          </a:prstGeom>
-          <a:noFill xmlns:a="http://schemas.openxmlformats.org/drawingml/2006/main"/>
-          <a:ln xmlns:a="http://schemas.openxmlformats.org/drawingml/2006/main" w="0">
-            <a:noFill/>
-          </a:ln>
-        </p:spPr>
-        <p:txBody>
-          <a:bodyPr xmlns:a="http://schemas.openxmlformats.org/drawingml/2006/main">
-            <a:noAutofit/>
-          </a:bodyPr>
-          <a:lstStyle xmlns:a="http://schemas.openxmlformats.org/drawingml/2006/main"/>
-          <a:p xmlns:a="http://schemas.openxmlformats.org/drawingml/2006/main">
-            <a:pPr>
-              <a:defRPr sz="2175" b="0">
-                <a:solidFill>
-                  <a:srgbClr val="172D3D"/>
-                </a:solidFill>
-                <a:latin typeface="Arial"/>
-                <a:ea typeface="Arial"/>
-                <a:cs typeface="Arial"/>
-              </a:defRPr>
-            </a:pPr>
-            <a:r>
-              <a:rPr sz="2175" b="0">
-                <a:solidFill>
-                  <a:srgbClr val="172D3D"/>
-                </a:solidFill>
-                <a:latin typeface="Arial"/>
-                <a:ea typeface="Arial"/>
-                <a:cs typeface="Arial"/>
-              </a:rPr>
-              <a:t>Each operator was held</a:t>
-            </a:r>
-          </a:p>
-          <a:p xmlns:a="http://schemas.openxmlformats.org/drawingml/2006/main">
-            <a:pPr>
-              <a:defRPr sz="2175" b="0">
-                <a:solidFill>
-                  <a:srgbClr val="172D3D"/>
-                </a:solidFill>
-                <a:latin typeface="Arial"/>
-                <a:ea typeface="Arial"/>
-                <a:cs typeface="Arial"/>
-              </a:defRPr>
-            </a:pPr>
-            <a:r>
-              <a:rPr sz="2175" b="0">
-                <a:solidFill>
-                  <a:srgbClr val="172D3D"/>
-                </a:solidFill>
-                <a:latin typeface="Arial"/>
-                <a:ea typeface="Arial"/>
-                <a:cs typeface="Arial"/>
-              </a:rPr>
-              <a:t>out in turn during</a:t>
-            </a:r>
-          </a:p>
-          <a:p xmlns:a="http://schemas.openxmlformats.org/drawingml/2006/main">
-            <a:pPr>
-              <a:defRPr sz="2175" b="0">
-                <a:solidFill>
-                  <a:srgbClr val="172D3D"/>
-                </a:solidFill>
-                <a:latin typeface="Arial"/>
-                <a:ea typeface="Arial"/>
-                <a:cs typeface="Arial"/>
-              </a:defRPr>
-            </a:pPr>
-            <a:r>
-              <a:rPr sz="2175" b="0">
-                <a:solidFill>
-                  <a:srgbClr val="172D3D"/>
-                </a:solidFill>
-                <a:latin typeface="Arial"/>
-                <a:ea typeface="Arial"/>
-                <a:cs typeface="Arial"/>
-              </a:rPr>
-              <a:t>validation.</a:t>
-            </a:r>
-          </a:p>
-        </p:txBody>
-      </p:sp>
-      <p:sp>
-        <p:nvSpPr>
-          <p:cNvPr id="7" name="Recognition used present and past observations.&#10;These are de">
-            <a:extLst xmlns:a="http://schemas.openxmlformats.org/drawingml/2006/main">
-              <a:ext uri="{FF2B5EF4-FFF2-40B4-BE49-F238E27FC236}">
-                <a16:creationId xmlns:a16="http://schemas.microsoft.com/office/drawing/2014/main" id="{61552150-185B-4660-9ABC-0ECD18018E3B}"/>
-              </a:ext>
-            </a:extLst>
-          </p:cNvPr>
-          <p:cNvSpPr>
-            <a:spLocks xmlns:a="http://schemas.openxmlformats.org/drawingml/2006/main" noGrp="1"/>
-          </p:cNvSpPr>
-          <p:nvPr/>
-        </p:nvSpPr>
-        <p:spPr>
-          <a:xfrm xmlns:a="http://schemas.openxmlformats.org/drawingml/2006/main">
-            <a:off x="571500" y="4877800"/>
-            <a:ext cx="10858500" cy="628650"/>
-          </a:xfrm>
-          <a:prstGeom xmlns:a="http://schemas.openxmlformats.org/drawingml/2006/main" prst="rect">
-            <a:avLst/>
-          </a:prstGeom>
-          <a:noFill xmlns:a="http://schemas.openxmlformats.org/drawingml/2006/main"/>
-          <a:ln xmlns:a="http://schemas.openxmlformats.org/drawingml/2006/main" w="0">
-            <a:noFill/>
-          </a:ln>
-        </p:spPr>
-        <p:txBody>
-          <a:bodyPr xmlns:a="http://schemas.openxmlformats.org/drawingml/2006/main">
-            <a:noAutofit/>
-          </a:bodyPr>
-          <a:lstStyle xmlns:a="http://schemas.openxmlformats.org/drawingml/2006/main"/>
-          <a:p xmlns:a="http://schemas.openxmlformats.org/drawingml/2006/main">
-            <a:pPr>
-              <a:defRPr sz="1875" b="0">
-                <a:solidFill>
-                  <a:srgbClr val="536B79"/>
-                </a:solidFill>
-                <a:latin typeface="Arial"/>
-                <a:ea typeface="Arial"/>
-                <a:cs typeface="Arial"/>
-              </a:defRPr>
-            </a:pPr>
-            <a:r>
-              <a:rPr sz="1875" b="0">
-                <a:solidFill>
-                  <a:srgbClr val="536B79"/>
-                </a:solidFill>
-                <a:latin typeface="Arial"/>
-                <a:ea typeface="Arial"/>
-                <a:cs typeface="Arial"/>
-              </a:rPr>
-              <a:t>Recognition used present and past observations.</a:t>
-            </a:r>
-          </a:p>
-          <a:p xmlns:a="http://schemas.openxmlformats.org/drawingml/2006/main">
-            <a:pPr>
-              <a:defRPr sz="1875" b="0">
-                <a:solidFill>
-                  <a:srgbClr val="536B79"/>
-                </a:solidFill>
-                <a:latin typeface="Arial"/>
-                <a:ea typeface="Arial"/>
-                <a:cs typeface="Arial"/>
-              </a:defRPr>
-            </a:pPr>
-            <a:r>
-              <a:rPr sz="1875" b="0">
-                <a:solidFill>
-                  <a:srgbClr val="536B79"/>
-                </a:solidFill>
-                <a:latin typeface="Arial"/>
-                <a:ea typeface="Arial"/>
-                <a:cs typeface="Arial"/>
-              </a:rPr>
-              <a:t>Predictive policy: 15 to 73 stop onsets per trial vs 6 to 9 for fixed/reactive, nearly all under 0.5 s. Chattering, not longer stops.</a:t>
-            </a:r>
-          </a:p>
-        </p:txBody>
-      </p:sp>
-    </p:spTree>
-    <p:extLst>
-      <p:ext uri="{BB962C8B-B14F-4D97-AF65-F5344CB8AC3E}">
-        <p14:creationId xmlns:p14="http://schemas.microsoft.com/office/powerpoint/2010/main" val="1512327385"/>
-      </p:ext>
-    </p:extLst>
-  </p:cSld>
-</p:sld>
-</file>
-
-<file path=ppt/slides/slide9.xml><?xml version="1.0" encoding="utf-8"?>
-<p:sld xmlns:p="http://schemas.openxmlformats.org/presentationml/2006/main">
-  <p:cSld>
-    <p:spTree>
-      <p:nvGrpSpPr>
-        <p:cNvPr id="1" name=""/>
-        <p:cNvGrpSpPr/>
-        <p:nvPr/>
-      </p:nvGrpSpPr>
-      <p:grpSpPr>
-        <a:xfrm xmlns:a="http://schemas.openxmlformats.org/drawingml/2006/main"/>
-      </p:grpSpPr>
-      <p:sp>
-        <p:nvSpPr>
-          <p:cNvPr id="7" name="Reported safety generally exceeded expectations">
-            <a:extLst xmlns:a="http://schemas.openxmlformats.org/drawingml/2006/main">
-              <a:ext uri="{FF2B5EF4-FFF2-40B4-BE49-F238E27FC236}">
-                <a16:creationId xmlns:a16="http://schemas.microsoft.com/office/drawing/2014/main" id="{5814CDDA-1AB1-4D61-8FAF-E713491B3C34}"/>
-              </a:ext>
-            </a:extLst>
-          </p:cNvPr>
-          <p:cNvSpPr>
-            <a:spLocks xmlns:a="http://schemas.openxmlformats.org/drawingml/2006/main" noGrp="1"/>
-          </p:cNvSpPr>
-          <p:nvPr/>
-        </p:nvSpPr>
-        <p:spPr>
-          <a:xfrm xmlns:a="http://schemas.openxmlformats.org/drawingml/2006/main">
-            <a:off x="438150" y="381000"/>
-            <a:ext cx="11049000" cy="809625"/>
-          </a:xfrm>
-          <a:prstGeom xmlns:a="http://schemas.openxmlformats.org/drawingml/2006/main" prst="rect">
-            <a:avLst/>
-          </a:prstGeom>
-          <a:noFill xmlns:a="http://schemas.openxmlformats.org/drawingml/2006/main"/>
-          <a:ln xmlns:a="http://schemas.openxmlformats.org/drawingml/2006/main" w="0">
-            <a:noFill/>
-          </a:ln>
-        </p:spPr>
-        <p:txBody>
-          <a:bodyPr xmlns:a="http://schemas.openxmlformats.org/drawingml/2006/main">
-            <a:noAutofit/>
-          </a:bodyPr>
-          <a:lstStyle xmlns:a="http://schemas.openxmlformats.org/drawingml/2006/main"/>
-          <a:p xmlns:a="http://schemas.openxmlformats.org/drawingml/2006/main">
-            <a:pPr>
-              <a:defRPr sz="3300" b="1">
-                <a:solidFill>
-                  <a:srgbClr val="172D3D"/>
-                </a:solidFill>
-                <a:latin typeface="Arial"/>
-                <a:ea typeface="Arial"/>
-                <a:cs typeface="Arial"/>
-              </a:defRPr>
-            </a:pPr>
-            <a:r>
-              <a:rPr sz="3300" b="1">
-                <a:solidFill>
-                  <a:srgbClr val="172D3D"/>
-                </a:solidFill>
-                <a:latin typeface="Arial"/>
-                <a:ea typeface="Arial"/>
-                <a:cs typeface="Arial"/>
-              </a:rPr>
-              <a:t>Reported safety generally exceeded expectations</a:t>
-            </a:r>
-          </a:p>
-        </p:txBody>
-      </p:sp>
-      <p:sp>
-        <p:nvSpPr>
-          <p:cNvPr id="2" name="07">
-            <a:extLst xmlns:a="http://schemas.openxmlformats.org/drawingml/2006/main">
-              <a:ext uri="{FF2B5EF4-FFF2-40B4-BE49-F238E27FC236}">
-                <a16:creationId xmlns:a16="http://schemas.microsoft.com/office/drawing/2014/main" id="{C4C99FBE-1199-451A-A032-F316AA2D1434}"/>
-              </a:ext>
-            </a:extLst>
-          </p:cNvPr>
-          <p:cNvSpPr>
-            <a:spLocks xmlns:a="http://schemas.openxmlformats.org/drawingml/2006/main" noGrp="1"/>
-          </p:cNvSpPr>
-          <p:nvPr/>
-        </p:nvSpPr>
-        <p:spPr>
-          <a:xfrm xmlns:a="http://schemas.openxmlformats.org/drawingml/2006/main">
-            <a:off x="466725" y="6362700"/>
-            <a:ext cx="476250" cy="228600"/>
-          </a:xfrm>
-          <a:prstGeom xmlns:a="http://schemas.openxmlformats.org/drawingml/2006/main" prst="rect">
-            <a:avLst/>
-          </a:prstGeom>
-          <a:noFill xmlns:a="http://schemas.openxmlformats.org/drawingml/2006/main"/>
-          <a:ln xmlns:a="http://schemas.openxmlformats.org/drawingml/2006/main" w="0">
-            <a:noFill/>
-          </a:ln>
-        </p:spPr>
-        <p:txBody>
-          <a:bodyPr xmlns:a="http://schemas.openxmlformats.org/drawingml/2006/main">
-            <a:noAutofit/>
-          </a:bodyPr>
-          <a:lstStyle xmlns:a="http://schemas.openxmlformats.org/drawingml/2006/main"/>
-          <a:p xmlns:a="http://schemas.openxmlformats.org/drawingml/2006/main">
-            <a:pPr>
-              <a:defRPr sz="1200" b="0">
-                <a:solidFill>
-                  <a:srgbClr val="536B79"/>
-                </a:solidFill>
-                <a:latin typeface="Arial"/>
-                <a:ea typeface="Arial"/>
-                <a:cs typeface="Arial"/>
-              </a:defRPr>
-            </a:pPr>
-            <a:r>
-              <a:rPr sz="1200" b="0">
-                <a:solidFill>
-                  <a:srgbClr val="536B79"/>
-                </a:solidFill>
-                <a:latin typeface="Arial"/>
-                <a:ea typeface="Arial"/>
-                <a:cs typeface="Arial"/>
-              </a:rPr>
-              <a:t>11</a:t>
-            </a:r>
-          </a:p>
-        </p:txBody>
-      </p:sp>
-      <p:sp>
-        <p:nvSpPr>
-          <p:cNvPr id="3" name="Changes between intake and end ratings">
-            <a:extLst xmlns:a="http://schemas.openxmlformats.org/drawingml/2006/main">
-              <a:ext uri="{FF2B5EF4-FFF2-40B4-BE49-F238E27FC236}">
-                <a16:creationId xmlns:a16="http://schemas.microsoft.com/office/drawing/2014/main" id="{2DFEBB9F-3B8E-435B-BEE5-DF4C4122DD86}"/>
-              </a:ext>
-            </a:extLst>
-          </p:cNvPr>
-          <p:cNvSpPr>
-            <a:spLocks xmlns:a="http://schemas.openxmlformats.org/drawingml/2006/main" noGrp="1"/>
-          </p:cNvSpPr>
-          <p:nvPr/>
-        </p:nvSpPr>
-        <p:spPr>
-          <a:xfrm xmlns:a="http://schemas.openxmlformats.org/drawingml/2006/main">
-            <a:off x="571500" y="1295400"/>
-            <a:ext cx="10763250" cy="476250"/>
-          </a:xfrm>
-          <a:prstGeom xmlns:a="http://schemas.openxmlformats.org/drawingml/2006/main" prst="rect">
-            <a:avLst/>
-          </a:prstGeom>
-          <a:noFill xmlns:a="http://schemas.openxmlformats.org/drawingml/2006/main"/>
-          <a:ln xmlns:a="http://schemas.openxmlformats.org/drawingml/2006/main" w="0">
-            <a:noFill/>
-          </a:ln>
-        </p:spPr>
-        <p:txBody>
-          <a:bodyPr xmlns:a="http://schemas.openxmlformats.org/drawingml/2006/main">
-            <a:noAutofit/>
-          </a:bodyPr>
-          <a:lstStyle xmlns:a="http://schemas.openxmlformats.org/drawingml/2006/main"/>
-          <a:p xmlns:a="http://schemas.openxmlformats.org/drawingml/2006/main">
-            <a:pPr>
-              <a:defRPr sz="2250" b="0">
-                <a:solidFill>
-                  <a:srgbClr val="172D3D"/>
-                </a:solidFill>
-                <a:latin typeface="Arial"/>
-                <a:ea typeface="Arial"/>
-                <a:cs typeface="Arial"/>
-              </a:defRPr>
-            </a:pPr>
-            <a:r>
-              <a:rPr sz="2250" b="0">
-                <a:solidFill>
-                  <a:srgbClr val="172D3D"/>
-                </a:solidFill>
-                <a:latin typeface="Arial"/>
-                <a:ea typeface="Arial"/>
-                <a:cs typeface="Arial"/>
-              </a:rPr>
-              <a:t>Changes between intake and end ratings</a:t>
-            </a:r>
-          </a:p>
-        </p:txBody>
-      </p:sp>
-      <p:graphicFrame>
-        <p:nvGraphicFramePr>
-          <p:cNvPr id="10" name="Chart"/>
-          <p:cNvGraphicFramePr/>
-          <p:nvPr/>
-        </p:nvGraphicFramePr>
-        <p:xfrm>
-          <a:off xmlns:a="http://schemas.openxmlformats.org/drawingml/2006/main" x="619125" y="1952625"/>
-          <a:ext xmlns:a="http://schemas.openxmlformats.org/drawingml/2006/main" cx="10715625" cy="2571750"/>
-        </p:xfrm>
-        <a:graphic xmlns:a="http://schemas.openxmlformats.org/drawingml/2006/main">
-          <a:graphicData uri="http://schemas.openxmlformats.org/drawingml/2006/chart">
-            <c:chart xmlns:r="http://schemas.openxmlformats.org/officeDocument/2006/relationships" xmlns:c="http://schemas.openxmlformats.org/drawingml/2006/chart" r:id="Rb2a10100880f4f5f"/>
-          </a:graphicData>
-        </a:graphic>
-      </p:graphicFrame>
-      <p:sp>
-        <p:nvSpPr>
-          <p:cNvPr id="5" name="8 of 11 safety ratings increased; trust responses were more ">
-            <a:extLst xmlns:a="http://schemas.openxmlformats.org/drawingml/2006/main">
-              <a:ext uri="{FF2B5EF4-FFF2-40B4-BE49-F238E27FC236}">
-                <a16:creationId xmlns:a16="http://schemas.microsoft.com/office/drawing/2014/main" id="{4C68F436-7C3E-4DDA-A61F-723CD0311D75}"/>
-              </a:ext>
-            </a:extLst>
-          </p:cNvPr>
-          <p:cNvSpPr>
-            <a:spLocks xmlns:a="http://schemas.openxmlformats.org/drawingml/2006/main" noGrp="1"/>
-          </p:cNvSpPr>
-          <p:nvPr/>
-        </p:nvSpPr>
-        <p:spPr>
-          <a:xfrm xmlns:a="http://schemas.openxmlformats.org/drawingml/2006/main">
-            <a:off x="571500" y="4695825"/>
-            <a:ext cx="10763250" cy="552450"/>
-          </a:xfrm>
-          <a:prstGeom xmlns:a="http://schemas.openxmlformats.org/drawingml/2006/main" prst="rect">
-            <a:avLst/>
-          </a:prstGeom>
-          <a:noFill xmlns:a="http://schemas.openxmlformats.org/drawingml/2006/main"/>
-          <a:ln xmlns:a="http://schemas.openxmlformats.org/drawingml/2006/main" w="0">
-            <a:noFill/>
-          </a:ln>
-        </p:spPr>
-        <p:txBody>
-          <a:bodyPr xmlns:a="http://schemas.openxmlformats.org/drawingml/2006/main">
-            <a:noAutofit/>
-          </a:bodyPr>
-          <a:lstStyle xmlns:a="http://schemas.openxmlformats.org/drawingml/2006/main"/>
-          <a:p xmlns:a="http://schemas.openxmlformats.org/drawingml/2006/main">
-            <a:pPr>
-              <a:defRPr sz="2250" b="1">
-                <a:solidFill>
-                  <a:srgbClr val="006DAE"/>
-                </a:solidFill>
-                <a:latin typeface="Arial"/>
-                <a:ea typeface="Arial"/>
-                <a:cs typeface="Arial"/>
-              </a:defRPr>
-            </a:pPr>
-            <a:r>
-              <a:rPr sz="2250" b="1">
-                <a:solidFill>
-                  <a:srgbClr val="006DAE"/>
-                </a:solidFill>
-                <a:latin typeface="Arial"/>
-                <a:ea typeface="Arial"/>
-                <a:cs typeface="Arial"/>
-              </a:rPr>
-              <a:t>8 of 11 safety ratings increased; trust responses were more mixed.</a:t>
-            </a:r>
-          </a:p>
-        </p:txBody>
-      </p:sp>
-      <p:sp>
-        <p:nvSpPr>
-          <p:cNvPr id="6" name="Matched response sets, not a confirmed count of distinct peo">
-            <a:extLst xmlns:a="http://schemas.openxmlformats.org/drawingml/2006/main">
-              <a:ext uri="{FF2B5EF4-FFF2-40B4-BE49-F238E27FC236}">
-                <a16:creationId xmlns:a16="http://schemas.microsoft.com/office/drawing/2014/main" id="{DD433E31-694F-46D7-9C78-BABB08EABEFF}"/>
-              </a:ext>
-            </a:extLst>
-          </p:cNvPr>
-          <p:cNvSpPr>
-            <a:spLocks xmlns:a="http://schemas.openxmlformats.org/drawingml/2006/main" noGrp="1"/>
-          </p:cNvSpPr>
-          <p:nvPr/>
-        </p:nvSpPr>
-        <p:spPr>
-          <a:xfrm xmlns:a="http://schemas.openxmlformats.org/drawingml/2006/main">
-            <a:off x="571500" y="5286375"/>
-            <a:ext cx="10763250" cy="628650"/>
-          </a:xfrm>
-          <a:prstGeom xmlns:a="http://schemas.openxmlformats.org/drawingml/2006/main" prst="rect">
-            <a:avLst/>
-          </a:prstGeom>
-          <a:noFill xmlns:a="http://schemas.openxmlformats.org/drawingml/2006/main"/>
-          <a:ln xmlns:a="http://schemas.openxmlformats.org/drawingml/2006/main" w="0">
-            <a:noFill/>
-          </a:ln>
-        </p:spPr>
-        <p:txBody>
-          <a:bodyPr xmlns:a="http://schemas.openxmlformats.org/drawingml/2006/main">
-            <a:noAutofit/>
-          </a:bodyPr>
-          <a:lstStyle xmlns:a="http://schemas.openxmlformats.org/drawingml/2006/main"/>
-          <a:p xmlns:a="http://schemas.openxmlformats.org/drawingml/2006/main">
-            <a:pPr>
-              <a:defRPr sz="1800" b="0">
-                <a:solidFill>
-                  <a:srgbClr val="536B79"/>
-                </a:solidFill>
-                <a:latin typeface="Arial"/>
-                <a:ea typeface="Arial"/>
-                <a:cs typeface="Arial"/>
-              </a:defRPr>
-            </a:pPr>
-            <a:r>
-              <a:rPr sz="1800" b="0">
-                <a:solidFill>
-                  <a:srgbClr val="536B79"/>
-                </a:solidFill>
-                <a:latin typeface="Arial"/>
-                <a:ea typeface="Arial"/>
-                <a:cs typeface="Arial"/>
-              </a:rPr>
-              <a:t>Matched response sets, not a confirmed count of distinct people.</a:t>
-            </a:r>
-          </a:p>
-          <a:p xmlns:a="http://schemas.openxmlformats.org/drawingml/2006/main">
-            <a:pPr>
-              <a:defRPr sz="1800" b="0">
-                <a:solidFill>
-                  <a:srgbClr val="536B79"/>
-                </a:solidFill>
-                <a:latin typeface="Arial"/>
-                <a:ea typeface="Arial"/>
-                <a:cs typeface="Arial"/>
-              </a:defRPr>
-            </a:pPr>
-            <a:r>
-              <a:rPr sz="1800" b="0">
-                <a:solidFill>
-                  <a:srgbClr val="536B79"/>
-                </a:solidFill>
-                <a:latin typeface="Arial"/>
-                <a:ea typeface="Arial"/>
-                <a:cs typeface="Arial"/>
-              </a:rPr>
-              <a:t>Expected and experienced ratings do not identify a controller effect.</a:t>
             </a:r>
           </a:p>
         </p:txBody>

</xml_diff>

<commit_message>
Deck v4 trimmed to 14 slides for the 10-minute limit; guide timings updated (#8)
Co-authored-by: Claude Opus 5.5 <noreply@anthropic.com>
</commit_message>
<xml_diff>
--- a/presentation/FYP-assessment-presentation-v4.pptx
+++ b/presentation/FYP-assessment-presentation-v4.pptx
@@ -11,20 +11,16 @@
     <p:sldId xmlns:r="http://schemas.openxmlformats.org/officeDocument/2006/relationships" id="256" r:id="Ref2a4bf3706c4352"/>
     <p:sldId xmlns:r="http://schemas.openxmlformats.org/officeDocument/2006/relationships" id="257" r:id="Re6cd846b0b584733"/>
     <p:sldId xmlns:r="http://schemas.openxmlformats.org/officeDocument/2006/relationships" id="258" r:id="R731e077aa12e4340"/>
-    <p:sldId xmlns:ns0="http://schemas.openxmlformats.org/officeDocument/2006/relationships" id="268" ns0:id="rId19"/>
     <p:sldId xmlns:ns0="http://schemas.openxmlformats.org/officeDocument/2006/relationships" id="269" ns0:id="rId20"/>
     <p:sldId xmlns:r="http://schemas.openxmlformats.org/officeDocument/2006/relationships" id="259" r:id="Rf6250f778e214466"/>
     <p:sldId xmlns:r="http://schemas.openxmlformats.org/officeDocument/2006/relationships" id="260" r:id="R427b3517ce644e16"/>
-    <p:sldId xmlns:r="http://schemas.openxmlformats.org/officeDocument/2006/relationships" id="261" r:id="R1e9d0d0c5f744df0"/>
-    <p:sldId xmlns:ns0="http://schemas.openxmlformats.org/officeDocument/2006/relationships" id="272" ns0:id="rId23"/>
     <p:sldId xmlns:ns0="http://schemas.openxmlformats.org/officeDocument/2006/relationships" id="273" ns0:id="rId24"/>
     <p:sldId xmlns:r="http://schemas.openxmlformats.org/officeDocument/2006/relationships" id="262" r:id="R67d8387fc811496e"/>
     <p:sldId xmlns:r="http://schemas.openxmlformats.org/officeDocument/2006/relationships" id="263" r:id="R65dff22df0704d17"/>
-    <p:sldId xmlns:ns0="http://schemas.openxmlformats.org/officeDocument/2006/relationships" id="270" ns0:id="rId21"/>
-    <p:sldId xmlns:ns0="http://schemas.openxmlformats.org/officeDocument/2006/relationships" id="271" ns0:id="rId22"/>
     <p:sldId xmlns:r="http://schemas.openxmlformats.org/officeDocument/2006/relationships" id="264" r:id="R5788775e71334f66"/>
     <p:sldId xmlns:r="http://schemas.openxmlformats.org/officeDocument/2006/relationships" id="265" r:id="Re14ba9e474d542fd"/>
     <p:sldId xmlns:r="http://schemas.openxmlformats.org/officeDocument/2006/relationships" id="266" r:id="R7735b38b9c204791"/>
+    <p:sldId xmlns:ns0="http://schemas.openxmlformats.org/officeDocument/2006/relationships" id="271" ns0:id="rId22"/>
     <p:sldId xmlns:r="http://schemas.openxmlformats.org/officeDocument/2006/relationships" id="267" r:id="R997e45ef8e6d46c1"/>
   </p:sldIdLst>
   <p:sldSz cx="12192000" cy="6858000"/>
@@ -1100,94 +1096,6 @@
           <a:p xmlns:a="http://schemas.openxmlformats.org/drawingml/2006/main">
             <a:r>
               <a:t>Sources: Paper Experimental Method; data/analysis/recovered/results.json; data/analysis/questionnaires/results.json. Fourteen trials, 65,697 telemetry rows, 31 block responses, eleven matched intake/end sets.</a:t>
-            </a:r>
-          </a:p>
-        </p:txBody>
-      </p:sp>
-      <p:sp>
-        <p:nvSpPr>
-          <p:cNvPr id="4" name="Slide Number Placeholder 3"/>
-          <p:cNvSpPr>
-            <a:spLocks xmlns:a="http://schemas.openxmlformats.org/drawingml/2006/main" noGrp="1"/>
-          </p:cNvSpPr>
-          <p:nvPr>
-            <p:ph type="sldNum" idx="5"/>
-          </p:nvPr>
-        </p:nvSpPr>
-        <p:spPr/>
-        <p:txBody>
-          <a:bodyPr xmlns:a="http://schemas.openxmlformats.org/drawingml/2006/main"/>
-          <a:lstStyle xmlns:a="http://schemas.openxmlformats.org/drawingml/2006/main"/>
-          <a:p xmlns:a="http://schemas.openxmlformats.org/drawingml/2006/main"/>
-        </p:txBody>
-      </p:sp>
-    </p:spTree>
-  </p:cSld>
-  <p:clrMapOvr>
-    <a:masterClrMapping xmlns:a="http://schemas.openxmlformats.org/drawingml/2006/main"/>
-  </p:clrMapOvr>
-</p:notes>
-</file>
-
-<file path=ppt/notesSlides/notesSlide6.xml><?xml version="1.0" encoding="utf-8"?>
-<p:notes xmlns:p="http://schemas.openxmlformats.org/presentationml/2006/main">
-  <p:cSld>
-    <p:spTree>
-      <p:nvGrpSpPr>
-        <p:cNvPr id="1" name=""/>
-        <p:cNvGrpSpPr/>
-        <p:nvPr/>
-      </p:nvGrpSpPr>
-      <p:grpSpPr>
-        <a:xfrm xmlns:a="http://schemas.openxmlformats.org/drawingml/2006/main"/>
-      </p:grpSpPr>
-      <p:sp>
-        <p:nvSpPr>
-          <p:cNvPr id="2" name="Slide Image Placeholder 1"/>
-          <p:cNvSpPr>
-            <a:spLocks xmlns:a="http://schemas.openxmlformats.org/drawingml/2006/main" noGrp="1"/>
-          </p:cNvSpPr>
-          <p:nvPr>
-            <p:ph type="sldImg" idx="0"/>
-          </p:nvPr>
-        </p:nvSpPr>
-        <p:spPr/>
-      </p:sp>
-      <p:sp>
-        <p:nvSpPr>
-          <p:cNvPr id="3" name="Notes Placeholder 2"/>
-          <p:cNvSpPr>
-            <a:spLocks xmlns:a="http://schemas.openxmlformats.org/drawingml/2006/main" noGrp="1"/>
-          </p:cNvSpPr>
-          <p:nvPr>
-            <p:ph type="body" idx="1"/>
-          </p:nvPr>
-        </p:nvSpPr>
-        <p:spPr/>
-        <p:txBody>
-          <a:bodyPr xmlns:a="http://schemas.openxmlformats.org/drawingml/2006/main"/>
-          <a:lstStyle xmlns:a="http://schemas.openxmlformats.org/drawingml/2006/main"/>
-          <a:p xmlns:a="http://schemas.openxmlformats.org/drawingml/2006/main">
-            <a:r>
-              <a:t>Zenan | 45 seconds</a:t>
-            </a:r>
-          </a:p>
-          <a:p xmlns:a="http://schemas.openxmlformats.org/drawingml/2006/main"/>
-          <a:p xmlns:a="http://schemas.openxmlformats.org/drawingml/2006/main">
-            <a:r>
-              <a:t>The model assigns each observation to one of three task phases. For the version that can operate online using only present and past observations, accuracy was 79.4 percent. Giving the three phases equal weight lowers the score to 72.5 percent, so the overall figure hides weaker performance outside the dominant working phase. Validation held out each of three development operators in turn across thirty-two accepted trials.</a:t>
-            </a:r>
-          </a:p>
-          <a:p xmlns:a="http://schemas.openxmlformats.org/drawingml/2006/main"/>
-          <a:p xmlns:a="http://schemas.openxmlformats.org/drawingml/2006/main">
-            <a:r>
-              <a:t>The cost of learned context showed up in the trials. The predictive controller issued between 15 and 73 protective-stop onsets per trial, against 6 to 9 for the fixed and reactive controllers, but only two or three per trial lasted a second or more. The rest were sub-half-second toggles near a threshold. It did not hold the robot stopped for longer; it switched the request far more often. That is a design defect we can fix with hysteresis or a minimum stop dwell on the learned inputs, without touching the deterministic envelope.</a:t>
-            </a:r>
-          </a:p>
-          <a:p xmlns:a="http://schemas.openxmlformats.org/drawingml/2006/main"/>
-          <a:p xmlns:a="http://schemas.openxmlformats.org/drawingml/2006/main">
-            <a:r>
-              <a:t>Sources: data/models/pilot_hmm.json validation; paper Table III stop-onset column and Section VII-A.</a:t>
             </a:r>
           </a:p>
         </p:txBody>
@@ -7267,251 +7175,6 @@
 </a:theme>
 </file>
 
-<file path=ppt/slides/charts/chart1.xml><?xml version="1.0" encoding="utf-8"?>
-<c:chartSpace xmlns:c="http://schemas.openxmlformats.org/drawingml/2006/chart" xmlns:r="http://schemas.openxmlformats.org/officeDocument/2006/relationships">
-  <c:lang val="en-US"/>
-  <c:chart>
-    <c:plotArea>
-      <c:barChart>
-        <c:barDir val="col"/>
-        <c:grouping val="clustered"/>
-        <c:varyColors val="0"/>
-        <c:ser>
-          <c:idx val="0"/>
-          <c:order val="0"/>
-          <c:tx>
-            <c:v>Causal recognition accuracy</c:v>
-          </c:tx>
-          <c:spPr>
-            <a:solidFill xmlns:a="http://schemas.openxmlformats.org/drawingml/2006/main">
-              <a:srgbClr val="006DAE"/>
-            </a:solidFill>
-          </c:spPr>
-          <c:dLbls>
-            <c:dLbl>
-              <c:idx val="0"/>
-              <c:tx>
-                <c:rich>
-                  <a:bodyPr xmlns:a="http://schemas.openxmlformats.org/drawingml/2006/main"/>
-                  <a:lstStyle xmlns:a="http://schemas.openxmlformats.org/drawingml/2006/main"/>
-                  <a:p xmlns:a="http://schemas.openxmlformats.org/drawingml/2006/main">
-                    <a:r>
-                      <a:rPr sz="2100">
-                        <a:latin typeface="Arial"/>
-                        <a:ea typeface="Arial"/>
-                        <a:cs typeface="Arial"/>
-                      </a:rPr>
-                      <a:t>79.4%</a:t>
-                    </a:r>
-                  </a:p>
-                </c:rich>
-              </c:tx>
-              <c:txPr>
-                <a:bodyPr xmlns:a="http://schemas.openxmlformats.org/drawingml/2006/main" anchorCtr="1"/>
-                <a:lstStyle xmlns:a="http://schemas.openxmlformats.org/drawingml/2006/main"/>
-                <a:p xmlns:a="http://schemas.openxmlformats.org/drawingml/2006/main">
-                  <a:pPr>
-                    <a:defRPr sz="2100">
-                      <a:latin typeface="Arial"/>
-                      <a:ea typeface="Arial"/>
-                      <a:cs typeface="Arial"/>
-                    </a:defRPr>
-                  </a:pPr>
-                </a:p>
-              </c:txPr>
-              <c:showLegendKey val="0"/>
-              <c:showVal val="0"/>
-              <c:showCatName val="0"/>
-              <c:showSerName val="0"/>
-              <c:showPercent val="0"/>
-              <c:showBubbleSize val="0"/>
-            </c:dLbl>
-            <c:dLbl>
-              <c:idx val="1"/>
-              <c:tx>
-                <c:rich>
-                  <a:bodyPr xmlns:a="http://schemas.openxmlformats.org/drawingml/2006/main"/>
-                  <a:lstStyle xmlns:a="http://schemas.openxmlformats.org/drawingml/2006/main"/>
-                  <a:p xmlns:a="http://schemas.openxmlformats.org/drawingml/2006/main">
-                    <a:r>
-                      <a:rPr sz="2100">
-                        <a:latin typeface="Arial"/>
-                        <a:ea typeface="Arial"/>
-                        <a:cs typeface="Arial"/>
-                      </a:rPr>
-                      <a:t>72.5%</a:t>
-                    </a:r>
-                  </a:p>
-                </c:rich>
-              </c:tx>
-              <c:txPr>
-                <a:bodyPr xmlns:a="http://schemas.openxmlformats.org/drawingml/2006/main" anchorCtr="1"/>
-                <a:lstStyle xmlns:a="http://schemas.openxmlformats.org/drawingml/2006/main"/>
-                <a:p xmlns:a="http://schemas.openxmlformats.org/drawingml/2006/main">
-                  <a:pPr>
-                    <a:defRPr sz="2100">
-                      <a:latin typeface="Arial"/>
-                      <a:ea typeface="Arial"/>
-                      <a:cs typeface="Arial"/>
-                    </a:defRPr>
-                  </a:pPr>
-                </a:p>
-              </c:txPr>
-              <c:showLegendKey val="0"/>
-              <c:showVal val="0"/>
-              <c:showCatName val="0"/>
-              <c:showSerName val="0"/>
-              <c:showPercent val="0"/>
-              <c:showBubbleSize val="0"/>
-            </c:dLbl>
-          </c:dLbls>
-          <c:cat>
-            <c:strRef>
-              <c:f>'Chart Data'!$A$2:$A$3</c:f>
-              <c:strCache>
-                <c:ptCount val="2"/>
-                <c:pt idx="0">
-                  <c:v>Overall accuracy</c:v>
-                </c:pt>
-                <c:pt idx="1">
-                  <c:v>Equal weight per phase</c:v>
-                </c:pt>
-              </c:strCache>
-            </c:strRef>
-          </c:cat>
-          <c:val>
-            <c:numRef>
-              <c:f>'Chart Data'!$B$2:$B$3</c:f>
-              <c:numCache>
-                <c:formatCode>0.0%</c:formatCode>
-                <c:ptCount val="2"/>
-                <c:pt idx="0">
-                  <c:v>0.7937</c:v>
-                </c:pt>
-                <c:pt idx="1">
-                  <c:v>0.725</c:v>
-                </c:pt>
-              </c:numCache>
-            </c:numRef>
-          </c:val>
-        </c:ser>
-        <c:dLbls>
-          <c:txPr>
-            <a:bodyPr xmlns:a="http://schemas.openxmlformats.org/drawingml/2006/main" anchorCtr="1"/>
-            <a:lstStyle xmlns:a="http://schemas.openxmlformats.org/drawingml/2006/main"/>
-            <a:p xmlns:a="http://schemas.openxmlformats.org/drawingml/2006/main">
-              <a:pPr>
-                <a:defRPr sz="2100">
-                  <a:latin typeface="Arial"/>
-                  <a:ea typeface="Arial"/>
-                  <a:cs typeface="Arial"/>
-                </a:defRPr>
-              </a:pPr>
-            </a:p>
-          </c:txPr>
-          <c:dLblPos val="outEnd"/>
-          <c:showLegendKey val="0"/>
-          <c:showVal val="1"/>
-          <c:showCatName val="0"/>
-          <c:showSerName val="0"/>
-          <c:showPercent val="0"/>
-          <c:showBubbleSize val="0"/>
-          <c:showLeaderLines val="0"/>
-        </c:dLbls>
-        <c:gapWidth val="110"/>
-        <c:axId val="48650112"/>
-        <c:axId val="48672768"/>
-      </c:barChart>
-      <c:catAx>
-        <c:axId val="48650112"/>
-        <c:scaling>
-          <c:orientation val="minMax"/>
-        </c:scaling>
-        <c:delete val="0"/>
-        <c:axPos val="b"/>
-        <c:numFmt formatCode="General"/>
-        <c:majorTickMark val="none"/>
-        <c:minorTickMark val="none"/>
-        <c:spPr>
-          <a:ln xmlns:a="http://schemas.openxmlformats.org/drawingml/2006/main" w="9525">
-            <a:solidFill>
-              <a:srgbClr val="D4D4D4"/>
-            </a:solidFill>
-            <a:prstDash val="solid"/>
-          </a:ln>
-        </c:spPr>
-        <c:txPr>
-          <a:bodyPr xmlns:a="http://schemas.openxmlformats.org/drawingml/2006/main" anchorCtr="1"/>
-          <a:lstStyle xmlns:a="http://schemas.openxmlformats.org/drawingml/2006/main"/>
-          <a:p xmlns:a="http://schemas.openxmlformats.org/drawingml/2006/main">
-            <a:pPr>
-              <a:defRPr sz="1800">
-                <a:solidFill>
-                  <a:srgbClr val="666666"/>
-                </a:solidFill>
-                <a:latin typeface="Arial"/>
-                <a:ea typeface="Arial"/>
-                <a:cs typeface="Arial"/>
-              </a:defRPr>
-            </a:pPr>
-          </a:p>
-        </c:txPr>
-        <c:crossAx val="48672768"/>
-      </c:catAx>
-      <c:valAx>
-        <c:axId val="48672768"/>
-        <c:scaling>
-          <c:orientation val="minMax"/>
-          <c:max val="1"/>
-          <c:min val="0"/>
-        </c:scaling>
-        <c:delete val="0"/>
-        <c:axPos val="l"/>
-        <c:numFmt formatCode="0%"/>
-        <c:majorTickMark val="none"/>
-        <c:minorTickMark val="none"/>
-        <c:spPr>
-          <a:ln xmlns:a="http://schemas.openxmlformats.org/drawingml/2006/main" w="9525">
-            <a:solidFill>
-              <a:srgbClr val="D4D4D4"/>
-            </a:solidFill>
-            <a:prstDash val="solid"/>
-          </a:ln>
-        </c:spPr>
-        <c:txPr>
-          <a:bodyPr xmlns:a="http://schemas.openxmlformats.org/drawingml/2006/main" anchorCtr="1"/>
-          <a:lstStyle xmlns:a="http://schemas.openxmlformats.org/drawingml/2006/main"/>
-          <a:p xmlns:a="http://schemas.openxmlformats.org/drawingml/2006/main">
-            <a:pPr>
-              <a:defRPr sz="1650">
-                <a:solidFill>
-                  <a:srgbClr val="666666"/>
-                </a:solidFill>
-                <a:latin typeface="Arial"/>
-                <a:ea typeface="Arial"/>
-                <a:cs typeface="Arial"/>
-              </a:defRPr>
-            </a:pPr>
-          </a:p>
-        </c:txPr>
-        <c:crossAx val="48650112"/>
-        <c:crossBetween val="between"/>
-        <c:majorUnit val="0.25"/>
-      </c:valAx>
-    </c:plotArea>
-    <c:plotVisOnly val="1"/>
-  </c:chart>
-  <c:spPr>
-    <a:solidFill xmlns:a="http://schemas.openxmlformats.org/drawingml/2006/main">
-      <a:srgbClr val="FFFFFF"/>
-    </a:solidFill>
-  </c:spPr>
-  <c:externalData r:id="rIdChartSnapshot1">
-    <c:autoUpdate val="0"/>
-  </c:externalData>
-</c:chartSpace>
-</file>
-
 <file path=ppt/slides/charts/chart2.xml><?xml version="1.0" encoding="utf-8"?>
 <c:chartSpace xmlns:c="http://schemas.openxmlformats.org/drawingml/2006/chart" xmlns:r="http://schemas.openxmlformats.org/officeDocument/2006/relationships">
   <c:lang val="en-US"/>
@@ -8393,6 +8056,266 @@
 </file>
 
 <file path=ppt/slides/slide10.xml><?xml version="1.0" encoding="utf-8"?>
+<p:sld xmlns:a="http://schemas.openxmlformats.org/drawingml/2006/main" xmlns:p="http://schemas.openxmlformats.org/presentationml/2006/main" xmlns:r="http://schemas.openxmlformats.org/officeDocument/2006/relationships">
+  <p:cSld>
+    <p:spTree>
+      <p:nvGrpSpPr>
+        <p:cNvPr id="1" name=""/>
+        <p:cNvGrpSpPr/>
+        <p:nvPr/>
+      </p:nvGrpSpPr>
+      <p:grpSpPr/>
+      <p:sp>
+        <p:nvSpPr>
+          <p:cNvPr id="7" name="The task and laboratory prototype">
+            <a:extLst>
+              <a:ext uri="{FF2B5EF4-FFF2-40B4-BE49-F238E27FC236}">
+                <a16:creationId xmlns:a16="http://schemas.microsoft.com/office/drawing/2014/main" id="{DA806EAB-9D1F-4D99-9E8F-92CEBF025533}"/>
+              </a:ext>
+            </a:extLst>
+          </p:cNvPr>
+          <p:cNvSpPr>
+            <a:spLocks noGrp="1"/>
+          </p:cNvSpPr>
+          <p:nvPr/>
+        </p:nvSpPr>
+        <p:spPr>
+          <a:xfrm>
+            <a:off x="438150" y="381000"/>
+            <a:ext cx="11049000" cy="809625"/>
+          </a:xfrm>
+          <a:prstGeom prst="rect">
+            <a:avLst/>
+          </a:prstGeom>
+          <a:noFill/>
+          <a:ln w="0">
+            <a:noFill/>
+          </a:ln>
+        </p:spPr>
+        <p:txBody>
+          <a:bodyPr>
+            <a:noAutofit/>
+          </a:bodyPr>
+          <a:lstStyle/>
+          <a:p>
+            <a:pPr>
+              <a:defRPr sz="3300" b="1">
+                <a:solidFill>
+                  <a:srgbClr val="172D3D"/>
+                </a:solidFill>
+                <a:latin typeface="Arial"/>
+                <a:ea typeface="Arial"/>
+                <a:cs typeface="Arial"/>
+              </a:defRPr>
+            </a:pPr>
+            <a:r>
+              <a:rPr sz="3300" b="1">
+                <a:solidFill>
+                  <a:srgbClr val="172D3D"/>
+                </a:solidFill>
+                <a:latin typeface="Arial"/>
+                <a:ea typeface="Arial"/>
+                <a:cs typeface="Arial"/>
+              </a:rPr>
+              <a:t>Our trained task-phase model</a:t>
+            </a:r>
+          </a:p>
+        </p:txBody>
+      </p:sp>
+      <p:sp>
+        <p:nvSpPr>
+          <p:cNvPr id="2" name="03">
+            <a:extLst>
+              <a:ext uri="{FF2B5EF4-FFF2-40B4-BE49-F238E27FC236}">
+                <a16:creationId xmlns:a16="http://schemas.microsoft.com/office/drawing/2014/main" id="{CFB5FF92-5DE5-431F-B644-183C6C08DB02}"/>
+              </a:ext>
+            </a:extLst>
+          </p:cNvPr>
+          <p:cNvSpPr>
+            <a:spLocks noGrp="1"/>
+          </p:cNvSpPr>
+          <p:nvPr/>
+        </p:nvSpPr>
+        <p:spPr>
+          <a:xfrm>
+            <a:off x="466725" y="6362700"/>
+            <a:ext cx="476250" cy="228600"/>
+          </a:xfrm>
+          <a:prstGeom prst="rect">
+            <a:avLst/>
+          </a:prstGeom>
+          <a:noFill/>
+          <a:ln w="0">
+            <a:noFill/>
+          </a:ln>
+        </p:spPr>
+        <p:txBody>
+          <a:bodyPr>
+            <a:noAutofit/>
+          </a:bodyPr>
+          <a:lstStyle/>
+          <a:p>
+            <a:pPr>
+              <a:defRPr sz="1200" b="0">
+                <a:solidFill>
+                  <a:srgbClr val="536B79"/>
+                </a:solidFill>
+                <a:latin typeface="Arial"/>
+                <a:ea typeface="Arial"/>
+                <a:cs typeface="Arial"/>
+              </a:defRPr>
+            </a:pPr>
+            <a:r>
+              <a:rPr sz="1200" b="0">
+                <a:solidFill>
+                  <a:srgbClr val="536B79"/>
+                </a:solidFill>
+                <a:latin typeface="Arial"/>
+                <a:ea typeface="Arial"/>
+                <a:cs typeface="Arial"/>
+              </a:rPr>
+              <a:t>07</a:t>
+            </a:r>
+          </a:p>
+        </p:txBody>
+      </p:sp>
+      <p:pic>
+        <p:nvPicPr>
+          <p:cNvPr id="8" name="Picture 7" descr="held-out-trial.png"/>
+          <p:cNvPicPr>
+            <a:picLocks noChangeAspect="1"/>
+          </p:cNvPicPr>
+          <p:nvPr/>
+        </p:nvPicPr>
+        <p:blipFill>
+          <a:blip r:embed="rId2"/>
+          <a:stretch>
+            <a:fillRect/>
+          </a:stretch>
+        </p:blipFill>
+        <p:spPr>
+          <a:xfrm>
+            <a:off x="571500" y="1200000"/>
+            <a:ext cx="7400000" cy="2825455"/>
+          </a:xfrm>
+          <a:prstGeom prst="rect">
+            <a:avLst/>
+          </a:prstGeom>
+        </p:spPr>
+      </p:pic>
+      <p:pic>
+        <p:nvPicPr>
+          <p:cNvPr id="9" name="Picture 8" descr="confusion.png"/>
+          <p:cNvPicPr>
+            <a:picLocks noChangeAspect="1"/>
+          </p:cNvPicPr>
+          <p:nvPr/>
+        </p:nvPicPr>
+        <p:blipFill>
+          <a:blip r:embed="rId3"/>
+          <a:stretch>
+            <a:fillRect/>
+          </a:stretch>
+        </p:blipFill>
+        <p:spPr>
+          <a:xfrm>
+            <a:off x="8150000" y="1150000"/>
+            <a:ext cx="3616667" cy="3100000"/>
+          </a:xfrm>
+          <a:prstGeom prst="rect">
+            <a:avLst/>
+          </a:prstGeom>
+        </p:spPr>
+      </p:pic>
+      <p:sp>
+        <p:nvSpPr>
+          <p:cNvPr id="6" name="Schematic of the procedure; scale and motion are illustrativ">
+            <a:extLst>
+              <a:ext uri="{FF2B5EF4-FFF2-40B4-BE49-F238E27FC236}">
+                <a16:creationId xmlns:a16="http://schemas.microsoft.com/office/drawing/2014/main" id="{2BCF01A8-A812-4BB7-ADB0-153753A61F5C}"/>
+              </a:ext>
+            </a:extLst>
+          </p:cNvPr>
+          <p:cNvSpPr>
+            <a:spLocks noGrp="1"/>
+          </p:cNvSpPr>
+          <p:nvPr/>
+        </p:nvSpPr>
+        <p:spPr>
+          <a:xfrm>
+            <a:off x="571500" y="4500000"/>
+            <a:ext cx="10950000" cy="1500000"/>
+          </a:xfrm>
+          <a:prstGeom prst="rect">
+            <a:avLst/>
+          </a:prstGeom>
+          <a:noFill/>
+          <a:ln w="0">
+            <a:noFill/>
+          </a:ln>
+        </p:spPr>
+        <p:txBody>
+          <a:bodyPr>
+            <a:noAutofit/>
+          </a:bodyPr>
+          <a:lstStyle/>
+          <a:p>
+            <a:pPr>
+              <a:defRPr sz="1650" b="0">
+                <a:solidFill>
+                  <a:srgbClr val="536B79"/>
+                </a:solidFill>
+                <a:latin typeface="Arial"/>
+                <a:ea typeface="Arial"/>
+                <a:cs typeface="Arial"/>
+              </a:defRPr>
+            </a:pPr>
+            <a:r>
+              <a:rPr sz="1400" b="0">
+                <a:solidFill>
+                  <a:srgbClr val="536B79"/>
+                </a:solidFill>
+                <a:latin typeface="Arial"/>
+                <a:ea typeface="Arial"/>
+                <a:cs typeface="Arial"/>
+              </a:rPr>
+              <a:t>Trained by us on 32 labelled trials from 3 operators; tested on a person it never saw (left: live estimate vs actual).</a:t>
+            </a:r>
+          </a:p>
+          <a:p>
+            <a:pPr>
+              <a:defRPr sz="1650" b="0">
+                <a:solidFill>
+                  <a:srgbClr val="536B79"/>
+                </a:solidFill>
+                <a:latin typeface="Arial"/>
+                <a:ea typeface="Arial"/>
+                <a:cs typeface="Arial"/>
+              </a:defRPr>
+            </a:pPr>
+            <a:r>
+              <a:rPr sz="1400" b="0">
+                <a:solidFill>
+                  <a:srgbClr val="536B79"/>
+                </a:solidFill>
+                <a:latin typeface="Arial"/>
+                <a:ea typeface="Arial"/>
+                <a:cs typeface="Arial"/>
+              </a:rPr>
+              <a:t>Right: it recognises working reliably and hesitates mainly at phase changes, good enough to drive the controller in real time.</a:t>
+            </a:r>
+          </a:p>
+        </p:txBody>
+      </p:sp>
+    </p:spTree>
+  </p:cSld>
+  <p:clrMapOvr>
+    <a:masterClrMapping/>
+  </p:clrMapOvr>
+</p:sld>
+</file>
+
+<file path=ppt/slides/slide11.xml><?xml version="1.0" encoding="utf-8"?>
 <p:sld xmlns:p="http://schemas.openxmlformats.org/presentationml/2006/main">
   <p:cSld>
     <p:spTree>
@@ -8406,6 +8329,352 @@
       </p:grpSpPr>
       <p:sp>
         <p:nvSpPr>
+          <p:cNvPr id="7" name="Reported safety generally exceeded expectations">
+            <a:extLst xmlns:a="http://schemas.openxmlformats.org/drawingml/2006/main">
+              <a:ext uri="{FF2B5EF4-FFF2-40B4-BE49-F238E27FC236}">
+                <a16:creationId xmlns:a16="http://schemas.microsoft.com/office/drawing/2014/main" id="{5814CDDA-1AB1-4D61-8FAF-E713491B3C34}"/>
+              </a:ext>
+            </a:extLst>
+          </p:cNvPr>
+          <p:cNvSpPr>
+            <a:spLocks xmlns:a="http://schemas.openxmlformats.org/drawingml/2006/main" noGrp="1"/>
+          </p:cNvSpPr>
+          <p:nvPr/>
+        </p:nvSpPr>
+        <p:spPr>
+          <a:xfrm xmlns:a="http://schemas.openxmlformats.org/drawingml/2006/main">
+            <a:off x="438150" y="381000"/>
+            <a:ext cx="11049000" cy="809625"/>
+          </a:xfrm>
+          <a:prstGeom xmlns:a="http://schemas.openxmlformats.org/drawingml/2006/main" prst="rect">
+            <a:avLst/>
+          </a:prstGeom>
+          <a:noFill xmlns:a="http://schemas.openxmlformats.org/drawingml/2006/main"/>
+          <a:ln xmlns:a="http://schemas.openxmlformats.org/drawingml/2006/main" w="0">
+            <a:noFill/>
+          </a:ln>
+        </p:spPr>
+        <p:txBody>
+          <a:bodyPr xmlns:a="http://schemas.openxmlformats.org/drawingml/2006/main">
+            <a:noAutofit/>
+          </a:bodyPr>
+          <a:lstStyle xmlns:a="http://schemas.openxmlformats.org/drawingml/2006/main"/>
+          <a:p xmlns:a="http://schemas.openxmlformats.org/drawingml/2006/main">
+            <a:pPr>
+              <a:defRPr sz="3300" b="1">
+                <a:solidFill>
+                  <a:srgbClr val="172D3D"/>
+                </a:solidFill>
+                <a:latin typeface="Arial"/>
+                <a:ea typeface="Arial"/>
+                <a:cs typeface="Arial"/>
+              </a:defRPr>
+            </a:pPr>
+            <a:r>
+              <a:rPr sz="3300" b="1">
+                <a:solidFill>
+                  <a:srgbClr val="172D3D"/>
+                </a:solidFill>
+                <a:latin typeface="Arial"/>
+                <a:ea typeface="Arial"/>
+                <a:cs typeface="Arial"/>
+              </a:rPr>
+              <a:t>Reported safety generally exceeded expectations</a:t>
+            </a:r>
+          </a:p>
+        </p:txBody>
+      </p:sp>
+      <p:sp>
+        <p:nvSpPr>
+          <p:cNvPr id="2" name="07">
+            <a:extLst xmlns:a="http://schemas.openxmlformats.org/drawingml/2006/main">
+              <a:ext uri="{FF2B5EF4-FFF2-40B4-BE49-F238E27FC236}">
+                <a16:creationId xmlns:a16="http://schemas.microsoft.com/office/drawing/2014/main" id="{C4C99FBE-1199-451A-A032-F316AA2D1434}"/>
+              </a:ext>
+            </a:extLst>
+          </p:cNvPr>
+          <p:cNvSpPr>
+            <a:spLocks xmlns:a="http://schemas.openxmlformats.org/drawingml/2006/main" noGrp="1"/>
+          </p:cNvSpPr>
+          <p:nvPr/>
+        </p:nvSpPr>
+        <p:spPr>
+          <a:xfrm xmlns:a="http://schemas.openxmlformats.org/drawingml/2006/main">
+            <a:off x="466725" y="6362700"/>
+            <a:ext cx="476250" cy="228600"/>
+          </a:xfrm>
+          <a:prstGeom xmlns:a="http://schemas.openxmlformats.org/drawingml/2006/main" prst="rect">
+            <a:avLst/>
+          </a:prstGeom>
+          <a:noFill xmlns:a="http://schemas.openxmlformats.org/drawingml/2006/main"/>
+          <a:ln xmlns:a="http://schemas.openxmlformats.org/drawingml/2006/main" w="0">
+            <a:noFill/>
+          </a:ln>
+        </p:spPr>
+        <p:txBody>
+          <a:bodyPr xmlns:a="http://schemas.openxmlformats.org/drawingml/2006/main">
+            <a:noAutofit/>
+          </a:bodyPr>
+          <a:lstStyle xmlns:a="http://schemas.openxmlformats.org/drawingml/2006/main"/>
+          <a:p xmlns:a="http://schemas.openxmlformats.org/drawingml/2006/main">
+            <a:pPr>
+              <a:defRPr sz="1200" b="0">
+                <a:solidFill>
+                  <a:srgbClr val="536B79"/>
+                </a:solidFill>
+                <a:latin typeface="Arial"/>
+                <a:ea typeface="Arial"/>
+                <a:cs typeface="Arial"/>
+              </a:defRPr>
+            </a:pPr>
+            <a:r>
+              <a:rPr sz="1200" b="0">
+                <a:solidFill>
+                  <a:srgbClr val="536B79"/>
+                </a:solidFill>
+                <a:latin typeface="Arial"/>
+                <a:ea typeface="Arial"/>
+                <a:cs typeface="Arial"/>
+              </a:rPr>
+              <a:t>08</a:t>
+            </a:r>
+          </a:p>
+        </p:txBody>
+      </p:sp>
+      <p:sp>
+        <p:nvSpPr>
+          <p:cNvPr id="3" name="Changes between intake and end ratings">
+            <a:extLst xmlns:a="http://schemas.openxmlformats.org/drawingml/2006/main">
+              <a:ext uri="{FF2B5EF4-FFF2-40B4-BE49-F238E27FC236}">
+                <a16:creationId xmlns:a16="http://schemas.microsoft.com/office/drawing/2014/main" id="{2DFEBB9F-3B8E-435B-BEE5-DF4C4122DD86}"/>
+              </a:ext>
+            </a:extLst>
+          </p:cNvPr>
+          <p:cNvSpPr>
+            <a:spLocks xmlns:a="http://schemas.openxmlformats.org/drawingml/2006/main" noGrp="1"/>
+          </p:cNvSpPr>
+          <p:nvPr/>
+        </p:nvSpPr>
+        <p:spPr>
+          <a:xfrm xmlns:a="http://schemas.openxmlformats.org/drawingml/2006/main">
+            <a:off x="571500" y="1295400"/>
+            <a:ext cx="10763250" cy="476250"/>
+          </a:xfrm>
+          <a:prstGeom xmlns:a="http://schemas.openxmlformats.org/drawingml/2006/main" prst="rect">
+            <a:avLst/>
+          </a:prstGeom>
+          <a:noFill xmlns:a="http://schemas.openxmlformats.org/drawingml/2006/main"/>
+          <a:ln xmlns:a="http://schemas.openxmlformats.org/drawingml/2006/main" w="0">
+            <a:noFill/>
+          </a:ln>
+        </p:spPr>
+        <p:txBody>
+          <a:bodyPr xmlns:a="http://schemas.openxmlformats.org/drawingml/2006/main">
+            <a:noAutofit/>
+          </a:bodyPr>
+          <a:lstStyle xmlns:a="http://schemas.openxmlformats.org/drawingml/2006/main"/>
+          <a:p xmlns:a="http://schemas.openxmlformats.org/drawingml/2006/main">
+            <a:pPr>
+              <a:defRPr sz="2250" b="0">
+                <a:solidFill>
+                  <a:srgbClr val="172D3D"/>
+                </a:solidFill>
+                <a:latin typeface="Arial"/>
+                <a:ea typeface="Arial"/>
+                <a:cs typeface="Arial"/>
+              </a:defRPr>
+            </a:pPr>
+            <a:r>
+              <a:rPr sz="2250" b="0">
+                <a:solidFill>
+                  <a:srgbClr val="172D3D"/>
+                </a:solidFill>
+                <a:latin typeface="Arial"/>
+                <a:ea typeface="Arial"/>
+                <a:cs typeface="Arial"/>
+              </a:rPr>
+              <a:t>Changes between intake and end ratings</a:t>
+            </a:r>
+          </a:p>
+        </p:txBody>
+      </p:sp>
+      <p:graphicFrame>
+        <p:nvGraphicFramePr>
+          <p:cNvPr id="10" name="Chart"/>
+          <p:cNvGraphicFramePr/>
+          <p:nvPr/>
+        </p:nvGraphicFramePr>
+        <p:xfrm>
+          <a:off xmlns:a="http://schemas.openxmlformats.org/drawingml/2006/main" x="619125" y="1952625"/>
+          <a:ext xmlns:a="http://schemas.openxmlformats.org/drawingml/2006/main" cx="10715625" cy="2571750"/>
+        </p:xfrm>
+        <a:graphic xmlns:a="http://schemas.openxmlformats.org/drawingml/2006/main">
+          <a:graphicData uri="http://schemas.openxmlformats.org/drawingml/2006/chart">
+            <c:chart xmlns:r="http://schemas.openxmlformats.org/officeDocument/2006/relationships" xmlns:c="http://schemas.openxmlformats.org/drawingml/2006/chart" r:id="Rb2a10100880f4f5f"/>
+          </a:graphicData>
+        </a:graphic>
+      </p:graphicFrame>
+      <p:sp>
+        <p:nvSpPr>
+          <p:cNvPr id="5" name="8 of 11 safety ratings increased; trust responses were more ">
+            <a:extLst xmlns:a="http://schemas.openxmlformats.org/drawingml/2006/main">
+              <a:ext uri="{FF2B5EF4-FFF2-40B4-BE49-F238E27FC236}">
+                <a16:creationId xmlns:a16="http://schemas.microsoft.com/office/drawing/2014/main" id="{4C68F436-7C3E-4DDA-A61F-723CD0311D75}"/>
+              </a:ext>
+            </a:extLst>
+          </p:cNvPr>
+          <p:cNvSpPr>
+            <a:spLocks xmlns:a="http://schemas.openxmlformats.org/drawingml/2006/main" noGrp="1"/>
+          </p:cNvSpPr>
+          <p:nvPr/>
+        </p:nvSpPr>
+        <p:spPr>
+          <a:xfrm xmlns:a="http://schemas.openxmlformats.org/drawingml/2006/main">
+            <a:off x="571500" y="4695825"/>
+            <a:ext cx="10763250" cy="552450"/>
+          </a:xfrm>
+          <a:prstGeom xmlns:a="http://schemas.openxmlformats.org/drawingml/2006/main" prst="rect">
+            <a:avLst/>
+          </a:prstGeom>
+          <a:noFill xmlns:a="http://schemas.openxmlformats.org/drawingml/2006/main"/>
+          <a:ln xmlns:a="http://schemas.openxmlformats.org/drawingml/2006/main" w="0">
+            <a:noFill/>
+          </a:ln>
+        </p:spPr>
+        <p:txBody>
+          <a:bodyPr xmlns:a="http://schemas.openxmlformats.org/drawingml/2006/main">
+            <a:noAutofit/>
+          </a:bodyPr>
+          <a:lstStyle xmlns:a="http://schemas.openxmlformats.org/drawingml/2006/main"/>
+          <a:p xmlns:a="http://schemas.openxmlformats.org/drawingml/2006/main">
+            <a:pPr>
+              <a:defRPr sz="2250" b="1">
+                <a:solidFill>
+                  <a:srgbClr val="006DAE"/>
+                </a:solidFill>
+                <a:latin typeface="Arial"/>
+                <a:ea typeface="Arial"/>
+                <a:cs typeface="Arial"/>
+              </a:defRPr>
+            </a:pPr>
+            <a:r>
+              <a:rPr sz="2250" b="1">
+                <a:solidFill>
+                  <a:srgbClr val="006DAE"/>
+                </a:solidFill>
+                <a:latin typeface="Arial"/>
+                <a:ea typeface="Arial"/>
+                <a:cs typeface="Arial"/>
+              </a:rPr>
+              <a:t>8 of 11 safety ratings increased; trust responses were more mixed.</a:t>
+            </a:r>
+          </a:p>
+        </p:txBody>
+      </p:sp>
+      <p:sp>
+        <p:nvSpPr>
+          <p:cNvPr id="6" name="Matched response sets, not a confirmed count of distinct peo">
+            <a:extLst xmlns:a="http://schemas.openxmlformats.org/drawingml/2006/main">
+              <a:ext uri="{FF2B5EF4-FFF2-40B4-BE49-F238E27FC236}">
+                <a16:creationId xmlns:a16="http://schemas.microsoft.com/office/drawing/2014/main" id="{DD433E31-694F-46D7-9C78-BABB08EABEFF}"/>
+              </a:ext>
+            </a:extLst>
+          </p:cNvPr>
+          <p:cNvSpPr>
+            <a:spLocks xmlns:a="http://schemas.openxmlformats.org/drawingml/2006/main" noGrp="1"/>
+          </p:cNvSpPr>
+          <p:nvPr/>
+        </p:nvSpPr>
+        <p:spPr>
+          <a:xfrm xmlns:a="http://schemas.openxmlformats.org/drawingml/2006/main">
+            <a:off x="571500" y="5286375"/>
+            <a:ext cx="10763250" cy="628650"/>
+          </a:xfrm>
+          <a:prstGeom xmlns:a="http://schemas.openxmlformats.org/drawingml/2006/main" prst="rect">
+            <a:avLst/>
+          </a:prstGeom>
+          <a:noFill xmlns:a="http://schemas.openxmlformats.org/drawingml/2006/main"/>
+          <a:ln xmlns:a="http://schemas.openxmlformats.org/drawingml/2006/main" w="0">
+            <a:noFill/>
+          </a:ln>
+        </p:spPr>
+        <p:txBody>
+          <a:bodyPr xmlns:a="http://schemas.openxmlformats.org/drawingml/2006/main">
+            <a:noAutofit/>
+          </a:bodyPr>
+          <a:lstStyle xmlns:a="http://schemas.openxmlformats.org/drawingml/2006/main"/>
+          <a:p xmlns:a="http://schemas.openxmlformats.org/drawingml/2006/main">
+            <a:pPr>
+              <a:defRPr sz="1800" b="0">
+                <a:solidFill>
+                  <a:srgbClr val="536B79"/>
+                </a:solidFill>
+                <a:latin typeface="Arial"/>
+                <a:ea typeface="Arial"/>
+                <a:cs typeface="Arial"/>
+              </a:defRPr>
+            </a:pPr>
+            <a:r>
+              <a:rPr sz="1800" b="0">
+                <a:solidFill>
+                  <a:srgbClr val="536B79"/>
+                </a:solidFill>
+                <a:latin typeface="Arial"/>
+                <a:ea typeface="Arial"/>
+                <a:cs typeface="Arial"/>
+              </a:rPr>
+              <a:t>Matched response sets, not a confirmed count of distinct people.</a:t>
+            </a:r>
+          </a:p>
+          <a:p xmlns:a="http://schemas.openxmlformats.org/drawingml/2006/main">
+            <a:pPr>
+              <a:defRPr sz="1800" b="0">
+                <a:solidFill>
+                  <a:srgbClr val="536B79"/>
+                </a:solidFill>
+                <a:latin typeface="Arial"/>
+                <a:ea typeface="Arial"/>
+                <a:cs typeface="Arial"/>
+              </a:defRPr>
+            </a:pPr>
+            <a:r>
+              <a:rPr sz="1800" b="0">
+                <a:solidFill>
+                  <a:srgbClr val="536B79"/>
+                </a:solidFill>
+                <a:latin typeface="Arial"/>
+                <a:ea typeface="Arial"/>
+                <a:cs typeface="Arial"/>
+              </a:rPr>
+              <a:t>Expected and experienced ratings do not identify a controller effect.</a:t>
+            </a:r>
+          </a:p>
+        </p:txBody>
+      </p:sp>
+    </p:spTree>
+    <p:extLst>
+      <p:ext uri="{BB962C8B-B14F-4D97-AF65-F5344CB8AC3E}">
+        <p14:creationId xmlns:p14="http://schemas.microsoft.com/office/powerpoint/2010/main" val="1512327385"/>
+      </p:ext>
+    </p:extLst>
+  </p:cSld>
+</p:sld>
+</file>
+
+<file path=ppt/slides/slide12.xml><?xml version="1.0" encoding="utf-8"?>
+<p:sld xmlns:p="http://schemas.openxmlformats.org/presentationml/2006/main">
+  <p:cSld>
+    <p:spTree>
+      <p:nvGrpSpPr>
+        <p:cNvPr id="1" name=""/>
+        <p:cNvGrpSpPr/>
+        <p:nvPr/>
+      </p:nvGrpSpPr>
+      <p:grpSpPr>
+        <a:xfrm xmlns:a="http://schemas.openxmlformats.org/drawingml/2006/main"/>
+      </p:grpSpPr>
+      <p:sp>
+        <p:nvSpPr>
           <p:cNvPr id="7" name="Distance measurement affects interpretation">
             <a:extLst xmlns:a="http://schemas.openxmlformats.org/drawingml/2006/main">
               <a:ext uri="{FF2B5EF4-FFF2-40B4-BE49-F238E27FC236}">
@@ -8513,7 +8782,7 @@
                 <a:ea typeface="Arial"/>
                 <a:cs typeface="Arial"/>
               </a:rPr>
-              <a:t>12</a:t>
+              <a:t>09</a:t>
             </a:r>
           </a:p>
         </p:txBody>
@@ -8738,7 +9007,7 @@
 </p:sld>
 </file>
 
-<file path=ppt/slides/slide11.xml><?xml version="1.0" encoding="utf-8"?>
+<file path=ppt/slides/slide14.xml><?xml version="1.0" encoding="utf-8"?>
 <p:sld xmlns:a="http://schemas.openxmlformats.org/drawingml/2006/main" xmlns:p="http://schemas.openxmlformats.org/presentationml/2006/main" xmlns:r="http://schemas.openxmlformats.org/officeDocument/2006/relationships">
   <p:cSld>
     <p:spTree>
@@ -8800,7 +9069,7 @@
                 <a:ea typeface="Arial"/>
                 <a:cs typeface="Arial"/>
               </a:rPr>
-              <a:t>One real trial, as the controller saw it</a:t>
+              <a:t>Results answer the research question</a:t>
             </a:r>
           </a:p>
         </p:txBody>
@@ -8858,219 +9127,6 @@
                 <a:cs typeface="Arial"/>
               </a:rPr>
               <a:t>13</a:t>
-            </a:r>
-          </a:p>
-        </p:txBody>
-      </p:sp>
-      <p:pic>
-        <p:nvPicPr>
-          <p:cNvPr id="8" name="Picture 7" descr="representative-trace-full.png"/>
-          <p:cNvPicPr>
-            <a:picLocks noChangeAspect="1"/>
-          </p:cNvPicPr>
-          <p:nvPr/>
-        </p:nvPicPr>
-        <p:blipFill>
-          <a:blip r:embed="rId2"/>
-          <a:stretch>
-            <a:fillRect/>
-          </a:stretch>
-        </p:blipFill>
-        <p:spPr>
-          <a:xfrm>
-            <a:off x="571500" y="1250000"/>
-            <a:ext cx="8541000" cy="4242253"/>
-          </a:xfrm>
-          <a:prstGeom prst="rect">
-            <a:avLst/>
-          </a:prstGeom>
-        </p:spPr>
-      </p:pic>
-      <p:sp>
-        <p:nvSpPr>
-          <p:cNvPr id="6" name="Schematic of the procedure; scale and motion are illustrativ">
-            <a:extLst>
-              <a:ext uri="{FF2B5EF4-FFF2-40B4-BE49-F238E27FC236}">
-                <a16:creationId xmlns:a16="http://schemas.microsoft.com/office/drawing/2014/main" id="{2BCF01A8-A812-4BB7-ADB0-153753A61F5C}"/>
-              </a:ext>
-            </a:extLst>
-          </p:cNvPr>
-          <p:cNvSpPr>
-            <a:spLocks noGrp="1"/>
-          </p:cNvSpPr>
-          <p:nvPr/>
-        </p:nvSpPr>
-        <p:spPr>
-          <a:xfrm>
-            <a:off x="571500" y="5500000"/>
-            <a:ext cx="10950000" cy="700000"/>
-          </a:xfrm>
-          <a:prstGeom prst="rect">
-            <a:avLst/>
-          </a:prstGeom>
-          <a:noFill/>
-          <a:ln w="0">
-            <a:noFill/>
-          </a:ln>
-        </p:spPr>
-        <p:txBody>
-          <a:bodyPr>
-            <a:noAutofit/>
-          </a:bodyPr>
-          <a:lstStyle/>
-          <a:p>
-            <a:pPr>
-              <a:defRPr sz="1650" b="0">
-                <a:solidFill>
-                  <a:srgbClr val="536B79"/>
-                </a:solidFill>
-                <a:latin typeface="Arial"/>
-                <a:ea typeface="Arial"/>
-                <a:cs typeface="Arial"/>
-              </a:defRPr>
-            </a:pPr>
-            <a:r>
-              <a:rPr sz="1300" b="0">
-                <a:solidFill>
-                  <a:srgbClr val="536B79"/>
-                </a:solidFill>
-                <a:latin typeface="Arial"/>
-                <a:ea typeface="Arial"/>
-                <a:cs typeface="Arial"/>
-              </a:rPr>
-              <a:t>Distance to the robot, closing speed, speed command and joint speed from one predictive trial. The robot stops every time the worker comes close; the rapid on/off flicker is the predictor switching we identify as the fix.</a:t>
-            </a:r>
-          </a:p>
-        </p:txBody>
-      </p:sp>
-    </p:spTree>
-  </p:cSld>
-  <p:clrMapOvr>
-    <a:masterClrMapping/>
-  </p:clrMapOvr>
-</p:sld>
-</file>
-
-<file path=ppt/slides/slide12.xml><?xml version="1.0" encoding="utf-8"?>
-<p:sld xmlns:a="http://schemas.openxmlformats.org/drawingml/2006/main" xmlns:p="http://schemas.openxmlformats.org/presentationml/2006/main" xmlns:r="http://schemas.openxmlformats.org/officeDocument/2006/relationships">
-  <p:cSld>
-    <p:spTree>
-      <p:nvGrpSpPr>
-        <p:cNvPr id="1" name=""/>
-        <p:cNvGrpSpPr/>
-        <p:nvPr/>
-      </p:nvGrpSpPr>
-      <p:grpSpPr/>
-      <p:sp>
-        <p:nvSpPr>
-          <p:cNvPr id="7" name="The task and laboratory prototype">
-            <a:extLst>
-              <a:ext uri="{FF2B5EF4-FFF2-40B4-BE49-F238E27FC236}">
-                <a16:creationId xmlns:a16="http://schemas.microsoft.com/office/drawing/2014/main" id="{DA806EAB-9D1F-4D99-9E8F-92CEBF025533}"/>
-              </a:ext>
-            </a:extLst>
-          </p:cNvPr>
-          <p:cNvSpPr>
-            <a:spLocks noGrp="1"/>
-          </p:cNvSpPr>
-          <p:nvPr/>
-        </p:nvSpPr>
-        <p:spPr>
-          <a:xfrm>
-            <a:off x="438150" y="381000"/>
-            <a:ext cx="11049000" cy="809625"/>
-          </a:xfrm>
-          <a:prstGeom prst="rect">
-            <a:avLst/>
-          </a:prstGeom>
-          <a:noFill/>
-          <a:ln w="0">
-            <a:noFill/>
-          </a:ln>
-        </p:spPr>
-        <p:txBody>
-          <a:bodyPr>
-            <a:noAutofit/>
-          </a:bodyPr>
-          <a:lstStyle/>
-          <a:p>
-            <a:pPr>
-              <a:defRPr sz="3300" b="1">
-                <a:solidFill>
-                  <a:srgbClr val="172D3D"/>
-                </a:solidFill>
-                <a:latin typeface="Arial"/>
-                <a:ea typeface="Arial"/>
-                <a:cs typeface="Arial"/>
-              </a:defRPr>
-            </a:pPr>
-            <a:r>
-              <a:rPr sz="3300" b="1">
-                <a:solidFill>
-                  <a:srgbClr val="172D3D"/>
-                </a:solidFill>
-                <a:latin typeface="Arial"/>
-                <a:ea typeface="Arial"/>
-                <a:cs typeface="Arial"/>
-              </a:rPr>
-              <a:t>Results answer the research question</a:t>
-            </a:r>
-          </a:p>
-        </p:txBody>
-      </p:sp>
-      <p:sp>
-        <p:nvSpPr>
-          <p:cNvPr id="2" name="03">
-            <a:extLst>
-              <a:ext uri="{FF2B5EF4-FFF2-40B4-BE49-F238E27FC236}">
-                <a16:creationId xmlns:a16="http://schemas.microsoft.com/office/drawing/2014/main" id="{CFB5FF92-5DE5-431F-B644-183C6C08DB02}"/>
-              </a:ext>
-            </a:extLst>
-          </p:cNvPr>
-          <p:cNvSpPr>
-            <a:spLocks noGrp="1"/>
-          </p:cNvSpPr>
-          <p:nvPr/>
-        </p:nvSpPr>
-        <p:spPr>
-          <a:xfrm>
-            <a:off x="466725" y="6362700"/>
-            <a:ext cx="476250" cy="228600"/>
-          </a:xfrm>
-          <a:prstGeom prst="rect">
-            <a:avLst/>
-          </a:prstGeom>
-          <a:noFill/>
-          <a:ln w="0">
-            <a:noFill/>
-          </a:ln>
-        </p:spPr>
-        <p:txBody>
-          <a:bodyPr>
-            <a:noAutofit/>
-          </a:bodyPr>
-          <a:lstStyle/>
-          <a:p>
-            <a:pPr>
-              <a:defRPr sz="1200" b="0">
-                <a:solidFill>
-                  <a:srgbClr val="536B79"/>
-                </a:solidFill>
-                <a:latin typeface="Arial"/>
-                <a:ea typeface="Arial"/>
-                <a:cs typeface="Arial"/>
-              </a:defRPr>
-            </a:pPr>
-            <a:r>
-              <a:rPr sz="1200" b="0">
-                <a:solidFill>
-                  <a:srgbClr val="536B79"/>
-                </a:solidFill>
-                <a:latin typeface="Arial"/>
-                <a:ea typeface="Arial"/>
-                <a:cs typeface="Arial"/>
-              </a:rPr>
-              <a:t>14</a:t>
             </a:r>
           </a:p>
         </p:txBody>
@@ -9459,7 +9515,7 @@
 </p:sld>
 </file>
 
-<file path=ppt/slides/slide13.xml><?xml version="1.0" encoding="utf-8"?>
+<file path=ppt/slides/slide15.xml><?xml version="1.0" encoding="utf-8"?>
 <p:sld xmlns:p="http://schemas.openxmlformats.org/presentationml/2006/main">
   <p:cSld>
     <p:spTree>
@@ -9580,7 +9636,7 @@
                 <a:ea typeface="Arial"/>
                 <a:cs typeface="Arial"/>
               </a:rPr>
-              <a:t>15</a:t>
+              <a:t>10</a:t>
             </a:r>
           </a:p>
         </p:txBody>
@@ -9936,7 +9992,7 @@
 </p:sld>
 </file>
 
-<file path=ppt/slides/slide14.xml><?xml version="1.0" encoding="utf-8"?>
+<file path=ppt/slides/slide16.xml><?xml version="1.0" encoding="utf-8"?>
 <p:sld xmlns:p="http://schemas.openxmlformats.org/presentationml/2006/main">
   <p:cSld>
     <p:spTree>
@@ -10057,7 +10113,7 @@
                 <a:ea typeface="Arial"/>
                 <a:cs typeface="Arial"/>
               </a:rPr>
-              <a:t>16</a:t>
+              <a:t>11</a:t>
             </a:r>
           </a:p>
         </p:txBody>
@@ -10453,7 +10509,7 @@
 </p:sld>
 </file>
 
-<file path=ppt/slides/slide15.xml><?xml version="1.0" encoding="utf-8"?>
+<file path=ppt/slides/slide17.xml><?xml version="1.0" encoding="utf-8"?>
 <p:sld xmlns:p="http://schemas.openxmlformats.org/presentationml/2006/main">
   <p:cSld>
     <p:spTree>
@@ -10574,7 +10630,7 @@
                 <a:ea typeface="Arial"/>
                 <a:cs typeface="Arial"/>
               </a:rPr>
-              <a:t>17</a:t>
+              <a:t>12</a:t>
             </a:r>
           </a:p>
         </p:txBody>
@@ -10961,7 +11017,7 @@
 </p:sld>
 </file>
 
-<file path=ppt/slides/slide16.xml><?xml version="1.0" encoding="utf-8"?>
+<file path=ppt/slides/slide18.xml><?xml version="1.0" encoding="utf-8"?>
 <p:sld xmlns:p="http://schemas.openxmlformats.org/presentationml/2006/main">
   <p:cSld>
     <p:spTree>
@@ -11082,7 +11138,7 @@
                 <a:ea typeface="Arial"/>
                 <a:cs typeface="Arial"/>
               </a:rPr>
-              <a:t>18</a:t>
+              <a:t>14</a:t>
             </a:r>
           </a:p>
         </p:txBody>
@@ -11368,572 +11424,6 @@
       </p:ext>
     </p:extLst>
   </p:cSld>
-</p:sld>
-</file>
-
-<file path=ppt/slides/slide17.xml><?xml version="1.0" encoding="utf-8"?>
-<p:sld xmlns:a="http://schemas.openxmlformats.org/drawingml/2006/main" xmlns:p="http://schemas.openxmlformats.org/presentationml/2006/main" xmlns:r="http://schemas.openxmlformats.org/officeDocument/2006/relationships">
-  <p:cSld>
-    <p:spTree>
-      <p:nvGrpSpPr>
-        <p:cNvPr id="1" name=""/>
-        <p:cNvGrpSpPr/>
-        <p:nvPr/>
-      </p:nvGrpSpPr>
-      <p:grpSpPr/>
-      <p:sp>
-        <p:nvSpPr>
-          <p:cNvPr id="7" name="The task and laboratory prototype">
-            <a:extLst>
-              <a:ext uri="{FF2B5EF4-FFF2-40B4-BE49-F238E27FC236}">
-                <a16:creationId xmlns:a16="http://schemas.microsoft.com/office/drawing/2014/main" id="{DA806EAB-9D1F-4D99-9E8F-92CEBF025533}"/>
-              </a:ext>
-            </a:extLst>
-          </p:cNvPr>
-          <p:cNvSpPr>
-            <a:spLocks noGrp="1"/>
-          </p:cNvSpPr>
-          <p:nvPr/>
-        </p:nvSpPr>
-        <p:spPr>
-          <a:xfrm>
-            <a:off x="438150" y="381000"/>
-            <a:ext cx="11049000" cy="809625"/>
-          </a:xfrm>
-          <a:prstGeom prst="rect">
-            <a:avLst/>
-          </a:prstGeom>
-          <a:noFill/>
-          <a:ln w="0">
-            <a:noFill/>
-          </a:ln>
-        </p:spPr>
-        <p:txBody>
-          <a:bodyPr>
-            <a:noAutofit/>
-          </a:bodyPr>
-          <a:lstStyle/>
-          <a:p>
-            <a:pPr>
-              <a:defRPr sz="3300" b="1">
-                <a:solidFill>
-                  <a:srgbClr val="172D3D"/>
-                </a:solidFill>
-                <a:latin typeface="Arial"/>
-                <a:ea typeface="Arial"/>
-                <a:cs typeface="Arial"/>
-              </a:defRPr>
-            </a:pPr>
-            <a:r>
-              <a:rPr sz="3300" b="1">
-                <a:solidFill>
-                  <a:srgbClr val="172D3D"/>
-                </a:solidFill>
-                <a:latin typeface="Arial"/>
-                <a:ea typeface="Arial"/>
-                <a:cs typeface="Arial"/>
-              </a:rPr>
-              <a:t>Inside our trained model</a:t>
-            </a:r>
-          </a:p>
-        </p:txBody>
-      </p:sp>
-      <p:sp>
-        <p:nvSpPr>
-          <p:cNvPr id="2" name="03">
-            <a:extLst>
-              <a:ext uri="{FF2B5EF4-FFF2-40B4-BE49-F238E27FC236}">
-                <a16:creationId xmlns:a16="http://schemas.microsoft.com/office/drawing/2014/main" id="{CFB5FF92-5DE5-431F-B644-183C6C08DB02}"/>
-              </a:ext>
-            </a:extLst>
-          </p:cNvPr>
-          <p:cNvSpPr>
-            <a:spLocks noGrp="1"/>
-          </p:cNvSpPr>
-          <p:nvPr/>
-        </p:nvSpPr>
-        <p:spPr>
-          <a:xfrm>
-            <a:off x="466725" y="6362700"/>
-            <a:ext cx="476250" cy="228600"/>
-          </a:xfrm>
-          <a:prstGeom prst="rect">
-            <a:avLst/>
-          </a:prstGeom>
-          <a:noFill/>
-          <a:ln w="0">
-            <a:noFill/>
-          </a:ln>
-        </p:spPr>
-        <p:txBody>
-          <a:bodyPr>
-            <a:noAutofit/>
-          </a:bodyPr>
-          <a:lstStyle/>
-          <a:p>
-            <a:pPr>
-              <a:defRPr sz="1200" b="0">
-                <a:solidFill>
-                  <a:srgbClr val="536B79"/>
-                </a:solidFill>
-                <a:latin typeface="Arial"/>
-                <a:ea typeface="Arial"/>
-                <a:cs typeface="Arial"/>
-              </a:defRPr>
-            </a:pPr>
-            <a:r>
-              <a:rPr sz="1200" b="0">
-                <a:solidFill>
-                  <a:srgbClr val="536B79"/>
-                </a:solidFill>
-                <a:latin typeface="Arial"/>
-                <a:ea typeface="Arial"/>
-                <a:cs typeface="Arial"/>
-              </a:rPr>
-              <a:t>09</a:t>
-            </a:r>
-          </a:p>
-        </p:txBody>
-      </p:sp>
-      <p:pic>
-        <p:nvPicPr>
-          <p:cNvPr id="8" name="Picture 7" descr="pipeline.png"/>
-          <p:cNvPicPr>
-            <a:picLocks noChangeAspect="1"/>
-          </p:cNvPicPr>
-          <p:nvPr/>
-        </p:nvPicPr>
-        <p:blipFill>
-          <a:blip r:embed="rId2"/>
-          <a:stretch>
-            <a:fillRect/>
-          </a:stretch>
-        </p:blipFill>
-        <p:spPr>
-          <a:xfrm>
-            <a:off x="571500" y="1200000"/>
-            <a:ext cx="6900000" cy="2258182"/>
-          </a:xfrm>
-          <a:prstGeom prst="rect">
-            <a:avLst/>
-          </a:prstGeom>
-        </p:spPr>
-      </p:pic>
-      <p:pic>
-        <p:nvPicPr>
-          <p:cNvPr id="9" name="Picture 8" descr="feature-space.png"/>
-          <p:cNvPicPr>
-            <a:picLocks noChangeAspect="1"/>
-          </p:cNvPicPr>
-          <p:nvPr/>
-        </p:nvPicPr>
-        <p:blipFill>
-          <a:blip r:embed="rId3"/>
-          <a:stretch>
-            <a:fillRect/>
-          </a:stretch>
-        </p:blipFill>
-        <p:spPr>
-          <a:xfrm>
-            <a:off x="7650000" y="1150000"/>
-            <a:ext cx="4266667" cy="3200000"/>
-          </a:xfrm>
-          <a:prstGeom prst="rect">
-            <a:avLst/>
-          </a:prstGeom>
-        </p:spPr>
-      </p:pic>
-      <p:sp>
-        <p:nvSpPr>
-          <p:cNvPr id="6" name="Schematic of the procedure; scale and motion are illustrativ">
-            <a:extLst>
-              <a:ext uri="{FF2B5EF4-FFF2-40B4-BE49-F238E27FC236}">
-                <a16:creationId xmlns:a16="http://schemas.microsoft.com/office/drawing/2014/main" id="{2BCF01A8-A812-4BB7-ADB0-153753A61F5C}"/>
-              </a:ext>
-            </a:extLst>
-          </p:cNvPr>
-          <p:cNvSpPr>
-            <a:spLocks noGrp="1"/>
-          </p:cNvSpPr>
-          <p:nvPr/>
-        </p:nvSpPr>
-        <p:spPr>
-          <a:xfrm>
-            <a:off x="571500" y="4500000"/>
-            <a:ext cx="10950000" cy="1500000"/>
-          </a:xfrm>
-          <a:prstGeom prst="rect">
-            <a:avLst/>
-          </a:prstGeom>
-          <a:noFill/>
-          <a:ln w="0">
-            <a:noFill/>
-          </a:ln>
-        </p:spPr>
-        <p:txBody>
-          <a:bodyPr>
-            <a:noAutofit/>
-          </a:bodyPr>
-          <a:lstStyle/>
-          <a:p>
-            <a:pPr>
-              <a:defRPr sz="1650" b="0">
-                <a:solidFill>
-                  <a:srgbClr val="536B79"/>
-                </a:solidFill>
-                <a:latin typeface="Arial"/>
-                <a:ea typeface="Arial"/>
-                <a:cs typeface="Arial"/>
-              </a:defRPr>
-            </a:pPr>
-            <a:r>
-              <a:rPr sz="1400" b="0">
-                <a:solidFill>
-                  <a:srgbClr val="536B79"/>
-                </a:solidFill>
-                <a:latin typeface="Arial"/>
-                <a:ea typeface="Arial"/>
-                <a:cs typeface="Arial"/>
-              </a:rPr>
-              <a:t>Trained by us on 32 labelled trials from three operators (about 90,000 motion frames).</a:t>
-            </a:r>
-          </a:p>
-          <a:p>
-            <a:pPr>
-              <a:defRPr sz="1650" b="0">
-                <a:solidFill>
-                  <a:srgbClr val="536B79"/>
-                </a:solidFill>
-                <a:latin typeface="Arial"/>
-                <a:ea typeface="Arial"/>
-                <a:cs typeface="Arial"/>
-              </a:defRPr>
-            </a:pPr>
-            <a:r>
-              <a:rPr sz="1400" b="0">
-                <a:solidFill>
-                  <a:srgbClr val="536B79"/>
-                </a:solidFill>
-                <a:latin typeface="Arial"/>
-                <a:ea typeface="Arial"/>
-                <a:cs typeface="Arial"/>
-              </a:rPr>
-              <a:t>Four body-motion signals feed a hidden Markov model that learned what approaching, working and retreating look like.</a:t>
-            </a:r>
-          </a:p>
-          <a:p>
-            <a:pPr>
-              <a:defRPr sz="1650" b="0">
-                <a:solidFill>
-                  <a:srgbClr val="536B79"/>
-                </a:solidFill>
-                <a:latin typeface="Arial"/>
-                <a:ea typeface="Arial"/>
-                <a:cs typeface="Arial"/>
-              </a:defRPr>
-            </a:pPr>
-            <a:r>
-              <a:rPr sz="1400" b="0">
-                <a:solidFill>
-                  <a:srgbClr val="536B79"/>
-                </a:solidFill>
-                <a:latin typeface="Arial"/>
-                <a:ea typeface="Arial"/>
-                <a:cs typeface="Arial"/>
-              </a:rPr>
-              <a:t>Right: every dot is a real frame. The phases separate by distance and approach direction, which is what the model exploits.</a:t>
-            </a:r>
-          </a:p>
-        </p:txBody>
-      </p:sp>
-    </p:spTree>
-  </p:cSld>
-  <p:clrMapOvr>
-    <a:masterClrMapping/>
-  </p:clrMapOvr>
-</p:sld>
-</file>
-
-<file path=ppt/slides/slide18.xml><?xml version="1.0" encoding="utf-8"?>
-<p:sld xmlns:a="http://schemas.openxmlformats.org/drawingml/2006/main" xmlns:p="http://schemas.openxmlformats.org/presentationml/2006/main" xmlns:r="http://schemas.openxmlformats.org/officeDocument/2006/relationships">
-  <p:cSld>
-    <p:spTree>
-      <p:nvGrpSpPr>
-        <p:cNvPr id="1" name=""/>
-        <p:cNvGrpSpPr/>
-        <p:nvPr/>
-      </p:nvGrpSpPr>
-      <p:grpSpPr/>
-      <p:sp>
-        <p:nvSpPr>
-          <p:cNvPr id="7" name="The task and laboratory prototype">
-            <a:extLst>
-              <a:ext uri="{FF2B5EF4-FFF2-40B4-BE49-F238E27FC236}">
-                <a16:creationId xmlns:a16="http://schemas.microsoft.com/office/drawing/2014/main" id="{DA806EAB-9D1F-4D99-9E8F-92CEBF025533}"/>
-              </a:ext>
-            </a:extLst>
-          </p:cNvPr>
-          <p:cNvSpPr>
-            <a:spLocks noGrp="1"/>
-          </p:cNvSpPr>
-          <p:nvPr/>
-        </p:nvSpPr>
-        <p:spPr>
-          <a:xfrm>
-            <a:off x="438150" y="381000"/>
-            <a:ext cx="11049000" cy="809625"/>
-          </a:xfrm>
-          <a:prstGeom prst="rect">
-            <a:avLst/>
-          </a:prstGeom>
-          <a:noFill/>
-          <a:ln w="0">
-            <a:noFill/>
-          </a:ln>
-        </p:spPr>
-        <p:txBody>
-          <a:bodyPr>
-            <a:noAutofit/>
-          </a:bodyPr>
-          <a:lstStyle/>
-          <a:p>
-            <a:pPr>
-              <a:defRPr sz="3300" b="1">
-                <a:solidFill>
-                  <a:srgbClr val="172D3D"/>
-                </a:solidFill>
-                <a:latin typeface="Arial"/>
-                <a:ea typeface="Arial"/>
-                <a:cs typeface="Arial"/>
-              </a:defRPr>
-            </a:pPr>
-            <a:r>
-              <a:rPr sz="3300" b="1">
-                <a:solidFill>
-                  <a:srgbClr val="172D3D"/>
-                </a:solidFill>
-                <a:latin typeface="Arial"/>
-                <a:ea typeface="Arial"/>
-                <a:cs typeface="Arial"/>
-              </a:rPr>
-              <a:t>Watching the model work on a new person</a:t>
-            </a:r>
-          </a:p>
-        </p:txBody>
-      </p:sp>
-      <p:sp>
-        <p:nvSpPr>
-          <p:cNvPr id="2" name="03">
-            <a:extLst>
-              <a:ext uri="{FF2B5EF4-FFF2-40B4-BE49-F238E27FC236}">
-                <a16:creationId xmlns:a16="http://schemas.microsoft.com/office/drawing/2014/main" id="{CFB5FF92-5DE5-431F-B644-183C6C08DB02}"/>
-              </a:ext>
-            </a:extLst>
-          </p:cNvPr>
-          <p:cNvSpPr>
-            <a:spLocks noGrp="1"/>
-          </p:cNvSpPr>
-          <p:nvPr/>
-        </p:nvSpPr>
-        <p:spPr>
-          <a:xfrm>
-            <a:off x="466725" y="6362700"/>
-            <a:ext cx="476250" cy="228600"/>
-          </a:xfrm>
-          <a:prstGeom prst="rect">
-            <a:avLst/>
-          </a:prstGeom>
-          <a:noFill/>
-          <a:ln w="0">
-            <a:noFill/>
-          </a:ln>
-        </p:spPr>
-        <p:txBody>
-          <a:bodyPr>
-            <a:noAutofit/>
-          </a:bodyPr>
-          <a:lstStyle/>
-          <a:p>
-            <a:pPr>
-              <a:defRPr sz="1200" b="0">
-                <a:solidFill>
-                  <a:srgbClr val="536B79"/>
-                </a:solidFill>
-                <a:latin typeface="Arial"/>
-                <a:ea typeface="Arial"/>
-                <a:cs typeface="Arial"/>
-              </a:defRPr>
-            </a:pPr>
-            <a:r>
-              <a:rPr sz="1200" b="0">
-                <a:solidFill>
-                  <a:srgbClr val="536B79"/>
-                </a:solidFill>
-                <a:latin typeface="Arial"/>
-                <a:ea typeface="Arial"/>
-                <a:cs typeface="Arial"/>
-              </a:rPr>
-              <a:t>10</a:t>
-            </a:r>
-          </a:p>
-        </p:txBody>
-      </p:sp>
-      <p:pic>
-        <p:nvPicPr>
-          <p:cNvPr id="8" name="Picture 7" descr="held-out-trial.png"/>
-          <p:cNvPicPr>
-            <a:picLocks noChangeAspect="1"/>
-          </p:cNvPicPr>
-          <p:nvPr/>
-        </p:nvPicPr>
-        <p:blipFill>
-          <a:blip r:embed="rId2"/>
-          <a:stretch>
-            <a:fillRect/>
-          </a:stretch>
-        </p:blipFill>
-        <p:spPr>
-          <a:xfrm>
-            <a:off x="571500" y="1200000"/>
-            <a:ext cx="7400000" cy="2825455"/>
-          </a:xfrm>
-          <a:prstGeom prst="rect">
-            <a:avLst/>
-          </a:prstGeom>
-        </p:spPr>
-      </p:pic>
-      <p:pic>
-        <p:nvPicPr>
-          <p:cNvPr id="9" name="Picture 8" descr="confusion.png"/>
-          <p:cNvPicPr>
-            <a:picLocks noChangeAspect="1"/>
-          </p:cNvPicPr>
-          <p:nvPr/>
-        </p:nvPicPr>
-        <p:blipFill>
-          <a:blip r:embed="rId3"/>
-          <a:stretch>
-            <a:fillRect/>
-          </a:stretch>
-        </p:blipFill>
-        <p:spPr>
-          <a:xfrm>
-            <a:off x="8150000" y="1150000"/>
-            <a:ext cx="3616667" cy="3100000"/>
-          </a:xfrm>
-          <a:prstGeom prst="rect">
-            <a:avLst/>
-          </a:prstGeom>
-        </p:spPr>
-      </p:pic>
-      <p:sp>
-        <p:nvSpPr>
-          <p:cNvPr id="6" name="Schematic of the procedure; scale and motion are illustrativ">
-            <a:extLst>
-              <a:ext uri="{FF2B5EF4-FFF2-40B4-BE49-F238E27FC236}">
-                <a16:creationId xmlns:a16="http://schemas.microsoft.com/office/drawing/2014/main" id="{2BCF01A8-A812-4BB7-ADB0-153753A61F5C}"/>
-              </a:ext>
-            </a:extLst>
-          </p:cNvPr>
-          <p:cNvSpPr>
-            <a:spLocks noGrp="1"/>
-          </p:cNvSpPr>
-          <p:nvPr/>
-        </p:nvSpPr>
-        <p:spPr>
-          <a:xfrm>
-            <a:off x="571500" y="4500000"/>
-            <a:ext cx="10950000" cy="1500000"/>
-          </a:xfrm>
-          <a:prstGeom prst="rect">
-            <a:avLst/>
-          </a:prstGeom>
-          <a:noFill/>
-          <a:ln w="0">
-            <a:noFill/>
-          </a:ln>
-        </p:spPr>
-        <p:txBody>
-          <a:bodyPr>
-            <a:noAutofit/>
-          </a:bodyPr>
-          <a:lstStyle/>
-          <a:p>
-            <a:pPr>
-              <a:defRPr sz="1650" b="0">
-                <a:solidFill>
-                  <a:srgbClr val="536B79"/>
-                </a:solidFill>
-                <a:latin typeface="Arial"/>
-                <a:ea typeface="Arial"/>
-                <a:cs typeface="Arial"/>
-              </a:defRPr>
-            </a:pPr>
-            <a:r>
-              <a:rPr sz="1400" b="0">
-                <a:solidFill>
-                  <a:srgbClr val="536B79"/>
-                </a:solidFill>
-                <a:latin typeface="Arial"/>
-                <a:ea typeface="Arial"/>
-                <a:cs typeface="Arial"/>
-              </a:rPr>
-              <a:t>A typical trial from an operator the model never saw in training: live estimate (bottom) against what the person was doing (top).</a:t>
-            </a:r>
-          </a:p>
-          <a:p>
-            <a:pPr>
-              <a:defRPr sz="1650" b="0">
-                <a:solidFill>
-                  <a:srgbClr val="536B79"/>
-                </a:solidFill>
-                <a:latin typeface="Arial"/>
-                <a:ea typeface="Arial"/>
-                <a:cs typeface="Arial"/>
-              </a:defRPr>
-            </a:pPr>
-            <a:r>
-              <a:rPr sz="1400" b="0">
-                <a:solidFill>
-                  <a:srgbClr val="536B79"/>
-                </a:solidFill>
-                <a:latin typeface="Arial"/>
-                <a:ea typeface="Arial"/>
-                <a:cs typeface="Arial"/>
-              </a:rPr>
-              <a:t>It tracks the long working phase well and briefly hesitates at phase changes, where most errors fall.</a:t>
-            </a:r>
-          </a:p>
-          <a:p>
-            <a:pPr>
-              <a:defRPr sz="1650" b="0">
-                <a:solidFill>
-                  <a:srgbClr val="536B79"/>
-                </a:solidFill>
-                <a:latin typeface="Arial"/>
-                <a:ea typeface="Arial"/>
-                <a:cs typeface="Arial"/>
-              </a:defRPr>
-            </a:pPr>
-            <a:r>
-              <a:rPr sz="1400" b="0">
-                <a:solidFill>
-                  <a:srgbClr val="536B79"/>
-                </a:solidFill>
-                <a:latin typeface="Arial"/>
-                <a:ea typeface="Arial"/>
-                <a:cs typeface="Arial"/>
-              </a:rPr>
-              <a:t>Right: across all held-out operators, which phase the model chose for each true phase.</a:t>
-            </a:r>
-          </a:p>
-        </p:txBody>
-      </p:sp>
-    </p:spTree>
-  </p:cSld>
-  <p:clrMapOvr>
-    <a:masterClrMapping/>
-  </p:clrMapOvr>
 </p:sld>
 </file>
 
@@ -12752,8 +12242,41 @@
         </p:blipFill>
         <p:spPr>
           <a:xfrm>
-            <a:off x="1214438" y="1266825"/>
-            <a:ext cx="6096000" cy="3429000"/>
+            <a:off x="571500" y="1300000"/>
+            <a:ext cx="3900000" cy="2193750"/>
+          </a:xfrm>
+          <a:prstGeom prst="rect">
+            <a:avLst/>
+          </a:prstGeom>
+        </p:spPr>
+      </p:pic>
+      <p:pic xmlns:a="http://schemas.openxmlformats.org/drawingml/2006/main" xmlns:r="http://schemas.openxmlformats.org/officeDocument/2006/relationships">
+        <p:nvPicPr>
+          <p:cNvPr id="9" name="clip-approach-xsens.mp4">
+            <a:hlinkClick r:id="" action="ppaction://media"/>
+          </p:cNvPr>
+          <p:cNvPicPr>
+            <a:picLocks noChangeAspect="1"/>
+          </p:cNvPicPr>
+          <p:nvPr>
+            <a:videoFile r:link="rId7"/>
+            <p:extLst>
+              <p:ext uri="{DAA4B4D4-6D71-4841-9C94-3DE7FCFB9230}">
+                <p14:media xmlns:p14="http://schemas.microsoft.com/office/powerpoint/2010/main" r:embed="rId6"/>
+              </p:ext>
+            </p:extLst>
+          </p:nvPr>
+        </p:nvPicPr>
+        <p:blipFill>
+          <a:blip r:embed="rId8"/>
+          <a:stretch>
+            <a:fillRect/>
+          </a:stretch>
+        </p:blipFill>
+        <p:spPr>
+          <a:xfrm>
+            <a:off x="4600000" y="1300000"/>
+            <a:ext cx="3550000" cy="1996875"/>
           </a:xfrm>
           <a:prstGeom prst="rect">
             <a:avLst/>
@@ -12767,323 +12290,6 @@
       </p:ext>
     </p:extLst>
   </p:cSld>
-</p:sld>
-</file>
-
-<file path=ppt/slides/slide4.xml><?xml version="1.0" encoding="utf-8"?>
-<p:sld xmlns:a="http://schemas.openxmlformats.org/drawingml/2006/main" xmlns:p="http://schemas.openxmlformats.org/presentationml/2006/main" xmlns:r="http://schemas.openxmlformats.org/officeDocument/2006/relationships">
-  <p:cSld>
-    <p:spTree>
-      <p:nvGrpSpPr>
-        <p:cNvPr id="1" name=""/>
-        <p:cNvGrpSpPr/>
-        <p:nvPr/>
-      </p:nvGrpSpPr>
-      <p:grpSpPr/>
-      <p:sp>
-        <p:nvSpPr>
-          <p:cNvPr id="7" name="The task and laboratory prototype">
-            <a:extLst>
-              <a:ext uri="{FF2B5EF4-FFF2-40B4-BE49-F238E27FC236}">
-                <a16:creationId xmlns:a16="http://schemas.microsoft.com/office/drawing/2014/main" id="{DA806EAB-9D1F-4D99-9E8F-92CEBF025533}"/>
-              </a:ext>
-            </a:extLst>
-          </p:cNvPr>
-          <p:cNvSpPr>
-            <a:spLocks noGrp="1"/>
-          </p:cNvSpPr>
-          <p:nvPr/>
-        </p:nvSpPr>
-        <p:spPr>
-          <a:xfrm>
-            <a:off x="438150" y="381000"/>
-            <a:ext cx="11049000" cy="809625"/>
-          </a:xfrm>
-          <a:prstGeom prst="rect">
-            <a:avLst/>
-          </a:prstGeom>
-          <a:noFill/>
-          <a:ln w="0">
-            <a:noFill/>
-          </a:ln>
-        </p:spPr>
-        <p:txBody>
-          <a:bodyPr>
-            <a:noAutofit/>
-          </a:bodyPr>
-          <a:lstStyle/>
-          <a:p>
-            <a:pPr>
-              <a:defRPr sz="3300" b="1">
-                <a:solidFill>
-                  <a:srgbClr val="172D3D"/>
-                </a:solidFill>
-                <a:latin typeface="Arial"/>
-                <a:ea typeface="Arial"/>
-                <a:cs typeface="Arial"/>
-              </a:defRPr>
-            </a:pPr>
-            <a:r>
-              <a:rPr sz="3300" b="1">
-                <a:solidFill>
-                  <a:srgbClr val="172D3D"/>
-                </a:solidFill>
-                <a:latin typeface="Arial"/>
-                <a:ea typeface="Arial"/>
-                <a:cs typeface="Arial"/>
-              </a:rPr>
-              <a:t>What we built: the physical rig</a:t>
-            </a:r>
-          </a:p>
-        </p:txBody>
-      </p:sp>
-      <p:sp>
-        <p:nvSpPr>
-          <p:cNvPr id="2" name="03">
-            <a:extLst>
-              <a:ext uri="{FF2B5EF4-FFF2-40B4-BE49-F238E27FC236}">
-                <a16:creationId xmlns:a16="http://schemas.microsoft.com/office/drawing/2014/main" id="{CFB5FF92-5DE5-431F-B644-183C6C08DB02}"/>
-              </a:ext>
-            </a:extLst>
-          </p:cNvPr>
-          <p:cNvSpPr>
-            <a:spLocks noGrp="1"/>
-          </p:cNvSpPr>
-          <p:nvPr/>
-        </p:nvSpPr>
-        <p:spPr>
-          <a:xfrm>
-            <a:off x="466725" y="6362700"/>
-            <a:ext cx="476250" cy="228600"/>
-          </a:xfrm>
-          <a:prstGeom prst="rect">
-            <a:avLst/>
-          </a:prstGeom>
-          <a:noFill/>
-          <a:ln w="0">
-            <a:noFill/>
-          </a:ln>
-        </p:spPr>
-        <p:txBody>
-          <a:bodyPr>
-            <a:noAutofit/>
-          </a:bodyPr>
-          <a:lstStyle/>
-          <a:p>
-            <a:pPr>
-              <a:defRPr sz="1200" b="0">
-                <a:solidFill>
-                  <a:srgbClr val="536B79"/>
-                </a:solidFill>
-                <a:latin typeface="Arial"/>
-                <a:ea typeface="Arial"/>
-                <a:cs typeface="Arial"/>
-              </a:defRPr>
-            </a:pPr>
-            <a:r>
-              <a:rPr sz="1200" b="0">
-                <a:solidFill>
-                  <a:srgbClr val="536B79"/>
-                </a:solidFill>
-                <a:latin typeface="Arial"/>
-                <a:ea typeface="Arial"/>
-                <a:cs typeface="Arial"/>
-              </a:rPr>
-              <a:t>04</a:t>
-            </a:r>
-          </a:p>
-        </p:txBody>
-      </p:sp>
-      <p:pic>
-        <p:nvPicPr>
-          <p:cNvPr id="8" name="Picture 7" descr="image.jpg"/>
-          <p:cNvPicPr>
-            <a:picLocks noChangeAspect="1"/>
-          </p:cNvPicPr>
-          <p:nvPr/>
-        </p:nvPicPr>
-        <p:blipFill>
-          <a:blip r:embed="rId2"/>
-          <a:stretch>
-            <a:fillRect/>
-          </a:stretch>
-        </p:blipFill>
-        <p:spPr>
-          <a:xfrm>
-            <a:off x="571500" y="1300000"/>
-            <a:ext cx="2650000" cy="1490625"/>
-          </a:xfrm>
-          <a:prstGeom prst="rect">
-            <a:avLst/>
-          </a:prstGeom>
-        </p:spPr>
-      </p:pic>
-      <p:pic>
-        <p:nvPicPr>
-          <p:cNvPr id="9" name="Picture 8" descr="apparatus-b.jpg"/>
-          <p:cNvPicPr>
-            <a:picLocks noChangeAspect="1"/>
-          </p:cNvPicPr>
-          <p:nvPr/>
-        </p:nvPicPr>
-        <p:blipFill>
-          <a:blip r:embed="rId3"/>
-          <a:stretch>
-            <a:fillRect/>
-          </a:stretch>
-        </p:blipFill>
-        <p:spPr>
-          <a:xfrm>
-            <a:off x="3341500" y="1300000"/>
-            <a:ext cx="2650000" cy="1488417"/>
-          </a:xfrm>
-          <a:prstGeom prst="rect">
-            <a:avLst/>
-          </a:prstGeom>
-        </p:spPr>
-      </p:pic>
-      <p:pic>
-        <p:nvPicPr>
-          <p:cNvPr id="10" name="Picture 9" descr="apparatus-c.jpg"/>
-          <p:cNvPicPr>
-            <a:picLocks noChangeAspect="1"/>
-          </p:cNvPicPr>
-          <p:nvPr/>
-        </p:nvPicPr>
-        <p:blipFill>
-          <a:blip r:embed="rId4"/>
-          <a:stretch>
-            <a:fillRect/>
-          </a:stretch>
-        </p:blipFill>
-        <p:spPr>
-          <a:xfrm>
-            <a:off x="6111500" y="1300000"/>
-            <a:ext cx="2650000" cy="1490625"/>
-          </a:xfrm>
-          <a:prstGeom prst="rect">
-            <a:avLst/>
-          </a:prstGeom>
-        </p:spPr>
-      </p:pic>
-      <p:pic>
-        <p:nvPicPr>
-          <p:cNvPr id="11" name="clip-approach-xsens.mp4">
-            <a:hlinkClick r:id="" action="ppaction://media"/>
-          </p:cNvPr>
-          <p:cNvPicPr>
-            <a:picLocks noChangeAspect="1"/>
-          </p:cNvPicPr>
-          <p:nvPr>
-            <a:videoFile r:link="rId6"/>
-            <p:extLst>
-              <p:ext uri="{DAA4B4D4-6D71-4841-9C94-3DE7FCFB9230}">
-                <p14:media xmlns:p14="http://schemas.microsoft.com/office/powerpoint/2010/main" r:embed="rId5"/>
-              </p:ext>
-            </p:extLst>
-          </p:nvPr>
-        </p:nvPicPr>
-        <p:blipFill>
-          <a:blip r:embed="rId7"/>
-          <a:stretch>
-            <a:fillRect/>
-          </a:stretch>
-        </p:blipFill>
-        <p:spPr>
-          <a:xfrm>
-            <a:off x="8900000" y="1300000"/>
-            <a:ext cx="2750000" cy="1546875"/>
-          </a:xfrm>
-          <a:prstGeom prst="rect">
-            <a:avLst/>
-          </a:prstGeom>
-        </p:spPr>
-      </p:pic>
-      <p:sp>
-        <p:nvSpPr>
-          <p:cNvPr id="6" name="Schematic of the procedure; scale and motion are illustrativ">
-            <a:extLst>
-              <a:ext uri="{FF2B5EF4-FFF2-40B4-BE49-F238E27FC236}">
-                <a16:creationId xmlns:a16="http://schemas.microsoft.com/office/drawing/2014/main" id="{2BCF01A8-A812-4BB7-ADB0-153753A61F5C}"/>
-              </a:ext>
-            </a:extLst>
-          </p:cNvPr>
-          <p:cNvSpPr>
-            <a:spLocks noGrp="1"/>
-          </p:cNvSpPr>
-          <p:nvPr/>
-        </p:nvSpPr>
-        <p:spPr>
-          <a:xfrm>
-            <a:off x="571500" y="4500000"/>
-            <a:ext cx="10950000" cy="1300000"/>
-          </a:xfrm>
-          <a:prstGeom prst="rect">
-            <a:avLst/>
-          </a:prstGeom>
-          <a:noFill/>
-          <a:ln w="0">
-            <a:noFill/>
-          </a:ln>
-        </p:spPr>
-        <p:txBody>
-          <a:bodyPr>
-            <a:noAutofit/>
-          </a:bodyPr>
-          <a:lstStyle/>
-          <a:p>
-            <a:pPr>
-              <a:defRPr sz="1650" b="0">
-                <a:solidFill>
-                  <a:srgbClr val="536B79"/>
-                </a:solidFill>
-                <a:latin typeface="Arial"/>
-                <a:ea typeface="Arial"/>
-                <a:cs typeface="Arial"/>
-              </a:defRPr>
-            </a:pPr>
-            <a:r>
-              <a:rPr sz="1400" b="0">
-                <a:solidFill>
-                  <a:srgbClr val="536B79"/>
-                </a:solidFill>
-                <a:latin typeface="Arial"/>
-                <a:ea typeface="Arial"/>
-                <a:cs typeface="Arial"/>
-              </a:rPr>
-              <a:t>UR10 holding a full-size panel at ceiling height, OptiTrack cameras around the cell, operator in an Xsens suit.</a:t>
-            </a:r>
-          </a:p>
-          <a:p>
-            <a:pPr>
-              <a:defRPr sz="1650" b="0">
-                <a:solidFill>
-                  <a:srgbClr val="536B79"/>
-                </a:solidFill>
-                <a:latin typeface="Arial"/>
-                <a:ea typeface="Arial"/>
-                <a:cs typeface="Arial"/>
-              </a:defRPr>
-            </a:pPr>
-            <a:r>
-              <a:rPr sz="1400" b="0">
-                <a:solidFill>
-                  <a:srgbClr val="536B79"/>
-                </a:solidFill>
-                <a:latin typeface="Arial"/>
-                <a:ea typeface="Arial"/>
-                <a:cs typeface="Arial"/>
-              </a:rPr>
-              <a:t>Video: a participant approaching the robot while the suit streams every body segment to the controller in real time.</a:t>
-            </a:r>
-          </a:p>
-        </p:txBody>
-      </p:sp>
-    </p:spTree>
-  </p:cSld>
-  <p:clrMapOvr>
-    <a:masterClrMapping/>
-  </p:clrMapOvr>
   <p:timing>
     <p:tnLst>
       <p:par>
@@ -13097,7 +12303,7 @@
                   </p:stCondLst>
                 </p:cTn>
                 <p:tgtEl>
-                  <p:spTgt spid="11"/>
+                  <p:spTgt spid="9"/>
                 </p:tgtEl>
               </p:cMediaNode>
             </p:video>
@@ -13228,7 +12434,7 @@
                 <a:ea typeface="Arial"/>
                 <a:cs typeface="Arial"/>
               </a:rPr>
-              <a:t>05</a:t>
+              <a:t>04</a:t>
             </a:r>
           </a:p>
         </p:txBody>
@@ -13513,7 +12719,7 @@
                 <a:ea typeface="Arial"/>
                 <a:cs typeface="Arial"/>
               </a:rPr>
-              <a:t>06</a:t>
+              <a:t>05</a:t>
             </a:r>
           </a:p>
         </p:txBody>
@@ -14118,7 +13324,7 @@
                 <a:ea typeface="Arial"/>
                 <a:cs typeface="Arial"/>
               </a:rPr>
-              <a:t>07</a:t>
+              <a:t>06</a:t>
             </a:r>
           </a:p>
         </p:txBody>
@@ -14535,824 +13741,6 @@
                 <a:cs typeface="Arial"/>
               </a:rPr>
               <a:t>11 matched intake/end sets. Complete individual linkage is unavailable.</a:t>
-            </a:r>
-          </a:p>
-        </p:txBody>
-      </p:sp>
-    </p:spTree>
-    <p:extLst>
-      <p:ext uri="{BB962C8B-B14F-4D97-AF65-F5344CB8AC3E}">
-        <p14:creationId xmlns:p14="http://schemas.microsoft.com/office/powerpoint/2010/main" val="1512327385"/>
-      </p:ext>
-    </p:extLst>
-  </p:cSld>
-</p:sld>
-</file>
-
-<file path=ppt/slides/slide8.xml><?xml version="1.0" encoding="utf-8"?>
-<p:sld xmlns:p="http://schemas.openxmlformats.org/presentationml/2006/main">
-  <p:cSld>
-    <p:spTree>
-      <p:nvGrpSpPr>
-        <p:cNvPr id="1" name=""/>
-        <p:cNvGrpSpPr/>
-        <p:nvPr/>
-      </p:nvGrpSpPr>
-      <p:grpSpPr>
-        <a:xfrm xmlns:a="http://schemas.openxmlformats.org/drawingml/2006/main"/>
-      </p:grpSpPr>
-      <p:sp>
-        <p:nvSpPr>
-          <p:cNvPr id="8" name="Task-phase recognition">
-            <a:extLst xmlns:a="http://schemas.openxmlformats.org/drawingml/2006/main">
-              <a:ext uri="{FF2B5EF4-FFF2-40B4-BE49-F238E27FC236}">
-                <a16:creationId xmlns:a16="http://schemas.microsoft.com/office/drawing/2014/main" id="{96A2AFE6-22E8-453C-8953-0DBB4028953C}"/>
-              </a:ext>
-            </a:extLst>
-          </p:cNvPr>
-          <p:cNvSpPr>
-            <a:spLocks xmlns:a="http://schemas.openxmlformats.org/drawingml/2006/main" noGrp="1"/>
-          </p:cNvSpPr>
-          <p:nvPr/>
-        </p:nvSpPr>
-        <p:spPr>
-          <a:xfrm xmlns:a="http://schemas.openxmlformats.org/drawingml/2006/main">
-            <a:off x="438150" y="381000"/>
-            <a:ext cx="11049000" cy="809625"/>
-          </a:xfrm>
-          <a:prstGeom xmlns:a="http://schemas.openxmlformats.org/drawingml/2006/main" prst="rect">
-            <a:avLst/>
-          </a:prstGeom>
-          <a:noFill xmlns:a="http://schemas.openxmlformats.org/drawingml/2006/main"/>
-          <a:ln xmlns:a="http://schemas.openxmlformats.org/drawingml/2006/main" w="0">
-            <a:noFill/>
-          </a:ln>
-        </p:spPr>
-        <p:txBody>
-          <a:bodyPr xmlns:a="http://schemas.openxmlformats.org/drawingml/2006/main">
-            <a:noAutofit/>
-          </a:bodyPr>
-          <a:lstStyle xmlns:a="http://schemas.openxmlformats.org/drawingml/2006/main"/>
-          <a:p xmlns:a="http://schemas.openxmlformats.org/drawingml/2006/main">
-            <a:pPr>
-              <a:defRPr sz="3300" b="1">
-                <a:solidFill>
-                  <a:srgbClr val="172D3D"/>
-                </a:solidFill>
-                <a:latin typeface="Arial"/>
-                <a:ea typeface="Arial"/>
-                <a:cs typeface="Arial"/>
-              </a:defRPr>
-            </a:pPr>
-            <a:r>
-              <a:rPr sz="3300" b="1">
-                <a:solidFill>
-                  <a:srgbClr val="172D3D"/>
-                </a:solidFill>
-                <a:latin typeface="Arial"/>
-                <a:ea typeface="Arial"/>
-                <a:cs typeface="Arial"/>
-              </a:rPr>
-              <a:t>Task-phase recognition</a:t>
-            </a:r>
-          </a:p>
-        </p:txBody>
-      </p:sp>
-      <p:sp>
-        <p:nvSpPr>
-          <p:cNvPr id="2" name="06">
-            <a:extLst xmlns:a="http://schemas.openxmlformats.org/drawingml/2006/main">
-              <a:ext uri="{FF2B5EF4-FFF2-40B4-BE49-F238E27FC236}">
-                <a16:creationId xmlns:a16="http://schemas.microsoft.com/office/drawing/2014/main" id="{AC64141E-F65C-4F79-B767-F9AB54E188D9}"/>
-              </a:ext>
-            </a:extLst>
-          </p:cNvPr>
-          <p:cNvSpPr>
-            <a:spLocks xmlns:a="http://schemas.openxmlformats.org/drawingml/2006/main" noGrp="1"/>
-          </p:cNvSpPr>
-          <p:nvPr/>
-        </p:nvSpPr>
-        <p:spPr>
-          <a:xfrm xmlns:a="http://schemas.openxmlformats.org/drawingml/2006/main">
-            <a:off x="466725" y="6362700"/>
-            <a:ext cx="476250" cy="228600"/>
-          </a:xfrm>
-          <a:prstGeom xmlns:a="http://schemas.openxmlformats.org/drawingml/2006/main" prst="rect">
-            <a:avLst/>
-          </a:prstGeom>
-          <a:noFill xmlns:a="http://schemas.openxmlformats.org/drawingml/2006/main"/>
-          <a:ln xmlns:a="http://schemas.openxmlformats.org/drawingml/2006/main" w="0">
-            <a:noFill/>
-          </a:ln>
-        </p:spPr>
-        <p:txBody>
-          <a:bodyPr xmlns:a="http://schemas.openxmlformats.org/drawingml/2006/main">
-            <a:noAutofit/>
-          </a:bodyPr>
-          <a:lstStyle xmlns:a="http://schemas.openxmlformats.org/drawingml/2006/main"/>
-          <a:p xmlns:a="http://schemas.openxmlformats.org/drawingml/2006/main">
-            <a:pPr>
-              <a:defRPr sz="1200" b="0">
-                <a:solidFill>
-                  <a:srgbClr val="536B79"/>
-                </a:solidFill>
-                <a:latin typeface="Arial"/>
-                <a:ea typeface="Arial"/>
-                <a:cs typeface="Arial"/>
-              </a:defRPr>
-            </a:pPr>
-            <a:r>
-              <a:rPr sz="1200" b="0">
-                <a:solidFill>
-                  <a:srgbClr val="536B79"/>
-                </a:solidFill>
-                <a:latin typeface="Arial"/>
-                <a:ea typeface="Arial"/>
-                <a:cs typeface="Arial"/>
-              </a:rPr>
-              <a:t>08</a:t>
-            </a:r>
-          </a:p>
-        </p:txBody>
-      </p:sp>
-      <p:sp>
-        <p:nvSpPr>
-          <p:cNvPr id="3" name="The model recognises approaching, working and retreating">
-            <a:extLst xmlns:a="http://schemas.openxmlformats.org/drawingml/2006/main">
-              <a:ext uri="{FF2B5EF4-FFF2-40B4-BE49-F238E27FC236}">
-                <a16:creationId xmlns:a16="http://schemas.microsoft.com/office/drawing/2014/main" id="{688F278D-A7FA-4FF6-BC11-CA003FC63529}"/>
-              </a:ext>
-            </a:extLst>
-          </p:cNvPr>
-          <p:cNvSpPr>
-            <a:spLocks xmlns:a="http://schemas.openxmlformats.org/drawingml/2006/main" noGrp="1"/>
-          </p:cNvSpPr>
-          <p:nvPr/>
-        </p:nvSpPr>
-        <p:spPr>
-          <a:xfrm xmlns:a="http://schemas.openxmlformats.org/drawingml/2006/main">
-            <a:off x="571500" y="1285875"/>
-            <a:ext cx="10858500" cy="590550"/>
-          </a:xfrm>
-          <a:prstGeom xmlns:a="http://schemas.openxmlformats.org/drawingml/2006/main" prst="rect">
-            <a:avLst/>
-          </a:prstGeom>
-          <a:noFill xmlns:a="http://schemas.openxmlformats.org/drawingml/2006/main"/>
-          <a:ln xmlns:a="http://schemas.openxmlformats.org/drawingml/2006/main" w="0">
-            <a:noFill/>
-          </a:ln>
-        </p:spPr>
-        <p:txBody>
-          <a:bodyPr xmlns:a="http://schemas.openxmlformats.org/drawingml/2006/main">
-            <a:noAutofit/>
-          </a:bodyPr>
-          <a:lstStyle xmlns:a="http://schemas.openxmlformats.org/drawingml/2006/main"/>
-          <a:p xmlns:a="http://schemas.openxmlformats.org/drawingml/2006/main">
-            <a:pPr>
-              <a:defRPr sz="2325" b="1">
-                <a:solidFill>
-                  <a:srgbClr val="006DAE"/>
-                </a:solidFill>
-                <a:latin typeface="Arial"/>
-                <a:ea typeface="Arial"/>
-                <a:cs typeface="Arial"/>
-              </a:defRPr>
-            </a:pPr>
-            <a:r>
-              <a:rPr sz="2325" b="1">
-                <a:solidFill>
-                  <a:srgbClr val="006DAE"/>
-                </a:solidFill>
-                <a:latin typeface="Arial"/>
-                <a:ea typeface="Arial"/>
-                <a:cs typeface="Arial"/>
-              </a:rPr>
-              <a:t>The model recognises approaching, working and retreating</a:t>
-            </a:r>
-          </a:p>
-        </p:txBody>
-      </p:sp>
-      <p:graphicFrame>
-        <p:nvGraphicFramePr>
-          <p:cNvPr id="11" name="Chart"/>
-          <p:cNvGraphicFramePr/>
-          <p:nvPr/>
-        </p:nvGraphicFramePr>
-        <p:xfrm>
-          <a:off xmlns:a="http://schemas.openxmlformats.org/drawingml/2006/main" x="619125" y="2038350"/>
-          <a:ext xmlns:a="http://schemas.openxmlformats.org/drawingml/2006/main" cx="6667500" cy="2952750"/>
-        </p:xfrm>
-        <a:graphic xmlns:a="http://schemas.openxmlformats.org/drawingml/2006/main">
-          <a:graphicData uri="http://schemas.openxmlformats.org/drawingml/2006/chart">
-            <c:chart xmlns:r="http://schemas.openxmlformats.org/officeDocument/2006/relationships" xmlns:c="http://schemas.openxmlformats.org/drawingml/2006/chart" r:id="Rf75f28609aee42cb"/>
-          </a:graphicData>
-        </a:graphic>
-      </p:graphicFrame>
-      <p:sp>
-        <p:nvSpPr>
-          <p:cNvPr id="5" name="32 development trials&#10;from 3 operators">
-            <a:extLst xmlns:a="http://schemas.openxmlformats.org/drawingml/2006/main">
-              <a:ext uri="{FF2B5EF4-FFF2-40B4-BE49-F238E27FC236}">
-                <a16:creationId xmlns:a16="http://schemas.microsoft.com/office/drawing/2014/main" id="{1D5C0430-4D0E-4A82-A702-E802FCCA0569}"/>
-              </a:ext>
-            </a:extLst>
-          </p:cNvPr>
-          <p:cNvSpPr>
-            <a:spLocks xmlns:a="http://schemas.openxmlformats.org/drawingml/2006/main" noGrp="1"/>
-          </p:cNvSpPr>
-          <p:nvPr/>
-        </p:nvSpPr>
-        <p:spPr>
-          <a:xfrm xmlns:a="http://schemas.openxmlformats.org/drawingml/2006/main">
-            <a:off x="7953375" y="2314575"/>
-            <a:ext cx="3524250" cy="914400"/>
-          </a:xfrm>
-          <a:prstGeom xmlns:a="http://schemas.openxmlformats.org/drawingml/2006/main" prst="rect">
-            <a:avLst/>
-          </a:prstGeom>
-          <a:noFill xmlns:a="http://schemas.openxmlformats.org/drawingml/2006/main"/>
-          <a:ln xmlns:a="http://schemas.openxmlformats.org/drawingml/2006/main" w="0">
-            <a:noFill/>
-          </a:ln>
-        </p:spPr>
-        <p:txBody>
-          <a:bodyPr xmlns:a="http://schemas.openxmlformats.org/drawingml/2006/main">
-            <a:noAutofit/>
-          </a:bodyPr>
-          <a:lstStyle xmlns:a="http://schemas.openxmlformats.org/drawingml/2006/main"/>
-          <a:p xmlns:a="http://schemas.openxmlformats.org/drawingml/2006/main">
-            <a:pPr>
-              <a:defRPr sz="2400" b="1">
-                <a:solidFill>
-                  <a:srgbClr val="172D3D"/>
-                </a:solidFill>
-                <a:latin typeface="Arial"/>
-                <a:ea typeface="Arial"/>
-                <a:cs typeface="Arial"/>
-              </a:defRPr>
-            </a:pPr>
-            <a:r>
-              <a:rPr sz="2400" b="1">
-                <a:solidFill>
-                  <a:srgbClr val="172D3D"/>
-                </a:solidFill>
-                <a:latin typeface="Arial"/>
-                <a:ea typeface="Arial"/>
-                <a:cs typeface="Arial"/>
-              </a:rPr>
-              <a:t>32 development trials</a:t>
-            </a:r>
-          </a:p>
-          <a:p xmlns:a="http://schemas.openxmlformats.org/drawingml/2006/main">
-            <a:pPr>
-              <a:defRPr sz="2400" b="1">
-                <a:solidFill>
-                  <a:srgbClr val="172D3D"/>
-                </a:solidFill>
-                <a:latin typeface="Arial"/>
-                <a:ea typeface="Arial"/>
-                <a:cs typeface="Arial"/>
-              </a:defRPr>
-            </a:pPr>
-            <a:r>
-              <a:rPr sz="2400" b="1">
-                <a:solidFill>
-                  <a:srgbClr val="172D3D"/>
-                </a:solidFill>
-                <a:latin typeface="Arial"/>
-                <a:ea typeface="Arial"/>
-                <a:cs typeface="Arial"/>
-              </a:rPr>
-              <a:t>from 3 operators</a:t>
-            </a:r>
-          </a:p>
-        </p:txBody>
-      </p:sp>
-      <p:sp>
-        <p:nvSpPr>
-          <p:cNvPr id="6" name="Each operator was held&#10;out in turn during&#10;validation.">
-            <a:extLst xmlns:a="http://schemas.openxmlformats.org/drawingml/2006/main">
-              <a:ext uri="{FF2B5EF4-FFF2-40B4-BE49-F238E27FC236}">
-                <a16:creationId xmlns:a16="http://schemas.microsoft.com/office/drawing/2014/main" id="{1CD572CB-78F6-4641-B899-95899A8F497E}"/>
-              </a:ext>
-            </a:extLst>
-          </p:cNvPr>
-          <p:cNvSpPr>
-            <a:spLocks xmlns:a="http://schemas.openxmlformats.org/drawingml/2006/main" noGrp="1"/>
-          </p:cNvSpPr>
-          <p:nvPr/>
-        </p:nvSpPr>
-        <p:spPr>
-          <a:xfrm xmlns:a="http://schemas.openxmlformats.org/drawingml/2006/main">
-            <a:off x="7953375" y="3505200"/>
-            <a:ext cx="3524250" cy="1200150"/>
-          </a:xfrm>
-          <a:prstGeom xmlns:a="http://schemas.openxmlformats.org/drawingml/2006/main" prst="rect">
-            <a:avLst/>
-          </a:prstGeom>
-          <a:noFill xmlns:a="http://schemas.openxmlformats.org/drawingml/2006/main"/>
-          <a:ln xmlns:a="http://schemas.openxmlformats.org/drawingml/2006/main" w="0">
-            <a:noFill/>
-          </a:ln>
-        </p:spPr>
-        <p:txBody>
-          <a:bodyPr xmlns:a="http://schemas.openxmlformats.org/drawingml/2006/main">
-            <a:noAutofit/>
-          </a:bodyPr>
-          <a:lstStyle xmlns:a="http://schemas.openxmlformats.org/drawingml/2006/main"/>
-          <a:p xmlns:a="http://schemas.openxmlformats.org/drawingml/2006/main">
-            <a:pPr>
-              <a:defRPr sz="2175" b="0">
-                <a:solidFill>
-                  <a:srgbClr val="172D3D"/>
-                </a:solidFill>
-                <a:latin typeface="Arial"/>
-                <a:ea typeface="Arial"/>
-                <a:cs typeface="Arial"/>
-              </a:defRPr>
-            </a:pPr>
-            <a:r>
-              <a:rPr sz="2175" b="0">
-                <a:solidFill>
-                  <a:srgbClr val="172D3D"/>
-                </a:solidFill>
-                <a:latin typeface="Arial"/>
-                <a:ea typeface="Arial"/>
-                <a:cs typeface="Arial"/>
-              </a:rPr>
-              <a:t>Each operator was held</a:t>
-            </a:r>
-          </a:p>
-          <a:p xmlns:a="http://schemas.openxmlformats.org/drawingml/2006/main">
-            <a:pPr>
-              <a:defRPr sz="2175" b="0">
-                <a:solidFill>
-                  <a:srgbClr val="172D3D"/>
-                </a:solidFill>
-                <a:latin typeface="Arial"/>
-                <a:ea typeface="Arial"/>
-                <a:cs typeface="Arial"/>
-              </a:defRPr>
-            </a:pPr>
-            <a:r>
-              <a:rPr sz="2175" b="0">
-                <a:solidFill>
-                  <a:srgbClr val="172D3D"/>
-                </a:solidFill>
-                <a:latin typeface="Arial"/>
-                <a:ea typeface="Arial"/>
-                <a:cs typeface="Arial"/>
-              </a:rPr>
-              <a:t>out in turn during</a:t>
-            </a:r>
-          </a:p>
-          <a:p xmlns:a="http://schemas.openxmlformats.org/drawingml/2006/main">
-            <a:pPr>
-              <a:defRPr sz="2175" b="0">
-                <a:solidFill>
-                  <a:srgbClr val="172D3D"/>
-                </a:solidFill>
-                <a:latin typeface="Arial"/>
-                <a:ea typeface="Arial"/>
-                <a:cs typeface="Arial"/>
-              </a:defRPr>
-            </a:pPr>
-            <a:r>
-              <a:rPr sz="2175" b="0">
-                <a:solidFill>
-                  <a:srgbClr val="172D3D"/>
-                </a:solidFill>
-                <a:latin typeface="Arial"/>
-                <a:ea typeface="Arial"/>
-                <a:cs typeface="Arial"/>
-              </a:rPr>
-              <a:t>validation.</a:t>
-            </a:r>
-          </a:p>
-        </p:txBody>
-      </p:sp>
-      <p:sp>
-        <p:nvSpPr>
-          <p:cNvPr id="7" name="Recognition used present and past observations.&#10;These are de">
-            <a:extLst xmlns:a="http://schemas.openxmlformats.org/drawingml/2006/main">
-              <a:ext uri="{FF2B5EF4-FFF2-40B4-BE49-F238E27FC236}">
-                <a16:creationId xmlns:a16="http://schemas.microsoft.com/office/drawing/2014/main" id="{61552150-185B-4660-9ABC-0ECD18018E3B}"/>
-              </a:ext>
-            </a:extLst>
-          </p:cNvPr>
-          <p:cNvSpPr>
-            <a:spLocks xmlns:a="http://schemas.openxmlformats.org/drawingml/2006/main" noGrp="1"/>
-          </p:cNvSpPr>
-          <p:nvPr/>
-        </p:nvSpPr>
-        <p:spPr>
-          <a:xfrm xmlns:a="http://schemas.openxmlformats.org/drawingml/2006/main">
-            <a:off x="571500" y="4877800"/>
-            <a:ext cx="10858500" cy="628650"/>
-          </a:xfrm>
-          <a:prstGeom xmlns:a="http://schemas.openxmlformats.org/drawingml/2006/main" prst="rect">
-            <a:avLst/>
-          </a:prstGeom>
-          <a:noFill xmlns:a="http://schemas.openxmlformats.org/drawingml/2006/main"/>
-          <a:ln xmlns:a="http://schemas.openxmlformats.org/drawingml/2006/main" w="0">
-            <a:noFill/>
-          </a:ln>
-        </p:spPr>
-        <p:txBody>
-          <a:bodyPr xmlns:a="http://schemas.openxmlformats.org/drawingml/2006/main">
-            <a:noAutofit/>
-          </a:bodyPr>
-          <a:lstStyle xmlns:a="http://schemas.openxmlformats.org/drawingml/2006/main"/>
-          <a:p xmlns:a="http://schemas.openxmlformats.org/drawingml/2006/main">
-            <a:pPr>
-              <a:defRPr sz="1875" b="0">
-                <a:solidFill>
-                  <a:srgbClr val="536B79"/>
-                </a:solidFill>
-                <a:latin typeface="Arial"/>
-                <a:ea typeface="Arial"/>
-                <a:cs typeface="Arial"/>
-              </a:defRPr>
-            </a:pPr>
-            <a:r>
-              <a:rPr sz="1875" b="0">
-                <a:solidFill>
-                  <a:srgbClr val="536B79"/>
-                </a:solidFill>
-                <a:latin typeface="Arial"/>
-                <a:ea typeface="Arial"/>
-                <a:cs typeface="Arial"/>
-              </a:rPr>
-              <a:t>Recognition used present and past observations.</a:t>
-            </a:r>
-          </a:p>
-          <a:p xmlns:a="http://schemas.openxmlformats.org/drawingml/2006/main">
-            <a:pPr>
-              <a:defRPr sz="1875" b="0">
-                <a:solidFill>
-                  <a:srgbClr val="536B79"/>
-                </a:solidFill>
-                <a:latin typeface="Arial"/>
-                <a:ea typeface="Arial"/>
-                <a:cs typeface="Arial"/>
-              </a:defRPr>
-            </a:pPr>
-            <a:r>
-              <a:rPr sz="1875" b="0">
-                <a:solidFill>
-                  <a:srgbClr val="536B79"/>
-                </a:solidFill>
-                <a:latin typeface="Arial"/>
-                <a:ea typeface="Arial"/>
-                <a:cs typeface="Arial"/>
-              </a:rPr>
-              <a:t>Predictive policy: 15 to 73 stop onsets per trial vs 6 to 9 for fixed/reactive, nearly all under 0.5 s. Chattering, not longer stops.</a:t>
-            </a:r>
-          </a:p>
-        </p:txBody>
-      </p:sp>
-    </p:spTree>
-    <p:extLst>
-      <p:ext uri="{BB962C8B-B14F-4D97-AF65-F5344CB8AC3E}">
-        <p14:creationId xmlns:p14="http://schemas.microsoft.com/office/powerpoint/2010/main" val="1512327385"/>
-      </p:ext>
-    </p:extLst>
-  </p:cSld>
-</p:sld>
-</file>
-
-<file path=ppt/slides/slide9.xml><?xml version="1.0" encoding="utf-8"?>
-<p:sld xmlns:p="http://schemas.openxmlformats.org/presentationml/2006/main">
-  <p:cSld>
-    <p:spTree>
-      <p:nvGrpSpPr>
-        <p:cNvPr id="1" name=""/>
-        <p:cNvGrpSpPr/>
-        <p:nvPr/>
-      </p:nvGrpSpPr>
-      <p:grpSpPr>
-        <a:xfrm xmlns:a="http://schemas.openxmlformats.org/drawingml/2006/main"/>
-      </p:grpSpPr>
-      <p:sp>
-        <p:nvSpPr>
-          <p:cNvPr id="7" name="Reported safety generally exceeded expectations">
-            <a:extLst xmlns:a="http://schemas.openxmlformats.org/drawingml/2006/main">
-              <a:ext uri="{FF2B5EF4-FFF2-40B4-BE49-F238E27FC236}">
-                <a16:creationId xmlns:a16="http://schemas.microsoft.com/office/drawing/2014/main" id="{5814CDDA-1AB1-4D61-8FAF-E713491B3C34}"/>
-              </a:ext>
-            </a:extLst>
-          </p:cNvPr>
-          <p:cNvSpPr>
-            <a:spLocks xmlns:a="http://schemas.openxmlformats.org/drawingml/2006/main" noGrp="1"/>
-          </p:cNvSpPr>
-          <p:nvPr/>
-        </p:nvSpPr>
-        <p:spPr>
-          <a:xfrm xmlns:a="http://schemas.openxmlformats.org/drawingml/2006/main">
-            <a:off x="438150" y="381000"/>
-            <a:ext cx="11049000" cy="809625"/>
-          </a:xfrm>
-          <a:prstGeom xmlns:a="http://schemas.openxmlformats.org/drawingml/2006/main" prst="rect">
-            <a:avLst/>
-          </a:prstGeom>
-          <a:noFill xmlns:a="http://schemas.openxmlformats.org/drawingml/2006/main"/>
-          <a:ln xmlns:a="http://schemas.openxmlformats.org/drawingml/2006/main" w="0">
-            <a:noFill/>
-          </a:ln>
-        </p:spPr>
-        <p:txBody>
-          <a:bodyPr xmlns:a="http://schemas.openxmlformats.org/drawingml/2006/main">
-            <a:noAutofit/>
-          </a:bodyPr>
-          <a:lstStyle xmlns:a="http://schemas.openxmlformats.org/drawingml/2006/main"/>
-          <a:p xmlns:a="http://schemas.openxmlformats.org/drawingml/2006/main">
-            <a:pPr>
-              <a:defRPr sz="3300" b="1">
-                <a:solidFill>
-                  <a:srgbClr val="172D3D"/>
-                </a:solidFill>
-                <a:latin typeface="Arial"/>
-                <a:ea typeface="Arial"/>
-                <a:cs typeface="Arial"/>
-              </a:defRPr>
-            </a:pPr>
-            <a:r>
-              <a:rPr sz="3300" b="1">
-                <a:solidFill>
-                  <a:srgbClr val="172D3D"/>
-                </a:solidFill>
-                <a:latin typeface="Arial"/>
-                <a:ea typeface="Arial"/>
-                <a:cs typeface="Arial"/>
-              </a:rPr>
-              <a:t>Reported safety generally exceeded expectations</a:t>
-            </a:r>
-          </a:p>
-        </p:txBody>
-      </p:sp>
-      <p:sp>
-        <p:nvSpPr>
-          <p:cNvPr id="2" name="07">
-            <a:extLst xmlns:a="http://schemas.openxmlformats.org/drawingml/2006/main">
-              <a:ext uri="{FF2B5EF4-FFF2-40B4-BE49-F238E27FC236}">
-                <a16:creationId xmlns:a16="http://schemas.microsoft.com/office/drawing/2014/main" id="{C4C99FBE-1199-451A-A032-F316AA2D1434}"/>
-              </a:ext>
-            </a:extLst>
-          </p:cNvPr>
-          <p:cNvSpPr>
-            <a:spLocks xmlns:a="http://schemas.openxmlformats.org/drawingml/2006/main" noGrp="1"/>
-          </p:cNvSpPr>
-          <p:nvPr/>
-        </p:nvSpPr>
-        <p:spPr>
-          <a:xfrm xmlns:a="http://schemas.openxmlformats.org/drawingml/2006/main">
-            <a:off x="466725" y="6362700"/>
-            <a:ext cx="476250" cy="228600"/>
-          </a:xfrm>
-          <a:prstGeom xmlns:a="http://schemas.openxmlformats.org/drawingml/2006/main" prst="rect">
-            <a:avLst/>
-          </a:prstGeom>
-          <a:noFill xmlns:a="http://schemas.openxmlformats.org/drawingml/2006/main"/>
-          <a:ln xmlns:a="http://schemas.openxmlformats.org/drawingml/2006/main" w="0">
-            <a:noFill/>
-          </a:ln>
-        </p:spPr>
-        <p:txBody>
-          <a:bodyPr xmlns:a="http://schemas.openxmlformats.org/drawingml/2006/main">
-            <a:noAutofit/>
-          </a:bodyPr>
-          <a:lstStyle xmlns:a="http://schemas.openxmlformats.org/drawingml/2006/main"/>
-          <a:p xmlns:a="http://schemas.openxmlformats.org/drawingml/2006/main">
-            <a:pPr>
-              <a:defRPr sz="1200" b="0">
-                <a:solidFill>
-                  <a:srgbClr val="536B79"/>
-                </a:solidFill>
-                <a:latin typeface="Arial"/>
-                <a:ea typeface="Arial"/>
-                <a:cs typeface="Arial"/>
-              </a:defRPr>
-            </a:pPr>
-            <a:r>
-              <a:rPr sz="1200" b="0">
-                <a:solidFill>
-                  <a:srgbClr val="536B79"/>
-                </a:solidFill>
-                <a:latin typeface="Arial"/>
-                <a:ea typeface="Arial"/>
-                <a:cs typeface="Arial"/>
-              </a:rPr>
-              <a:t>11</a:t>
-            </a:r>
-          </a:p>
-        </p:txBody>
-      </p:sp>
-      <p:sp>
-        <p:nvSpPr>
-          <p:cNvPr id="3" name="Changes between intake and end ratings">
-            <a:extLst xmlns:a="http://schemas.openxmlformats.org/drawingml/2006/main">
-              <a:ext uri="{FF2B5EF4-FFF2-40B4-BE49-F238E27FC236}">
-                <a16:creationId xmlns:a16="http://schemas.microsoft.com/office/drawing/2014/main" id="{2DFEBB9F-3B8E-435B-BEE5-DF4C4122DD86}"/>
-              </a:ext>
-            </a:extLst>
-          </p:cNvPr>
-          <p:cNvSpPr>
-            <a:spLocks xmlns:a="http://schemas.openxmlformats.org/drawingml/2006/main" noGrp="1"/>
-          </p:cNvSpPr>
-          <p:nvPr/>
-        </p:nvSpPr>
-        <p:spPr>
-          <a:xfrm xmlns:a="http://schemas.openxmlformats.org/drawingml/2006/main">
-            <a:off x="571500" y="1295400"/>
-            <a:ext cx="10763250" cy="476250"/>
-          </a:xfrm>
-          <a:prstGeom xmlns:a="http://schemas.openxmlformats.org/drawingml/2006/main" prst="rect">
-            <a:avLst/>
-          </a:prstGeom>
-          <a:noFill xmlns:a="http://schemas.openxmlformats.org/drawingml/2006/main"/>
-          <a:ln xmlns:a="http://schemas.openxmlformats.org/drawingml/2006/main" w="0">
-            <a:noFill/>
-          </a:ln>
-        </p:spPr>
-        <p:txBody>
-          <a:bodyPr xmlns:a="http://schemas.openxmlformats.org/drawingml/2006/main">
-            <a:noAutofit/>
-          </a:bodyPr>
-          <a:lstStyle xmlns:a="http://schemas.openxmlformats.org/drawingml/2006/main"/>
-          <a:p xmlns:a="http://schemas.openxmlformats.org/drawingml/2006/main">
-            <a:pPr>
-              <a:defRPr sz="2250" b="0">
-                <a:solidFill>
-                  <a:srgbClr val="172D3D"/>
-                </a:solidFill>
-                <a:latin typeface="Arial"/>
-                <a:ea typeface="Arial"/>
-                <a:cs typeface="Arial"/>
-              </a:defRPr>
-            </a:pPr>
-            <a:r>
-              <a:rPr sz="2250" b="0">
-                <a:solidFill>
-                  <a:srgbClr val="172D3D"/>
-                </a:solidFill>
-                <a:latin typeface="Arial"/>
-                <a:ea typeface="Arial"/>
-                <a:cs typeface="Arial"/>
-              </a:rPr>
-              <a:t>Changes between intake and end ratings</a:t>
-            </a:r>
-          </a:p>
-        </p:txBody>
-      </p:sp>
-      <p:graphicFrame>
-        <p:nvGraphicFramePr>
-          <p:cNvPr id="10" name="Chart"/>
-          <p:cNvGraphicFramePr/>
-          <p:nvPr/>
-        </p:nvGraphicFramePr>
-        <p:xfrm>
-          <a:off xmlns:a="http://schemas.openxmlformats.org/drawingml/2006/main" x="619125" y="1952625"/>
-          <a:ext xmlns:a="http://schemas.openxmlformats.org/drawingml/2006/main" cx="10715625" cy="2571750"/>
-        </p:xfrm>
-        <a:graphic xmlns:a="http://schemas.openxmlformats.org/drawingml/2006/main">
-          <a:graphicData uri="http://schemas.openxmlformats.org/drawingml/2006/chart">
-            <c:chart xmlns:r="http://schemas.openxmlformats.org/officeDocument/2006/relationships" xmlns:c="http://schemas.openxmlformats.org/drawingml/2006/chart" r:id="Rb2a10100880f4f5f"/>
-          </a:graphicData>
-        </a:graphic>
-      </p:graphicFrame>
-      <p:sp>
-        <p:nvSpPr>
-          <p:cNvPr id="5" name="8 of 11 safety ratings increased; trust responses were more ">
-            <a:extLst xmlns:a="http://schemas.openxmlformats.org/drawingml/2006/main">
-              <a:ext uri="{FF2B5EF4-FFF2-40B4-BE49-F238E27FC236}">
-                <a16:creationId xmlns:a16="http://schemas.microsoft.com/office/drawing/2014/main" id="{4C68F436-7C3E-4DDA-A61F-723CD0311D75}"/>
-              </a:ext>
-            </a:extLst>
-          </p:cNvPr>
-          <p:cNvSpPr>
-            <a:spLocks xmlns:a="http://schemas.openxmlformats.org/drawingml/2006/main" noGrp="1"/>
-          </p:cNvSpPr>
-          <p:nvPr/>
-        </p:nvSpPr>
-        <p:spPr>
-          <a:xfrm xmlns:a="http://schemas.openxmlformats.org/drawingml/2006/main">
-            <a:off x="571500" y="4695825"/>
-            <a:ext cx="10763250" cy="552450"/>
-          </a:xfrm>
-          <a:prstGeom xmlns:a="http://schemas.openxmlformats.org/drawingml/2006/main" prst="rect">
-            <a:avLst/>
-          </a:prstGeom>
-          <a:noFill xmlns:a="http://schemas.openxmlformats.org/drawingml/2006/main"/>
-          <a:ln xmlns:a="http://schemas.openxmlformats.org/drawingml/2006/main" w="0">
-            <a:noFill/>
-          </a:ln>
-        </p:spPr>
-        <p:txBody>
-          <a:bodyPr xmlns:a="http://schemas.openxmlformats.org/drawingml/2006/main">
-            <a:noAutofit/>
-          </a:bodyPr>
-          <a:lstStyle xmlns:a="http://schemas.openxmlformats.org/drawingml/2006/main"/>
-          <a:p xmlns:a="http://schemas.openxmlformats.org/drawingml/2006/main">
-            <a:pPr>
-              <a:defRPr sz="2250" b="1">
-                <a:solidFill>
-                  <a:srgbClr val="006DAE"/>
-                </a:solidFill>
-                <a:latin typeface="Arial"/>
-                <a:ea typeface="Arial"/>
-                <a:cs typeface="Arial"/>
-              </a:defRPr>
-            </a:pPr>
-            <a:r>
-              <a:rPr sz="2250" b="1">
-                <a:solidFill>
-                  <a:srgbClr val="006DAE"/>
-                </a:solidFill>
-                <a:latin typeface="Arial"/>
-                <a:ea typeface="Arial"/>
-                <a:cs typeface="Arial"/>
-              </a:rPr>
-              <a:t>8 of 11 safety ratings increased; trust responses were more mixed.</a:t>
-            </a:r>
-          </a:p>
-        </p:txBody>
-      </p:sp>
-      <p:sp>
-        <p:nvSpPr>
-          <p:cNvPr id="6" name="Matched response sets, not a confirmed count of distinct peo">
-            <a:extLst xmlns:a="http://schemas.openxmlformats.org/drawingml/2006/main">
-              <a:ext uri="{FF2B5EF4-FFF2-40B4-BE49-F238E27FC236}">
-                <a16:creationId xmlns:a16="http://schemas.microsoft.com/office/drawing/2014/main" id="{DD433E31-694F-46D7-9C78-BABB08EABEFF}"/>
-              </a:ext>
-            </a:extLst>
-          </p:cNvPr>
-          <p:cNvSpPr>
-            <a:spLocks xmlns:a="http://schemas.openxmlformats.org/drawingml/2006/main" noGrp="1"/>
-          </p:cNvSpPr>
-          <p:nvPr/>
-        </p:nvSpPr>
-        <p:spPr>
-          <a:xfrm xmlns:a="http://schemas.openxmlformats.org/drawingml/2006/main">
-            <a:off x="571500" y="5286375"/>
-            <a:ext cx="10763250" cy="628650"/>
-          </a:xfrm>
-          <a:prstGeom xmlns:a="http://schemas.openxmlformats.org/drawingml/2006/main" prst="rect">
-            <a:avLst/>
-          </a:prstGeom>
-          <a:noFill xmlns:a="http://schemas.openxmlformats.org/drawingml/2006/main"/>
-          <a:ln xmlns:a="http://schemas.openxmlformats.org/drawingml/2006/main" w="0">
-            <a:noFill/>
-          </a:ln>
-        </p:spPr>
-        <p:txBody>
-          <a:bodyPr xmlns:a="http://schemas.openxmlformats.org/drawingml/2006/main">
-            <a:noAutofit/>
-          </a:bodyPr>
-          <a:lstStyle xmlns:a="http://schemas.openxmlformats.org/drawingml/2006/main"/>
-          <a:p xmlns:a="http://schemas.openxmlformats.org/drawingml/2006/main">
-            <a:pPr>
-              <a:defRPr sz="1800" b="0">
-                <a:solidFill>
-                  <a:srgbClr val="536B79"/>
-                </a:solidFill>
-                <a:latin typeface="Arial"/>
-                <a:ea typeface="Arial"/>
-                <a:cs typeface="Arial"/>
-              </a:defRPr>
-            </a:pPr>
-            <a:r>
-              <a:rPr sz="1800" b="0">
-                <a:solidFill>
-                  <a:srgbClr val="536B79"/>
-                </a:solidFill>
-                <a:latin typeface="Arial"/>
-                <a:ea typeface="Arial"/>
-                <a:cs typeface="Arial"/>
-              </a:rPr>
-              <a:t>Matched response sets, not a confirmed count of distinct people.</a:t>
-            </a:r>
-          </a:p>
-          <a:p xmlns:a="http://schemas.openxmlformats.org/drawingml/2006/main">
-            <a:pPr>
-              <a:defRPr sz="1800" b="0">
-                <a:solidFill>
-                  <a:srgbClr val="536B79"/>
-                </a:solidFill>
-                <a:latin typeface="Arial"/>
-                <a:ea typeface="Arial"/>
-                <a:cs typeface="Arial"/>
-              </a:defRPr>
-            </a:pPr>
-            <a:r>
-              <a:rPr sz="1800" b="0">
-                <a:solidFill>
-                  <a:srgbClr val="536B79"/>
-                </a:solidFill>
-                <a:latin typeface="Arial"/>
-                <a:ea typeface="Arial"/>
-                <a:cs typeface="Arial"/>
-              </a:rPr>
-              <a:t>Expected and experienced ratings do not identify a controller effect.</a:t>
             </a:r>
           </a:p>
         </p:txBody>

</xml_diff>